<commit_message>
Highlight positive signals in October CEO status deck
Co-Authored-By: Claude Opus 5.5 <noreply@anthropic.com>
Claude-Session: https://claude.ai/code/session_01QGMjcfWM6zwQECSVCibDW3
</commit_message>
<xml_diff>
--- a/status_ceo/Stormberg_Status_CEO_Oct2026_EN.pptx
+++ b/status_ceo/Stormberg_Status_CEO_Oct2026_EN.pptx
@@ -11,9 +11,10 @@
     <p:sldId id="259" r:id="rId5"/>
     <p:sldId id="260" r:id="rId6"/>
     <p:sldId id="261" r:id="rId7"/>
+    <p:sldId id="262" r:id="rId8"/>
   </p:sldIdLst>
   <p:notesMasterIdLst>
-    <p:notesMasterId r:id="rId8"/>
+    <p:notesMasterId r:id="rId9"/>
   </p:notesMasterIdLst>
   <p:sldSz cx="9144000" cy="5143500"/>
   <p:notesSz cx="5143500" cy="9144000"/>
@@ -112,22 +113,23 @@
   <p:extLst>
     <p:ext uri="{521415D9-36F7-43E2-AB2F-B90AF26B5E84}">
       <p14:sectionLst xmlns:p14="http://schemas.microsoft.com/office/powerpoint/2010/main">
-        <p14:section name="Summary" id="{aaa6873c-beeb-7725-bda5-16fded7950df}">
+        <p14:section name="Summary" id="{49eee990-77be-4823-f4c8-397520ab78ab}">
           <p14:sldIdLst>
             <p14:sldId id="256"/>
             <p14:sldId id="257"/>
+            <p14:sldId id="258"/>
           </p14:sldIdLst>
         </p14:section>
-        <p14:section name="Progress" id="{b7fdf1aa-7b92-e32d-fb9d-2a7f0797a362}">
+        <p14:section name="Progress" id="{0cca0d4a-b40a-4843-8a8e-ebf1d2940598}">
           <p14:sldIdLst>
-            <p14:sldId id="258"/>
             <p14:sldId id="259"/>
             <p14:sldId id="260"/>
+            <p14:sldId id="261"/>
           </p14:sldIdLst>
         </p14:section>
-        <p14:section name="Next steps" id="{c7e28eb3-e09f-fb17-f89a-ae1806f2de55}">
+        <p14:section name="Next steps" id="{544b7951-04fe-846f-3628-73b8303ed710}">
           <p14:sldIdLst>
-            <p14:sldId id="261"/>
+            <p14:sldId id="262"/>
           </p14:sldIdLst>
         </p14:section>
       </p14:sectionLst>
@@ -139,7 +141,481 @@
 </p:presentation>
 </file>
 
-<file path=ppt/charts/chart3.xml><?xml version="1.0" encoding="utf-8"?>
+<file path=ppt/charts/chart4.xml><?xml version="1.0" encoding="utf-8"?>
+<c:chartSpace xmlns:c="http://schemas.openxmlformats.org/drawingml/2006/chart" xmlns:a="http://schemas.openxmlformats.org/drawingml/2006/main" xmlns:r="http://schemas.openxmlformats.org/officeDocument/2006/relationships">
+  <c:date1904 val="0"/>
+  <c:roundedCorners val="1"/>
+  <c:chart>
+    <c:title>
+      <c:tx>
+        <c:rich>
+          <a:bodyPr/>
+          <a:lstStyle/>
+          <a:p>
+            <a:pPr>
+              <a:defRPr sz="1200" b="0" i="0" u="none" strike="noStrike">
+                <a:solidFill>
+                  <a:srgbClr val="2A1F1C"/>
+                </a:solidFill>
+                <a:latin typeface="+mn-lt"/>
+              </a:defRPr>
+            </a:pPr>
+            <a:r>
+              <a:rPr sz="1200" b="0" i="0" u="none" strike="noStrike">
+                <a:solidFill>
+                  <a:srgbClr val="2A1F1C"/>
+                </a:solidFill>
+                <a:latin typeface="+mn-lt"/>
+              </a:rPr>
+              <a:t>Brooklyn store daily sales (USD)</a:t>
+            </a:r>
+          </a:p>
+        </c:rich>
+      </c:tx>
+      <c:layout/>
+      <c:overlay val="0"/>
+    </c:title>
+    <c:autoTitleDeleted val="0"/>
+    <c:plotArea>
+      <c:layout/>
+      <c:barChart>
+        <c:barDir val="col"/>
+        <c:grouping val="stacked"/>
+        <c:varyColors val="0"/>
+        <c:ser>
+          <c:idx val="0"/>
+          <c:order val="0"/>
+          <c:tx>
+            <c:strRef>
+              <c:f>Sheet1!$B$1</c:f>
+              <c:strCache>
+                <c:ptCount val="1"/>
+                <c:pt idx="0">
+                  <c:v>base</c:v>
+                </c:pt>
+              </c:strCache>
+            </c:strRef>
+          </c:tx>
+          <c:spPr>
+            <a:solidFill>
+              <a:srgbClr val="C9B8A6"/>
+            </a:solidFill>
+            <a:effectLst/>
+          </c:spPr>
+          <c:invertIfNegative val="0"/>
+          <c:dLbls>
+            <c:numFmt formatCode="#,##0" sourceLinked="0"/>
+            <c:txPr>
+              <a:bodyPr/>
+              <a:lstStyle/>
+              <a:p>
+                <a:pPr>
+                  <a:defRPr b="0" i="0" strike="noStrike" sz="1200" u="none">
+                    <a:solidFill>
+                      <a:srgbClr val="000000"/>
+                    </a:solidFill>
+                    <a:latin typeface="Arial"/>
+                  </a:defRPr>
+                </a:pPr>
+              </a:p>
+            </c:txPr>
+            <c:showLegendKey val="0"/>
+            <c:showVal val="0"/>
+            <c:showCatName val="0"/>
+            <c:showSerName val="0"/>
+            <c:showPercent val="0"/>
+            <c:showBubbleSize val="0"/>
+            <c:showLeaderLines val="0"/>
+          </c:dLbls>
+          <c:cat>
+            <c:multiLvlStrRef>
+              <c:f>Sheet1!$A$2:$A$14</c:f>
+              <c:multiLvlStrCache>
+                <c:ptCount val="13"/>
+                <c:lvl>
+                  <c:pt idx="0">
+                    <c:v>1</c:v>
+                  </c:pt>
+                  <c:pt idx="1">
+                    <c:v>2</c:v>
+                  </c:pt>
+                  <c:pt idx="2">
+                    <c:v>3</c:v>
+                  </c:pt>
+                  <c:pt idx="3">
+                    <c:v>4</c:v>
+                  </c:pt>
+                  <c:pt idx="4">
+                    <c:v>5</c:v>
+                  </c:pt>
+                  <c:pt idx="5">
+                    <c:v>6</c:v>
+                  </c:pt>
+                  <c:pt idx="6">
+                    <c:v>7</c:v>
+                  </c:pt>
+                  <c:pt idx="7">
+                    <c:v>8</c:v>
+                  </c:pt>
+                  <c:pt idx="8">
+                    <c:v>9</c:v>
+                  </c:pt>
+                  <c:pt idx="9">
+                    <c:v>10</c:v>
+                  </c:pt>
+                  <c:pt idx="10">
+                    <c:v>11</c:v>
+                  </c:pt>
+                  <c:pt idx="11">
+                    <c:v>12</c:v>
+                  </c:pt>
+                  <c:pt idx="12">
+                    <c:v>13</c:v>
+                  </c:pt>
+                </c:lvl>
+              </c:multiLvlStrCache>
+            </c:multiLvlStrRef>
+          </c:cat>
+          <c:val>
+            <c:numRef>
+              <c:f>Sheet1!$B$2:$B$14</c:f>
+              <c:numCache>
+                <c:formatCode>General</c:formatCode>
+                <c:ptCount val="13"/>
+                <c:pt idx="0">
+                  <c:v>1375</c:v>
+                </c:pt>
+                <c:pt idx="1">
+                  <c:v>525</c:v>
+                </c:pt>
+                <c:pt idx="2">
+                  <c:v>854</c:v>
+                </c:pt>
+                <c:pt idx="3">
+                  <c:v>931</c:v>
+                </c:pt>
+                <c:pt idx="4">
+                  <c:v>698</c:v>
+                </c:pt>
+                <c:pt idx="5">
+                  <c:v>1485</c:v>
+                </c:pt>
+                <c:pt idx="6">
+                  <c:v>739</c:v>
+                </c:pt>
+                <c:pt idx="7">
+                  <c:v>777</c:v>
+                </c:pt>
+                <c:pt idx="8">
+                  <c:v>885</c:v>
+                </c:pt>
+                <c:pt idx="9">
+                  <c:v>0</c:v>
+                </c:pt>
+                <c:pt idx="10">
+                  <c:v>0</c:v>
+                </c:pt>
+                <c:pt idx="11">
+                  <c:v>0</c:v>
+                </c:pt>
+                <c:pt idx="12">
+                  <c:v>866</c:v>
+                </c:pt>
+              </c:numCache>
+            </c:numRef>
+          </c:val>
+        </c:ser>
+        <c:ser>
+          <c:idx val="1"/>
+          <c:order val="1"/>
+          <c:tx>
+            <c:strRef>
+              <c:f>Sheet1!$C$1</c:f>
+              <c:strCache>
+                <c:ptCount val="1"/>
+                <c:pt idx="0">
+                  <c:v>hl</c:v>
+                </c:pt>
+              </c:strCache>
+            </c:strRef>
+          </c:tx>
+          <c:spPr>
+            <a:solidFill>
+              <a:srgbClr val="2E6B4F"/>
+            </a:solidFill>
+            <a:effectLst/>
+          </c:spPr>
+          <c:invertIfNegative val="0"/>
+          <c:dLbls>
+            <c:numFmt formatCode="#,##0" sourceLinked="0"/>
+            <c:txPr>
+              <a:bodyPr/>
+              <a:lstStyle/>
+              <a:p>
+                <a:pPr>
+                  <a:defRPr b="0" i="0" strike="noStrike" sz="1200" u="none">
+                    <a:solidFill>
+                      <a:srgbClr val="000000"/>
+                    </a:solidFill>
+                    <a:latin typeface="Arial"/>
+                  </a:defRPr>
+                </a:pPr>
+              </a:p>
+            </c:txPr>
+            <c:showLegendKey val="0"/>
+            <c:showVal val="0"/>
+            <c:showCatName val="0"/>
+            <c:showSerName val="0"/>
+            <c:showPercent val="0"/>
+            <c:showBubbleSize val="0"/>
+            <c:showLeaderLines val="0"/>
+          </c:dLbls>
+          <c:cat>
+            <c:multiLvlStrRef>
+              <c:f>Sheet1!$A$2:$A$14</c:f>
+              <c:multiLvlStrCache>
+                <c:ptCount val="13"/>
+                <c:lvl>
+                  <c:pt idx="0">
+                    <c:v>1</c:v>
+                  </c:pt>
+                  <c:pt idx="1">
+                    <c:v>2</c:v>
+                  </c:pt>
+                  <c:pt idx="2">
+                    <c:v>3</c:v>
+                  </c:pt>
+                  <c:pt idx="3">
+                    <c:v>4</c:v>
+                  </c:pt>
+                  <c:pt idx="4">
+                    <c:v>5</c:v>
+                  </c:pt>
+                  <c:pt idx="5">
+                    <c:v>6</c:v>
+                  </c:pt>
+                  <c:pt idx="6">
+                    <c:v>7</c:v>
+                  </c:pt>
+                  <c:pt idx="7">
+                    <c:v>8</c:v>
+                  </c:pt>
+                  <c:pt idx="8">
+                    <c:v>9</c:v>
+                  </c:pt>
+                  <c:pt idx="9">
+                    <c:v>10</c:v>
+                  </c:pt>
+                  <c:pt idx="10">
+                    <c:v>11</c:v>
+                  </c:pt>
+                  <c:pt idx="11">
+                    <c:v>12</c:v>
+                  </c:pt>
+                  <c:pt idx="12">
+                    <c:v>13</c:v>
+                  </c:pt>
+                </c:lvl>
+              </c:multiLvlStrCache>
+            </c:multiLvlStrRef>
+          </c:cat>
+          <c:val>
+            <c:numRef>
+              <c:f>Sheet1!$C$2:$C$14</c:f>
+              <c:numCache>
+                <c:formatCode>General</c:formatCode>
+                <c:ptCount val="13"/>
+                <c:pt idx="0">
+                  <c:v>0</c:v>
+                </c:pt>
+                <c:pt idx="1">
+                  <c:v>0</c:v>
+                </c:pt>
+                <c:pt idx="2">
+                  <c:v>0</c:v>
+                </c:pt>
+                <c:pt idx="3">
+                  <c:v>0</c:v>
+                </c:pt>
+                <c:pt idx="4">
+                  <c:v>0</c:v>
+                </c:pt>
+                <c:pt idx="5">
+                  <c:v>0</c:v>
+                </c:pt>
+                <c:pt idx="6">
+                  <c:v>0</c:v>
+                </c:pt>
+                <c:pt idx="7">
+                  <c:v>0</c:v>
+                </c:pt>
+                <c:pt idx="8">
+                  <c:v>0</c:v>
+                </c:pt>
+                <c:pt idx="9">
+                  <c:v>1569</c:v>
+                </c:pt>
+                <c:pt idx="10">
+                  <c:v>1637</c:v>
+                </c:pt>
+                <c:pt idx="11">
+                  <c:v>2030</c:v>
+                </c:pt>
+                <c:pt idx="12">
+                  <c:v>0</c:v>
+                </c:pt>
+              </c:numCache>
+            </c:numRef>
+          </c:val>
+        </c:ser>
+        <c:dLbls>
+          <c:numFmt formatCode="#,##0" sourceLinked="0"/>
+          <c:txPr>
+            <a:bodyPr/>
+            <a:lstStyle/>
+            <a:p>
+              <a:pPr>
+                <a:defRPr b="0" i="0" strike="noStrike" sz="1200" u="none">
+                  <a:solidFill>
+                    <a:srgbClr val="000000"/>
+                  </a:solidFill>
+                  <a:latin typeface="Arial"/>
+                </a:defRPr>
+              </a:pPr>
+            </a:p>
+          </c:txPr>
+          <c:showLegendKey val="0"/>
+          <c:showVal val="0"/>
+          <c:showCatName val="0"/>
+          <c:showSerName val="0"/>
+          <c:showPercent val="0"/>
+          <c:showBubbleSize val="0"/>
+          <c:showLeaderLines val="0"/>
+        </c:dLbls>
+        <c:gapWidth val="35"/>
+        <c:overlap val="100"/>
+        <c:axId val="2094734554"/>
+        <c:axId val="2094734552"/>
+        <c:axId val="2094734556"/>
+      </c:barChart>
+      <c:catAx>
+        <c:axId val="2094734554"/>
+        <c:scaling>
+          <c:orientation val="minMax"/>
+        </c:scaling>
+        <c:delete val="0"/>
+        <c:axPos val="b"/>
+        <c:numFmt formatCode="General" sourceLinked="1"/>
+        <c:majorTickMark val="out"/>
+        <c:minorTickMark val="none"/>
+        <c:tickLblPos val="low"/>
+        <c:spPr>
+          <a:ln w="12700" cap="flat">
+            <a:solidFill>
+              <a:srgbClr val="888888"/>
+            </a:solidFill>
+            <a:prstDash val="solid"/>
+            <a:round/>
+          </a:ln>
+        </c:spPr>
+        <c:txPr>
+          <a:bodyPr/>
+          <a:lstStyle/>
+          <a:p>
+            <a:pPr>
+              <a:defRPr sz="1000" b="0" i="0" u="none" strike="noStrike">
+                <a:solidFill>
+                  <a:srgbClr val="2A1F1C"/>
+                </a:solidFill>
+                <a:latin typeface="+mn-lt"/>
+              </a:defRPr>
+            </a:pPr>
+            <a:endParaRPr lang="en-US"/>
+          </a:p>
+        </c:txPr>
+        <c:crossAx val="2094734552"/>
+        <c:crosses val="autoZero"/>
+        <c:auto val="1"/>
+        <c:lblAlgn val="ctr"/>
+        <c:noMultiLvlLbl val="1"/>
+      </c:catAx>
+      <c:valAx>
+        <c:axId val="2094734552"/>
+        <c:scaling>
+          <c:orientation val="minMax"/>
+          <c:max val="2500"/>
+        </c:scaling>
+        <c:delete val="0"/>
+        <c:axPos val="l"/>
+        <c:majorGridlines>
+          <c:spPr>
+            <a:ln w="9525" cap="flat">
+              <a:solidFill>
+                <a:srgbClr val="F3EEE9"/>
+              </a:solidFill>
+              <a:prstDash val="solid"/>
+              <a:round/>
+            </a:ln>
+          </c:spPr>
+        </c:majorGridlines>
+        <c:numFmt formatCode="$#,##0" sourceLinked="0"/>
+        <c:majorTickMark val="out"/>
+        <c:minorTickMark val="none"/>
+        <c:tickLblPos val="nextTo"/>
+        <c:spPr>
+          <a:ln w="12700" cap="flat">
+            <a:solidFill>
+              <a:srgbClr val="888888"/>
+            </a:solidFill>
+            <a:prstDash val="solid"/>
+            <a:round/>
+          </a:ln>
+        </c:spPr>
+        <c:txPr>
+          <a:bodyPr/>
+          <a:lstStyle/>
+          <a:p>
+            <a:pPr>
+              <a:defRPr sz="900" b="0" i="0" u="none" strike="noStrike">
+                <a:solidFill>
+                  <a:srgbClr val="8C7B70"/>
+                </a:solidFill>
+                <a:latin typeface="+mn-lt"/>
+              </a:defRPr>
+            </a:pPr>
+            <a:endParaRPr lang="en-US"/>
+          </a:p>
+        </c:txPr>
+        <c:crossAx val="2094734554"/>
+        <c:crosses val="autoZero"/>
+        <c:crossBetween val="between"/>
+        <c:majorUnit val="500"/>
+      </c:valAx>
+      <c:spPr>
+        <a:noFill/>
+        <a:ln>
+          <a:noFill/>
+        </a:ln>
+        <a:effectLst/>
+      </c:spPr>
+    </c:plotArea>
+    <c:plotVisOnly val="1"/>
+    <c:dispBlanksAs val="span"/>
+  </c:chart>
+  <c:spPr>
+    <a:noFill/>
+    <a:ln>
+      <a:noFill/>
+    </a:ln>
+    <a:effectLst/>
+  </c:spPr>
+  <c:externalData r:id="rId1">
+    <c:autoUpdate val="0"/>
+  </c:externalData>
+</c:chartSpace>
+</file>
+
+<file path=ppt/charts/chart5.xml><?xml version="1.0" encoding="utf-8"?>
 <c:chartSpace xmlns:c="http://schemas.openxmlformats.org/drawingml/2006/chart" xmlns:a="http://schemas.openxmlformats.org/drawingml/2006/main" xmlns:r="http://schemas.openxmlformats.org/officeDocument/2006/relationships">
   <c:date1904 val="0"/>
   <c:roundedCorners val="1"/>
@@ -500,7 +976,7 @@
 </c:chartSpace>
 </file>
 
-<file path=ppt/charts/chart4.xml><?xml version="1.0" encoding="utf-8"?>
+<file path=ppt/charts/chart6.xml><?xml version="1.0" encoding="utf-8"?>
 <c:chartSpace xmlns:c="http://schemas.openxmlformats.org/drawingml/2006/chart" xmlns:a="http://schemas.openxmlformats.org/drawingml/2006/main" xmlns:r="http://schemas.openxmlformats.org/officeDocument/2006/relationships">
   <c:date1904 val="0"/>
   <c:roundedCorners val="1"/>
@@ -1635,6 +2111,94 @@
             <a:fld id="{F7021451-1387-4CA6-816F-3879F97B5CBC}" type="slidenum">
               <a:rPr lang="en-US"/>
               <a:t>6</a:t>
+            </a:fld>
+            <a:endParaRPr lang="en-US"/>
+          </a:p>
+        </p:txBody>
+      </p:sp>
+    </p:spTree>
+    <p:extLst>
+      <p:ext uri="{BB962C8B-B14F-4D97-AF65-F5344CB8AC3E}">
+        <p14:creationId xmlns:p14="http://schemas.microsoft.com/office/powerpoint/2010/main" val="1024086991"/>
+      </p:ext>
+    </p:extLst>
+  </p:cSld>
+  <p:clrMapOvr>
+    <a:masterClrMapping/>
+  </p:clrMapOvr>
+</p:notes>
+</file>
+
+<file path=ppt/notesSlides/notesSlide7.xml><?xml version="1.0" encoding="utf-8"?>
+<p:notes xmlns:a="http://schemas.openxmlformats.org/drawingml/2006/main" xmlns:r="http://schemas.openxmlformats.org/officeDocument/2006/relationships" xmlns:p="http://schemas.openxmlformats.org/presentationml/2006/main">
+  <p:cSld>
+    <p:spTree>
+      <p:nvGrpSpPr>
+        <p:cNvPr id="1" name=""/>
+        <p:cNvGrpSpPr/>
+        <p:nvPr/>
+      </p:nvGrpSpPr>
+      <p:grpSpPr>
+        <a:xfrm>
+          <a:off x="0" y="0"/>
+          <a:ext cx="0" cy="0"/>
+          <a:chOff x="0" y="0"/>
+          <a:chExt cx="0" cy="0"/>
+        </a:xfrm>
+      </p:grpSpPr>
+      <p:sp>
+        <p:nvSpPr>
+          <p:cNvPr id="2" name="Slide Image Placeholder 1"/>
+          <p:cNvSpPr>
+            <a:spLocks noGrp="1" noRot="1" noChangeAspect="1"/>
+          </p:cNvSpPr>
+          <p:nvPr>
+            <p:ph type="sldImg"/>
+          </p:nvPr>
+        </p:nvSpPr>
+        <p:spPr/>
+      </p:sp>
+      <p:sp>
+        <p:nvSpPr>
+          <p:cNvPr id="3" name="Notes Placeholder 2"/>
+          <p:cNvSpPr>
+            <a:spLocks noGrp="1"/>
+          </p:cNvSpPr>
+          <p:nvPr>
+            <p:ph type="body" idx="1"/>
+          </p:nvPr>
+        </p:nvSpPr>
+        <p:spPr/>
+        <p:txBody>
+          <a:bodyPr/>
+          <a:lstStyle/>
+          <a:p>
+            <a:r>
+              <a:rPr lang="en-US" dirty="0"/>
+              <a:t/>
+            </a:r>
+            <a:endParaRPr lang="en-US" dirty="0"/>
+          </a:p>
+        </p:txBody>
+      </p:sp>
+      <p:sp>
+        <p:nvSpPr>
+          <p:cNvPr id="4" name="Slide Number Placeholder 3"/>
+          <p:cNvSpPr>
+            <a:spLocks noGrp="1"/>
+          </p:cNvSpPr>
+          <p:nvPr>
+            <p:ph type="sldNum" sz="quarter" idx="10"/>
+          </p:nvPr>
+        </p:nvSpPr>
+        <p:spPr/>
+        <p:txBody>
+          <a:bodyPr/>
+          <a:lstStyle/>
+          <a:p>
+            <a:fld id="{F7021451-1387-4CA6-816F-3879F97B5CBC}" type="slidenum">
+              <a:rPr lang="en-US"/>
+              <a:t>7</a:t>
             </a:fld>
             <a:endParaRPr lang="en-US"/>
           </a:p>
@@ -2639,7 +3203,7 @@
                 <a:ea typeface="Cambria" pitchFamily="34" charset="-122"/>
                 <a:cs typeface="Cambria" pitchFamily="34" charset="-120"/>
               </a:rPr>
-              <a:t>The actions are live and purchases are picking up</a:t>
+              <a:t>Sales are rebounding: three straight days above $1,500</a:t>
             </a:r>
             <a:endParaRPr lang="en-US" sz="2600" dirty="0"/>
           </a:p>
@@ -2815,7 +3379,7 @@
                 <a:ea typeface="Cambria" pitchFamily="34" charset="-122"/>
                 <a:cs typeface="Cambria" pitchFamily="34" charset="-120"/>
               </a:rPr>
-              <a:t>2.3x</a:t>
+              <a:t>+90%</a:t>
             </a:r>
             <a:endParaRPr lang="en-US" sz="2800" dirty="0"/>
           </a:p>
@@ -2851,7 +3415,7 @@
                   <a:schemeClr val="tx1"/>
                 </a:solidFill>
               </a:rPr>
-              <a:t>Daily Meta investment</a:t>
+              <a:t>Brooklyn daily sales</a:t>
             </a:r>
             <a:endParaRPr lang="en-US" sz="1100" dirty="0"/>
           </a:p>
@@ -2865,7 +3429,7 @@
                   <a:schemeClr val="tx1"/>
                 </a:solidFill>
               </a:rPr>
-              <a:t>$72 → $166 per day</a:t>
+              <a:t>Oct 10–12 vs. Oct 1–9</a:t>
             </a:r>
             <a:endParaRPr lang="en-US" sz="1100" dirty="0"/>
           </a:p>
@@ -3057,7 +3621,7 @@
                   <a:schemeClr val="accent1"/>
                 </a:solidFill>
               </a:rPr>
-              <a:t>Execution: </a:t>
+              <a:t>Traction: </a:t>
             </a:r>
             <a:pPr indent="0" marL="0">
               <a:buNone/>
@@ -3068,7 +3632,7 @@
                   <a:schemeClr val="tx1"/>
                 </a:solidFill>
               </a:rPr>
-              <a:t>every Meta commitment is live across all 3 brands, and we restructured retargeting on October 10.</a:t>
+              <a:t>Brooklyn sold $1,745 a day from October 10 to 12, nearly double the first nine days of the month, right as Meta came on.</a:t>
             </a:r>
             <a:endParaRPr lang="en-US" sz="1400" dirty="0"/>
           </a:p>
@@ -3086,7 +3650,7 @@
                   <a:schemeClr val="accent1"/>
                 </a:solidFill>
               </a:rPr>
-              <a:t>Results: </a:t>
+              <a:t>Execution: </a:t>
             </a:r>
             <a:pPr indent="0" marL="0">
               <a:buNone/>
@@ -3097,7 +3661,36 @@
                   <a:schemeClr val="tx1"/>
                 </a:solidFill>
               </a:rPr>
-              <a:t>purchases are up sharply, but Meta return (0.76x) is still below breakeven. Budget has already moved toward what converts best.</a:t>
+              <a:t>every Meta commitment is live across all 3 brands.</a:t>
+            </a:r>
+            <a:endParaRPr lang="en-US" sz="1400" dirty="0"/>
+          </a:p>
+          <a:p>
+            <a:pPr marL="342900" indent="-342900">
+              <a:spcAft>
+                <a:spcPts val="1000"/>
+              </a:spcAft>
+              <a:buSzPct val="100000"/>
+              <a:buChar char="•"/>
+            </a:pPr>
+            <a:r>
+              <a:rPr lang="en-US" sz="1400" b="1" dirty="0">
+                <a:solidFill>
+                  <a:schemeClr val="accent1"/>
+                </a:solidFill>
+              </a:rPr>
+              <a:t>Watch: </a:t>
+            </a:r>
+            <a:pPr indent="0" marL="0">
+              <a:buNone/>
+            </a:pPr>
+            <a:r>
+              <a:rPr lang="en-US" sz="1400" dirty="0">
+                <a:solidFill>
+                  <a:schemeClr val="tx1"/>
+                </a:solidFill>
+              </a:rPr>
+              <a:t>Meta's direct return (0.76x) is still being built; budget has already moved toward what converts best.</a:t>
             </a:r>
             <a:endParaRPr lang="en-US" sz="1400" dirty="0"/>
           </a:p>
@@ -3237,6 +3830,720 @@
                 <a:ea typeface="Cambria" pitchFamily="34" charset="-122"/>
                 <a:cs typeface="Cambria" pitchFamily="34" charset="-120"/>
               </a:rPr>
+              <a:t>Positive signals from the last week</a:t>
+            </a:r>
+            <a:endParaRPr lang="en-US" sz="2600" dirty="0"/>
+          </a:p>
+        </p:txBody>
+      </p:sp>
+      <p:graphicFrame>
+        <p:nvGraphicFramePr>
+          <p:cNvPr id="3" name="Daily sales chart" descr=""/>
+          <p:cNvGraphicFramePr/>
+          <p:nvPr/>
+        </p:nvGraphicFramePr>
+        <p:xfrm>
+          <a:off x="457200" y="960120"/>
+          <a:ext cx="4297680" cy="2514600"/>
+        </p:xfrm>
+        <a:graphic xmlns:a="http://schemas.openxmlformats.org/drawingml/2006/main">
+          <a:graphicData uri="http://schemas.openxmlformats.org/drawingml/2006/chart">
+            <c:chart xmlns:c="http://schemas.openxmlformats.org/drawingml/2006/chart" r:id="rId1"/>
+          </a:graphicData>
+        </a:graphic>
+      </p:graphicFrame>
+      <p:sp>
+        <p:nvSpPr>
+          <p:cNvPr id="4" name="Text 1"/>
+          <p:cNvSpPr txBox="1"/>
+          <p:nvPr/>
+        </p:nvSpPr>
+        <p:spPr>
+          <a:xfrm>
+            <a:off x="457200" y="3611880"/>
+            <a:ext cx="1737360" cy="685800"/>
+          </a:xfrm>
+          <a:prstGeom prst="rect">
+            <a:avLst/>
+          </a:prstGeom>
+          <a:noFill/>
+          <a:ln/>
+        </p:spPr>
+        <p:txBody>
+          <a:bodyPr wrap="square" lIns="0" tIns="0" rIns="0" bIns="0" rtlCol="0" anchor="ctr"/>
+          <a:lstStyle/>
+          <a:p>
+            <a:pPr indent="0" marL="0">
+              <a:buNone/>
+            </a:pPr>
+            <a:r>
+              <a:rPr lang="en-US" sz="3200" b="1" dirty="0">
+                <a:solidFill>
+                  <a:schemeClr val="accent2"/>
+                </a:solidFill>
+                <a:latin typeface="Cambria" pitchFamily="34" charset="0"/>
+                <a:ea typeface="Cambria" pitchFamily="34" charset="-122"/>
+                <a:cs typeface="Cambria" pitchFamily="34" charset="-120"/>
+              </a:rPr>
+              <a:t>$1,745</a:t>
+            </a:r>
+            <a:endParaRPr lang="en-US" sz="3200" dirty="0"/>
+          </a:p>
+        </p:txBody>
+      </p:sp>
+      <p:sp>
+        <p:nvSpPr>
+          <p:cNvPr id="5" name="Text 2"/>
+          <p:cNvSpPr txBox="1"/>
+          <p:nvPr/>
+        </p:nvSpPr>
+        <p:spPr>
+          <a:xfrm>
+            <a:off x="2240280" y="3611880"/>
+            <a:ext cx="2514600" cy="685800"/>
+          </a:xfrm>
+          <a:prstGeom prst="rect">
+            <a:avLst/>
+          </a:prstGeom>
+          <a:noFill/>
+          <a:ln/>
+        </p:spPr>
+        <p:txBody>
+          <a:bodyPr wrap="square" lIns="0" tIns="0" rIns="0" bIns="0" rtlCol="0" anchor="ctr"/>
+          <a:lstStyle/>
+          <a:p>
+            <a:pPr indent="0" marL="0">
+              <a:buNone/>
+            </a:pPr>
+            <a:r>
+              <a:rPr lang="en-US" sz="1200" dirty="0">
+                <a:solidFill>
+                  <a:schemeClr val="tx1"/>
+                </a:solidFill>
+              </a:rPr>
+              <a:t>average daily sales Oct 10–12, vs. $919 Oct 1–9</a:t>
+            </a:r>
+            <a:endParaRPr lang="en-US" sz="1200" dirty="0"/>
+          </a:p>
+        </p:txBody>
+      </p:sp>
+      <p:sp>
+        <p:nvSpPr>
+          <p:cNvPr id="6" name="Positive card 1"/>
+          <p:cNvSpPr/>
+          <p:nvPr/>
+        </p:nvSpPr>
+        <p:spPr>
+          <a:xfrm>
+            <a:off x="5029200" y="1005840"/>
+            <a:ext cx="1783080" cy="1554480"/>
+          </a:xfrm>
+          <a:prstGeom prst="roundRect">
+            <a:avLst>
+              <a:gd name="adj" fmla="val 4706"/>
+            </a:avLst>
+          </a:prstGeom>
+          <a:solidFill>
+            <a:schemeClr val="bg2"/>
+          </a:solidFill>
+          <a:ln/>
+        </p:spPr>
+      </p:sp>
+      <p:sp>
+        <p:nvSpPr>
+          <p:cNvPr id="7" name="Positive dot 1"/>
+          <p:cNvSpPr/>
+          <p:nvPr/>
+        </p:nvSpPr>
+        <p:spPr>
+          <a:xfrm>
+            <a:off x="5166360" y="1143000"/>
+            <a:ext cx="256032" cy="256032"/>
+          </a:xfrm>
+          <a:prstGeom prst="ellipse">
+            <a:avLst/>
+          </a:prstGeom>
+          <a:solidFill>
+            <a:schemeClr val="accent2"/>
+          </a:solidFill>
+          <a:ln/>
+        </p:spPr>
+      </p:sp>
+      <p:sp>
+        <p:nvSpPr>
+          <p:cNvPr id="8" name="Text 5"/>
+          <p:cNvSpPr txBox="1"/>
+          <p:nvPr/>
+        </p:nvSpPr>
+        <p:spPr>
+          <a:xfrm>
+            <a:off x="5486400" y="1097280"/>
+            <a:ext cx="1261872" cy="365760"/>
+          </a:xfrm>
+          <a:prstGeom prst="rect">
+            <a:avLst/>
+          </a:prstGeom>
+          <a:noFill/>
+          <a:ln/>
+        </p:spPr>
+        <p:txBody>
+          <a:bodyPr wrap="square" lIns="0" tIns="0" rIns="0" bIns="0" rtlCol="0" anchor="ctr">
+            <a:normAutofit/>
+          </a:bodyPr>
+          <a:lstStyle/>
+          <a:p>
+            <a:pPr indent="0" marL="0">
+              <a:buNone/>
+            </a:pPr>
+            <a:r>
+              <a:rPr lang="en-US" sz="1200" b="1" dirty="0">
+                <a:solidFill>
+                  <a:schemeClr val="tx1"/>
+                </a:solidFill>
+                <a:latin typeface="Cambria" pitchFamily="34" charset="0"/>
+                <a:ea typeface="Cambria" pitchFamily="34" charset="-122"/>
+                <a:cs typeface="Cambria" pitchFamily="34" charset="-120"/>
+              </a:rPr>
+              <a:t>More profitable flows</a:t>
+            </a:r>
+            <a:endParaRPr lang="en-US" sz="1200" dirty="0"/>
+          </a:p>
+        </p:txBody>
+      </p:sp>
+      <p:sp>
+        <p:nvSpPr>
+          <p:cNvPr id="9" name="Text 6"/>
+          <p:cNvSpPr txBox="1"/>
+          <p:nvPr/>
+        </p:nvSpPr>
+        <p:spPr>
+          <a:xfrm>
+            <a:off x="5166360" y="1508760"/>
+            <a:ext cx="1536192" cy="987552"/>
+          </a:xfrm>
+          <a:prstGeom prst="rect">
+            <a:avLst/>
+          </a:prstGeom>
+          <a:noFill/>
+          <a:ln/>
+        </p:spPr>
+        <p:txBody>
+          <a:bodyPr wrap="square" lIns="0" tIns="0" rIns="0" bIns="0" rtlCol="0" anchor="t"/>
+          <a:lstStyle/>
+          <a:p>
+            <a:pPr indent="0" marL="0">
+              <a:buNone/>
+            </a:pPr>
+            <a:r>
+              <a:rPr lang="en-US" sz="1050" dirty="0">
+                <a:solidFill>
+                  <a:schemeClr val="tx1"/>
+                </a:solidFill>
+              </a:rPr>
+              <a:t>After the adjustments, flows earn $1.04 per recipient (vs. $0.21 in September) and $80 a day (+40%)</a:t>
+            </a:r>
+            <a:endParaRPr lang="en-US" sz="1050" dirty="0"/>
+          </a:p>
+        </p:txBody>
+      </p:sp>
+      <p:sp>
+        <p:nvSpPr>
+          <p:cNvPr id="10" name="Positive card 2"/>
+          <p:cNvSpPr/>
+          <p:nvPr/>
+        </p:nvSpPr>
+        <p:spPr>
+          <a:xfrm>
+            <a:off x="6903720" y="1005840"/>
+            <a:ext cx="1783080" cy="1554480"/>
+          </a:xfrm>
+          <a:prstGeom prst="roundRect">
+            <a:avLst>
+              <a:gd name="adj" fmla="val 4706"/>
+            </a:avLst>
+          </a:prstGeom>
+          <a:solidFill>
+            <a:schemeClr val="bg2"/>
+          </a:solidFill>
+          <a:ln/>
+        </p:spPr>
+      </p:sp>
+      <p:sp>
+        <p:nvSpPr>
+          <p:cNvPr id="11" name="Positive dot 2"/>
+          <p:cNvSpPr/>
+          <p:nvPr/>
+        </p:nvSpPr>
+        <p:spPr>
+          <a:xfrm>
+            <a:off x="7040880" y="1143000"/>
+            <a:ext cx="256032" cy="256032"/>
+          </a:xfrm>
+          <a:prstGeom prst="ellipse">
+            <a:avLst/>
+          </a:prstGeom>
+          <a:solidFill>
+            <a:schemeClr val="accent2"/>
+          </a:solidFill>
+          <a:ln/>
+        </p:spPr>
+      </p:sp>
+      <p:sp>
+        <p:nvSpPr>
+          <p:cNvPr id="12" name="Text 9"/>
+          <p:cNvSpPr txBox="1"/>
+          <p:nvPr/>
+        </p:nvSpPr>
+        <p:spPr>
+          <a:xfrm>
+            <a:off x="7360920" y="1097280"/>
+            <a:ext cx="1261872" cy="365760"/>
+          </a:xfrm>
+          <a:prstGeom prst="rect">
+            <a:avLst/>
+          </a:prstGeom>
+          <a:noFill/>
+          <a:ln/>
+        </p:spPr>
+        <p:txBody>
+          <a:bodyPr wrap="square" lIns="0" tIns="0" rIns="0" bIns="0" rtlCol="0" anchor="ctr">
+            <a:normAutofit/>
+          </a:bodyPr>
+          <a:lstStyle/>
+          <a:p>
+            <a:pPr indent="0" marL="0">
+              <a:buNone/>
+            </a:pPr>
+            <a:r>
+              <a:rPr lang="en-US" sz="1200" b="1" dirty="0">
+                <a:solidFill>
+                  <a:schemeClr val="tx1"/>
+                </a:solidFill>
+                <a:latin typeface="Cambria" pitchFamily="34" charset="0"/>
+                <a:ea typeface="Cambria" pitchFamily="34" charset="-122"/>
+                <a:cs typeface="Cambria" pitchFamily="34" charset="-120"/>
+              </a:rPr>
+              <a:t>Smile is growing</a:t>
+            </a:r>
+            <a:endParaRPr lang="en-US" sz="1200" dirty="0"/>
+          </a:p>
+        </p:txBody>
+      </p:sp>
+      <p:sp>
+        <p:nvSpPr>
+          <p:cNvPr id="13" name="Text 10"/>
+          <p:cNvSpPr txBox="1"/>
+          <p:nvPr/>
+        </p:nvSpPr>
+        <p:spPr>
+          <a:xfrm>
+            <a:off x="7040880" y="1508760"/>
+            <a:ext cx="1536192" cy="987552"/>
+          </a:xfrm>
+          <a:prstGeom prst="rect">
+            <a:avLst/>
+          </a:prstGeom>
+          <a:noFill/>
+          <a:ln/>
+        </p:spPr>
+        <p:txBody>
+          <a:bodyPr wrap="square" lIns="0" tIns="0" rIns="0" bIns="0" rtlCol="0" anchor="t"/>
+          <a:lstStyle/>
+          <a:p>
+            <a:pPr indent="0" marL="0">
+              <a:buNone/>
+            </a:pPr>
+            <a:r>
+              <a:rPr lang="en-US" sz="1050" dirty="0">
+                <a:solidFill>
+                  <a:schemeClr val="tx1"/>
+                </a:solidFill>
+              </a:rPr>
+              <a:t>Customers earning points on orders: from 74 to 82 a week (+11%) since paid media began</a:t>
+            </a:r>
+            <a:endParaRPr lang="en-US" sz="1050" dirty="0"/>
+          </a:p>
+        </p:txBody>
+      </p:sp>
+      <p:sp>
+        <p:nvSpPr>
+          <p:cNvPr id="14" name="Positive card 3"/>
+          <p:cNvSpPr/>
+          <p:nvPr/>
+        </p:nvSpPr>
+        <p:spPr>
+          <a:xfrm>
+            <a:off x="5029200" y="2697480"/>
+            <a:ext cx="1783080" cy="1554480"/>
+          </a:xfrm>
+          <a:prstGeom prst="roundRect">
+            <a:avLst>
+              <a:gd name="adj" fmla="val 4706"/>
+            </a:avLst>
+          </a:prstGeom>
+          <a:solidFill>
+            <a:schemeClr val="bg2"/>
+          </a:solidFill>
+          <a:ln/>
+        </p:spPr>
+      </p:sp>
+      <p:sp>
+        <p:nvSpPr>
+          <p:cNvPr id="15" name="Positive dot 3"/>
+          <p:cNvSpPr/>
+          <p:nvPr/>
+        </p:nvSpPr>
+        <p:spPr>
+          <a:xfrm>
+            <a:off x="5166360" y="2834640"/>
+            <a:ext cx="256032" cy="256032"/>
+          </a:xfrm>
+          <a:prstGeom prst="ellipse">
+            <a:avLst/>
+          </a:prstGeom>
+          <a:solidFill>
+            <a:schemeClr val="accent2"/>
+          </a:solidFill>
+          <a:ln/>
+        </p:spPr>
+      </p:sp>
+      <p:sp>
+        <p:nvSpPr>
+          <p:cNvPr id="16" name="Text 13"/>
+          <p:cNvSpPr txBox="1"/>
+          <p:nvPr/>
+        </p:nvSpPr>
+        <p:spPr>
+          <a:xfrm>
+            <a:off x="5486400" y="2788920"/>
+            <a:ext cx="1261872" cy="365760"/>
+          </a:xfrm>
+          <a:prstGeom prst="rect">
+            <a:avLst/>
+          </a:prstGeom>
+          <a:noFill/>
+          <a:ln/>
+        </p:spPr>
+        <p:txBody>
+          <a:bodyPr wrap="square" lIns="0" tIns="0" rIns="0" bIns="0" rtlCol="0" anchor="ctr">
+            <a:normAutofit/>
+          </a:bodyPr>
+          <a:lstStyle/>
+          <a:p>
+            <a:pPr indent="0" marL="0">
+              <a:buNone/>
+            </a:pPr>
+            <a:r>
+              <a:rPr lang="en-US" sz="1200" b="1" dirty="0">
+                <a:solidFill>
+                  <a:schemeClr val="tx1"/>
+                </a:solidFill>
+                <a:latin typeface="Cambria" pitchFamily="34" charset="0"/>
+                <a:ea typeface="Cambria" pitchFamily="34" charset="-122"/>
+                <a:cs typeface="Cambria" pitchFamily="34" charset="-120"/>
+              </a:rPr>
+              <a:t>Subscriptions up</a:t>
+            </a:r>
+            <a:endParaRPr lang="en-US" sz="1200" dirty="0"/>
+          </a:p>
+        </p:txBody>
+      </p:sp>
+      <p:sp>
+        <p:nvSpPr>
+          <p:cNvPr id="17" name="Text 14"/>
+          <p:cNvSpPr txBox="1"/>
+          <p:nvPr/>
+        </p:nvSpPr>
+        <p:spPr>
+          <a:xfrm>
+            <a:off x="5166360" y="3200400"/>
+            <a:ext cx="1536192" cy="987552"/>
+          </a:xfrm>
+          <a:prstGeom prst="rect">
+            <a:avLst/>
+          </a:prstGeom>
+          <a:noFill/>
+          <a:ln/>
+        </p:spPr>
+        <p:txBody>
+          <a:bodyPr wrap="square" lIns="0" tIns="0" rIns="0" bIns="0" rtlCol="0" anchor="t"/>
+          <a:lstStyle/>
+          <a:p>
+            <a:pPr indent="0" marL="0">
+              <a:buNone/>
+            </a:pPr>
+            <a:r>
+              <a:rPr lang="en-US" sz="1050" dirty="0">
+                <a:solidFill>
+                  <a:schemeClr val="tx1"/>
+                </a:solidFill>
+              </a:rPr>
+              <a:t>Higher subscription sales, with the Subscribe &amp; Save flow live since Oct 7</a:t>
+            </a:r>
+            <a:endParaRPr lang="en-US" sz="1050" dirty="0"/>
+          </a:p>
+        </p:txBody>
+      </p:sp>
+      <p:sp>
+        <p:nvSpPr>
+          <p:cNvPr id="18" name="Positive card 4"/>
+          <p:cNvSpPr/>
+          <p:nvPr/>
+        </p:nvSpPr>
+        <p:spPr>
+          <a:xfrm>
+            <a:off x="6903720" y="2697480"/>
+            <a:ext cx="1783080" cy="1554480"/>
+          </a:xfrm>
+          <a:prstGeom prst="roundRect">
+            <a:avLst>
+              <a:gd name="adj" fmla="val 4706"/>
+            </a:avLst>
+          </a:prstGeom>
+          <a:solidFill>
+            <a:schemeClr val="bg2"/>
+          </a:solidFill>
+          <a:ln/>
+        </p:spPr>
+      </p:sp>
+      <p:sp>
+        <p:nvSpPr>
+          <p:cNvPr id="19" name="Positive dot 4"/>
+          <p:cNvSpPr/>
+          <p:nvPr/>
+        </p:nvSpPr>
+        <p:spPr>
+          <a:xfrm>
+            <a:off x="7040880" y="2834640"/>
+            <a:ext cx="256032" cy="256032"/>
+          </a:xfrm>
+          <a:prstGeom prst="ellipse">
+            <a:avLst/>
+          </a:prstGeom>
+          <a:solidFill>
+            <a:schemeClr val="accent2"/>
+          </a:solidFill>
+          <a:ln/>
+        </p:spPr>
+      </p:sp>
+      <p:sp>
+        <p:nvSpPr>
+          <p:cNvPr id="20" name="Text 17"/>
+          <p:cNvSpPr txBox="1"/>
+          <p:nvPr/>
+        </p:nvSpPr>
+        <p:spPr>
+          <a:xfrm>
+            <a:off x="7360920" y="2788920"/>
+            <a:ext cx="1261872" cy="365760"/>
+          </a:xfrm>
+          <a:prstGeom prst="rect">
+            <a:avLst/>
+          </a:prstGeom>
+          <a:noFill/>
+          <a:ln/>
+        </p:spPr>
+        <p:txBody>
+          <a:bodyPr wrap="square" lIns="0" tIns="0" rIns="0" bIns="0" rtlCol="0" anchor="ctr">
+            <a:normAutofit/>
+          </a:bodyPr>
+          <a:lstStyle/>
+          <a:p>
+            <a:pPr indent="0" marL="0">
+              <a:buNone/>
+            </a:pPr>
+            <a:r>
+              <a:rPr lang="en-US" sz="1200" b="1" dirty="0">
+                <a:solidFill>
+                  <a:schemeClr val="tx1"/>
+                </a:solidFill>
+                <a:latin typeface="Cambria" pitchFamily="34" charset="0"/>
+                <a:ea typeface="Cambria" pitchFamily="34" charset="-122"/>
+                <a:cs typeface="Cambria" pitchFamily="34" charset="-120"/>
+              </a:rPr>
+              <a:t>Google: Brand and PMax</a:t>
+            </a:r>
+            <a:endParaRPr lang="en-US" sz="1200" dirty="0"/>
+          </a:p>
+        </p:txBody>
+      </p:sp>
+      <p:sp>
+        <p:nvSpPr>
+          <p:cNvPr id="21" name="Text 18"/>
+          <p:cNvSpPr txBox="1"/>
+          <p:nvPr/>
+        </p:nvSpPr>
+        <p:spPr>
+          <a:xfrm>
+            <a:off x="7040880" y="3200400"/>
+            <a:ext cx="1536192" cy="987552"/>
+          </a:xfrm>
+          <a:prstGeom prst="rect">
+            <a:avLst/>
+          </a:prstGeom>
+          <a:noFill/>
+          <a:ln/>
+        </p:spPr>
+        <p:txBody>
+          <a:bodyPr wrap="square" lIns="0" tIns="0" rIns="0" bIns="0" rtlCol="0" anchor="t"/>
+          <a:lstStyle/>
+          <a:p>
+            <a:pPr indent="0" marL="0">
+              <a:buNone/>
+            </a:pPr>
+            <a:r>
+              <a:rPr lang="en-US" sz="1050" dirty="0">
+                <a:solidFill>
+                  <a:schemeClr val="tx1"/>
+                </a:solidFill>
+              </a:rPr>
+              <a:t>Very strong ROAS last week, in step with Meta coming on</a:t>
+            </a:r>
+            <a:endParaRPr lang="en-US" sz="1050" dirty="0"/>
+          </a:p>
+        </p:txBody>
+      </p:sp>
+      <p:sp>
+        <p:nvSpPr>
+          <p:cNvPr id="22" name="Text 19"/>
+          <p:cNvSpPr txBox="1"/>
+          <p:nvPr/>
+        </p:nvSpPr>
+        <p:spPr>
+          <a:xfrm>
+            <a:off x="457200" y="4434840"/>
+            <a:ext cx="8229600" cy="274320"/>
+          </a:xfrm>
+          <a:prstGeom prst="rect">
+            <a:avLst/>
+          </a:prstGeom>
+          <a:noFill/>
+          <a:ln/>
+        </p:spPr>
+        <p:txBody>
+          <a:bodyPr wrap="square" lIns="0" tIns="0" rIns="0" bIns="0" rtlCol="0" anchor="ctr"/>
+          <a:lstStyle/>
+          <a:p>
+            <a:pPr indent="0" marL="0">
+              <a:buNone/>
+            </a:pPr>
+            <a:r>
+              <a:rPr lang="en-US" sz="900" i="1" dirty="0">
+                <a:solidFill>
+                  <a:schemeClr val="accent4"/>
+                </a:solidFill>
+              </a:rPr>
+              <a:t>Source: Klaviyo (Brooklyn Biltong) for store sales, flows and Smile. Subscriptions and Google: team platform reports.</a:t>
+            </a:r>
+            <a:endParaRPr lang="en-US" sz="900" dirty="0"/>
+          </a:p>
+        </p:txBody>
+      </p:sp>
+      <p:sp>
+        <p:nvSpPr>
+          <p:cNvPr id="25" name="Slide Number Placeholder 0"/>
+          <p:cNvSpPr>
+            <a:spLocks noGrp="1"/>
+          </p:cNvSpPr>
+          <p:nvPr>
+            <p:ph type="sldNum" sz="quarter" idx="4294967295"/>
+          </p:nvPr>
+        </p:nvSpPr>
+        <p:spPr>
+          <a:xfrm>
+            <a:off x="8321040" y="4800600"/>
+            <a:ext cx="365760" cy="228600"/>
+          </a:xfrm>
+          <a:prstGeom prst="rect">
+            <a:avLst/>
+          </a:prstGeom>
+          <a:extLst>
+            <a:ext uri="{C572A759-6A51-4108-AA02-DFA0A04FC94B}">
+              <ma14:wrappingTextBoxFlag xmlns:ma14="http://schemas.microsoft.com/office/mac/drawingml/2011/main" val="0"/>
+            </a:ext>
+          </a:extLst>
+        </p:spPr>
+        <p:txBody>
+          <a:bodyPr/>
+          <a:lstStyle>
+            <a:lvl1pPr>
+              <a:defRPr sz="900">
+                <a:solidFill>
+                  <a:schemeClr val="accent4"/>
+                </a:solidFill>
+              </a:defRPr>
+            </a:lvl1pPr>
+          </a:lstStyle>
+          <a:p>
+            <a:pPr algn="r"/>
+            <a:fld id="{F7021451-1387-4CA6-816F-3879F97B5CBC}" type="slidenum">
+              <a:rPr b="0" lang="en-US"/>
+              <a:t>3</a:t>
+            </a:fld>
+            <a:endParaRPr lang="en-US"/>
+          </a:p>
+        </p:txBody>
+      </p:sp>
+    </p:spTree>
+  </p:cSld>
+  <p:clrMapOvr>
+    <a:masterClrMapping/>
+  </p:clrMapOvr>
+</p:sld>
+</file>
+
+<file path=ppt/slides/slide4.xml><?xml version="1.0" encoding="utf-8"?>
+<p:sld xmlns:a="http://schemas.openxmlformats.org/drawingml/2006/main" xmlns:r="http://schemas.openxmlformats.org/officeDocument/2006/relationships" xmlns:p="http://schemas.openxmlformats.org/presentationml/2006/main">
+  <p:cSld name="Slide 4">
+    <p:spTree>
+      <p:nvGrpSpPr>
+        <p:cNvPr id="1" name=""/>
+        <p:cNvGrpSpPr/>
+        <p:nvPr/>
+      </p:nvGrpSpPr>
+      <p:grpSpPr>
+        <a:xfrm>
+          <a:off x="0" y="0"/>
+          <a:ext cx="0" cy="0"/>
+          <a:chOff x="0" y="0"/>
+          <a:chExt cx="0" cy="0"/>
+        </a:xfrm>
+      </p:grpSpPr>
+      <p:sp>
+        <p:nvSpPr>
+          <p:cNvPr id="2" name="Text 0"/>
+          <p:cNvSpPr/>
+          <p:nvPr>
+            <p:ph idx="100" type="title" hasCustomPrompt="1"/>
+          </p:nvPr>
+        </p:nvSpPr>
+        <p:spPr>
+          <a:xfrm>
+            <a:off x="457200" y="274320"/>
+            <a:ext cx="8229600" cy="594360"/>
+          </a:xfrm>
+          <a:prstGeom prst="rect">
+            <a:avLst/>
+          </a:prstGeom>
+          <a:noFill/>
+          <a:ln/>
+        </p:spPr>
+        <p:txBody>
+          <a:bodyPr wrap="square" lIns="0" tIns="0" rIns="0" bIns="0" rtlCol="0" anchor="ctr"/>
+          <a:lstStyle/>
+          <a:p>
+            <a:pPr algn="l" indent="0" marL="0">
+              <a:buNone/>
+            </a:pPr>
+            <a:r>
+              <a:rPr lang="en-US" sz="2600" b="1" dirty="0">
+                <a:solidFill>
+                  <a:schemeClr val="tx1"/>
+                </a:solidFill>
+                <a:latin typeface="Cambria" pitchFamily="34" charset="0"/>
+                <a:ea typeface="Cambria" pitchFamily="34" charset="-122"/>
+                <a:cs typeface="Cambria" pitchFamily="34" charset="-120"/>
+              </a:rPr>
               <a:t>October 9 commitments: status by brand</a:t>
             </a:r>
             <a:endParaRPr lang="en-US" sz="2600" dirty="0"/>
@@ -3245,7 +4552,7 @@
       </p:sp>
       <p:graphicFrame>
         <p:nvGraphicFramePr>
-          <p:cNvPr id="4" name="Commitment tracker"/>
+          <p:cNvPr id="5" name="Commitment tracker"/>
           <p:cNvGraphicFramePr>
             <a:graphicFrameLocks noGrp="1"/>
           </p:cNvGraphicFramePr>
@@ -6054,381 +7361,6 @@
             <a:pPr algn="r"/>
             <a:fld id="{F7021451-1387-4CA6-816F-3879F97B5CBC}" type="slidenum">
               <a:rPr b="0" lang="en-US"/>
-              <a:t>3</a:t>
-            </a:fld>
-            <a:endParaRPr lang="en-US"/>
-          </a:p>
-        </p:txBody>
-      </p:sp>
-    </p:spTree>
-  </p:cSld>
-  <p:clrMapOvr>
-    <a:masterClrMapping/>
-  </p:clrMapOvr>
-</p:sld>
-</file>
-
-<file path=ppt/slides/slide4.xml><?xml version="1.0" encoding="utf-8"?>
-<p:sld xmlns:a="http://schemas.openxmlformats.org/drawingml/2006/main" xmlns:r="http://schemas.openxmlformats.org/officeDocument/2006/relationships" xmlns:p="http://schemas.openxmlformats.org/presentationml/2006/main">
-  <p:cSld name="Slide 4">
-    <p:spTree>
-      <p:nvGrpSpPr>
-        <p:cNvPr id="1" name=""/>
-        <p:cNvGrpSpPr/>
-        <p:nvPr/>
-      </p:nvGrpSpPr>
-      <p:grpSpPr>
-        <a:xfrm>
-          <a:off x="0" y="0"/>
-          <a:ext cx="0" cy="0"/>
-          <a:chOff x="0" y="0"/>
-          <a:chExt cx="0" cy="0"/>
-        </a:xfrm>
-      </p:grpSpPr>
-      <p:sp>
-        <p:nvSpPr>
-          <p:cNvPr id="2" name="Text 0"/>
-          <p:cNvSpPr/>
-          <p:nvPr>
-            <p:ph idx="100" type="title" hasCustomPrompt="1"/>
-          </p:nvPr>
-        </p:nvSpPr>
-        <p:spPr>
-          <a:xfrm>
-            <a:off x="457200" y="274320"/>
-            <a:ext cx="8229600" cy="594360"/>
-          </a:xfrm>
-          <a:prstGeom prst="rect">
-            <a:avLst/>
-          </a:prstGeom>
-          <a:noFill/>
-          <a:ln/>
-        </p:spPr>
-        <p:txBody>
-          <a:bodyPr wrap="square" lIns="0" tIns="0" rIns="0" bIns="0" rtlCol="0" anchor="ctr"/>
-          <a:lstStyle/>
-          <a:p>
-            <a:pPr algn="l" indent="0" marL="0">
-              <a:buNone/>
-            </a:pPr>
-            <a:r>
-              <a:rPr lang="en-US" sz="2600" b="1" dirty="0">
-                <a:solidFill>
-                  <a:schemeClr val="tx1"/>
-                </a:solidFill>
-                <a:latin typeface="Cambria" pitchFamily="34" charset="0"/>
-                <a:ea typeface="Cambria" pitchFamily="34" charset="-122"/>
-                <a:cs typeface="Cambria" pitchFamily="34" charset="-120"/>
-              </a:rPr>
-              <a:t>Meta: more volume, efficiency still being built</a:t>
-            </a:r>
-            <a:endParaRPr lang="en-US" sz="2600" dirty="0"/>
-          </a:p>
-        </p:txBody>
-      </p:sp>
-      <p:graphicFrame>
-        <p:nvGraphicFramePr>
-          <p:cNvPr id="3" name="Purchases chart" descr=""/>
-          <p:cNvGraphicFramePr/>
-          <p:nvPr/>
-        </p:nvGraphicFramePr>
-        <p:xfrm>
-          <a:off x="457200" y="960120"/>
-          <a:ext cx="4206240" cy="3429000"/>
-        </p:xfrm>
-        <a:graphic xmlns:a="http://schemas.openxmlformats.org/drawingml/2006/main">
-          <a:graphicData uri="http://schemas.openxmlformats.org/drawingml/2006/chart">
-            <c:chart xmlns:c="http://schemas.openxmlformats.org/drawingml/2006/chart" r:id="rId1"/>
-          </a:graphicData>
-        </a:graphic>
-      </p:graphicFrame>
-      <p:sp>
-        <p:nvSpPr>
-          <p:cNvPr id="4" name="Text 1"/>
-          <p:cNvSpPr txBox="1"/>
-          <p:nvPr/>
-        </p:nvSpPr>
-        <p:spPr>
-          <a:xfrm>
-            <a:off x="4937760" y="1005840"/>
-            <a:ext cx="3749040" cy="320040"/>
-          </a:xfrm>
-          <a:prstGeom prst="rect">
-            <a:avLst/>
-          </a:prstGeom>
-          <a:noFill/>
-          <a:ln/>
-        </p:spPr>
-        <p:txBody>
-          <a:bodyPr wrap="square" lIns="0" tIns="0" rIns="0" bIns="0" rtlCol="0" anchor="ctr"/>
-          <a:lstStyle/>
-          <a:p>
-            <a:pPr indent="0" marL="0">
-              <a:buNone/>
-            </a:pPr>
-            <a:r>
-              <a:rPr lang="en-US" sz="1500" b="1" dirty="0">
-                <a:solidFill>
-                  <a:schemeClr val="accent2"/>
-                </a:solidFill>
-                <a:latin typeface="Cambria" pitchFamily="34" charset="0"/>
-                <a:ea typeface="Cambria" pitchFamily="34" charset="-122"/>
-                <a:cs typeface="Cambria" pitchFamily="34" charset="-120"/>
-              </a:rPr>
-              <a:t>What's working</a:t>
-            </a:r>
-            <a:endParaRPr lang="en-US" sz="1500" dirty="0"/>
-          </a:p>
-        </p:txBody>
-      </p:sp>
-      <p:sp>
-        <p:nvSpPr>
-          <p:cNvPr id="5" name="Text 2"/>
-          <p:cNvSpPr txBox="1"/>
-          <p:nvPr/>
-        </p:nvSpPr>
-        <p:spPr>
-          <a:xfrm>
-            <a:off x="4937760" y="1371600"/>
-            <a:ext cx="3749040" cy="1152144"/>
-          </a:xfrm>
-          <a:prstGeom prst="rect">
-            <a:avLst/>
-          </a:prstGeom>
-          <a:noFill/>
-          <a:ln/>
-        </p:spPr>
-        <p:txBody>
-          <a:bodyPr wrap="square" lIns="0" tIns="0" rIns="0" bIns="0" rtlCol="0" anchor="t"/>
-          <a:lstStyle/>
-          <a:p>
-            <a:pPr marL="342900" indent="-342900">
-              <a:spcAft>
-                <a:spcPts val="400"/>
-              </a:spcAft>
-              <a:buSzPct val="100000"/>
-              <a:buChar char="•"/>
-            </a:pPr>
-            <a:r>
-              <a:rPr lang="en-US" sz="1200" dirty="0">
-                <a:solidFill>
-                  <a:schemeClr val="tx1"/>
-                </a:solidFill>
-              </a:rPr>
-              <a:t>Ayoba new customers: $26 per purchase, 1.6x return</a:t>
-            </a:r>
-            <a:endParaRPr lang="en-US" sz="1200" dirty="0"/>
-          </a:p>
-          <a:p>
-            <a:pPr marL="342900" indent="-342900">
-              <a:spcAft>
-                <a:spcPts val="400"/>
-              </a:spcAft>
-              <a:buSzPct val="100000"/>
-              <a:buChar char="•"/>
-            </a:pPr>
-            <a:r>
-              <a:rPr lang="en-US" sz="1200" dirty="0">
-                <a:solidFill>
-                  <a:schemeClr val="tx1"/>
-                </a:solidFill>
-              </a:rPr>
-              <a:t>Brooklyn dynamic retargeting: $26 per purchase, 2.9x return</a:t>
-            </a:r>
-            <a:endParaRPr lang="en-US" sz="1200" dirty="0"/>
-          </a:p>
-          <a:p>
-            <a:pPr marL="342900" indent="-342900">
-              <a:spcAft>
-                <a:spcPts val="400"/>
-              </a:spcAft>
-              <a:buSzPct val="100000"/>
-              <a:buChar char="•"/>
-            </a:pPr>
-            <a:r>
-              <a:rPr lang="en-US" sz="1200" dirty="0">
-                <a:solidFill>
-                  <a:schemeClr val="tx1"/>
-                </a:solidFill>
-              </a:rPr>
-              <a:t>Beg &amp; Barker dynamic retargeting: 3.1x return</a:t>
-            </a:r>
-            <a:endParaRPr lang="en-US" sz="1200" dirty="0"/>
-          </a:p>
-        </p:txBody>
-      </p:sp>
-      <p:sp>
-        <p:nvSpPr>
-          <p:cNvPr id="6" name="Text 3"/>
-          <p:cNvSpPr txBox="1"/>
-          <p:nvPr/>
-        </p:nvSpPr>
-        <p:spPr>
-          <a:xfrm>
-            <a:off x="4937760" y="2697480"/>
-            <a:ext cx="3749040" cy="320040"/>
-          </a:xfrm>
-          <a:prstGeom prst="rect">
-            <a:avLst/>
-          </a:prstGeom>
-          <a:noFill/>
-          <a:ln/>
-        </p:spPr>
-        <p:txBody>
-          <a:bodyPr wrap="square" lIns="0" tIns="0" rIns="0" bIns="0" rtlCol="0" anchor="ctr"/>
-          <a:lstStyle/>
-          <a:p>
-            <a:pPr indent="0" marL="0">
-              <a:buNone/>
-            </a:pPr>
-            <a:r>
-              <a:rPr lang="en-US" sz="1500" b="1" dirty="0">
-                <a:solidFill>
-                  <a:schemeClr val="accent1"/>
-                </a:solidFill>
-                <a:latin typeface="Cambria" pitchFamily="34" charset="0"/>
-                <a:ea typeface="Cambria" pitchFamily="34" charset="-122"/>
-                <a:cs typeface="Cambria" pitchFamily="34" charset="-120"/>
-              </a:rPr>
-              <a:t>What we're fixing</a:t>
-            </a:r>
-            <a:endParaRPr lang="en-US" sz="1500" dirty="0"/>
-          </a:p>
-        </p:txBody>
-      </p:sp>
-      <p:sp>
-        <p:nvSpPr>
-          <p:cNvPr id="7" name="Text 4"/>
-          <p:cNvSpPr txBox="1"/>
-          <p:nvPr/>
-        </p:nvSpPr>
-        <p:spPr>
-          <a:xfrm>
-            <a:off x="4937760" y="3063240"/>
-            <a:ext cx="3749040" cy="768096"/>
-          </a:xfrm>
-          <a:prstGeom prst="rect">
-            <a:avLst/>
-          </a:prstGeom>
-          <a:noFill/>
-          <a:ln/>
-        </p:spPr>
-        <p:txBody>
-          <a:bodyPr wrap="square" lIns="0" tIns="0" rIns="0" bIns="0" rtlCol="0" anchor="t"/>
-          <a:lstStyle/>
-          <a:p>
-            <a:pPr marL="342900" indent="-342900">
-              <a:spcAft>
-                <a:spcPts val="400"/>
-              </a:spcAft>
-              <a:buSzPct val="100000"/>
-              <a:buChar char="•"/>
-            </a:pPr>
-            <a:r>
-              <a:rPr lang="en-US" sz="1200" dirty="0">
-                <a:solidFill>
-                  <a:schemeClr val="tx1"/>
-                </a:solidFill>
-              </a:rPr>
-              <a:t>Brooklyn new customers: $170 per purchase → budget trimmed on Oct 13</a:t>
-            </a:r>
-            <a:endParaRPr lang="en-US" sz="1200" dirty="0"/>
-          </a:p>
-          <a:p>
-            <a:pPr marL="342900" indent="-342900">
-              <a:spcAft>
-                <a:spcPts val="400"/>
-              </a:spcAft>
-              <a:buSzPct val="100000"/>
-              <a:buChar char="•"/>
-            </a:pPr>
-            <a:r>
-              <a:rPr lang="en-US" sz="1200" dirty="0">
-                <a:solidFill>
-                  <a:schemeClr val="tx1"/>
-                </a:solidFill>
-              </a:rPr>
-              <a:t>New retargeting (since Oct 10) is still learning; budget raised for Ayoba and Beg &amp; Barker</a:t>
-            </a:r>
-            <a:endParaRPr lang="en-US" sz="1200" dirty="0"/>
-          </a:p>
-        </p:txBody>
-      </p:sp>
-      <p:sp>
-        <p:nvSpPr>
-          <p:cNvPr id="8" name="Text 5"/>
-          <p:cNvSpPr txBox="1"/>
-          <p:nvPr/>
-        </p:nvSpPr>
-        <p:spPr>
-          <a:xfrm>
-            <a:off x="457200" y="4434840"/>
-            <a:ext cx="8229600" cy="274320"/>
-          </a:xfrm>
-          <a:prstGeom prst="rect">
-            <a:avLst/>
-          </a:prstGeom>
-          <a:noFill/>
-          <a:ln/>
-        </p:spPr>
-        <p:txBody>
-          <a:bodyPr wrap="square" lIns="0" tIns="0" rIns="0" bIns="0" rtlCol="0" anchor="ctr"/>
-          <a:lstStyle/>
-          <a:p>
-            <a:pPr indent="0" marL="0">
-              <a:buNone/>
-            </a:pPr>
-            <a:r>
-              <a:rPr lang="en-US" sz="900" i="1" dirty="0">
-                <a:solidFill>
-                  <a:schemeClr val="accent4"/>
-                </a:solidFill>
-              </a:rPr>
-              <a:t>Source: Meta Ads Manager, platform-attributed purchases and return. Excludes Google Ads and total store sales (see dashboards).</a:t>
-            </a:r>
-            <a:endParaRPr lang="en-US" sz="900" dirty="0"/>
-          </a:p>
-        </p:txBody>
-      </p:sp>
-      <p:sp>
-        <p:nvSpPr>
-          <p:cNvPr id="25" name="Slide Number Placeholder 0"/>
-          <p:cNvSpPr>
-            <a:spLocks noGrp="1"/>
-          </p:cNvSpPr>
-          <p:nvPr>
-            <p:ph type="sldNum" sz="quarter" idx="4294967295"/>
-          </p:nvPr>
-        </p:nvSpPr>
-        <p:spPr>
-          <a:xfrm>
-            <a:off x="8321040" y="4800600"/>
-            <a:ext cx="365760" cy="228600"/>
-          </a:xfrm>
-          <a:prstGeom prst="rect">
-            <a:avLst/>
-          </a:prstGeom>
-          <a:extLst>
-            <a:ext uri="{C572A759-6A51-4108-AA02-DFA0A04FC94B}">
-              <ma14:wrappingTextBoxFlag xmlns:ma14="http://schemas.microsoft.com/office/mac/drawingml/2011/main" val="0"/>
-            </a:ext>
-          </a:extLst>
-        </p:spPr>
-        <p:txBody>
-          <a:bodyPr/>
-          <a:lstStyle>
-            <a:lvl1pPr>
-              <a:defRPr sz="900">
-                <a:solidFill>
-                  <a:schemeClr val="accent4"/>
-                </a:solidFill>
-              </a:defRPr>
-            </a:lvl1pPr>
-          </a:lstStyle>
-          <a:p>
-            <a:pPr algn="r"/>
-            <a:fld id="{F7021451-1387-4CA6-816F-3879F97B5CBC}" type="slidenum">
-              <a:rPr b="0" lang="en-US"/>
               <a:t>4</a:t>
             </a:fld>
             <a:endParaRPr lang="en-US"/>
@@ -6495,207 +7427,21 @@
                 <a:ea typeface="Cambria" pitchFamily="34" charset="-122"/>
                 <a:cs typeface="Cambria" pitchFamily="34" charset="-120"/>
               </a:rPr>
-              <a:t>Brooklyn: email and SMS are driving repeat sales</a:t>
+              <a:t>Meta: more volume, efficiency still being built</a:t>
             </a:r>
             <a:endParaRPr lang="en-US" sz="2600" dirty="0"/>
           </a:p>
         </p:txBody>
       </p:sp>
-      <p:sp>
-        <p:nvSpPr>
-          <p:cNvPr id="3" name="Retention stat panel"/>
-          <p:cNvSpPr/>
-          <p:nvPr/>
-        </p:nvSpPr>
-        <p:spPr>
-          <a:xfrm>
-            <a:off x="457200" y="1005840"/>
-            <a:ext cx="3108960" cy="3291840"/>
-          </a:xfrm>
-          <a:prstGeom prst="roundRect">
-            <a:avLst>
-              <a:gd name="adj" fmla="val 2353"/>
-            </a:avLst>
-          </a:prstGeom>
-          <a:solidFill>
-            <a:schemeClr val="tx1"/>
-          </a:solidFill>
-          <a:ln/>
-        </p:spPr>
-      </p:sp>
-      <p:sp>
-        <p:nvSpPr>
-          <p:cNvPr id="4" name="Text 2"/>
-          <p:cNvSpPr txBox="1"/>
-          <p:nvPr/>
-        </p:nvSpPr>
-        <p:spPr>
-          <a:xfrm>
-            <a:off x="685800" y="1188720"/>
-            <a:ext cx="2651760" cy="685800"/>
-          </a:xfrm>
-          <a:prstGeom prst="rect">
-            <a:avLst/>
-          </a:prstGeom>
-          <a:noFill/>
-          <a:ln/>
-        </p:spPr>
-        <p:txBody>
-          <a:bodyPr wrap="square" lIns="0" tIns="0" rIns="0" bIns="0" rtlCol="0" anchor="ctr"/>
-          <a:lstStyle/>
-          <a:p>
-            <a:pPr indent="0" marL="0">
-              <a:buNone/>
-            </a:pPr>
-            <a:r>
-              <a:rPr lang="en-US" sz="4000" b="1" dirty="0">
-                <a:solidFill>
-                  <a:schemeClr val="bg1"/>
-                </a:solidFill>
-                <a:latin typeface="Cambria" pitchFamily="34" charset="0"/>
-                <a:ea typeface="Cambria" pitchFamily="34" charset="-122"/>
-                <a:cs typeface="Cambria" pitchFamily="34" charset="-120"/>
-              </a:rPr>
-              <a:t>$2,074</a:t>
-            </a:r>
-            <a:endParaRPr lang="en-US" sz="4000" dirty="0"/>
-          </a:p>
-        </p:txBody>
-      </p:sp>
-      <p:sp>
-        <p:nvSpPr>
-          <p:cNvPr id="5" name="Text 3"/>
-          <p:cNvSpPr txBox="1"/>
-          <p:nvPr/>
-        </p:nvSpPr>
-        <p:spPr>
-          <a:xfrm>
-            <a:off x="685800" y="1874520"/>
-            <a:ext cx="2651760" cy="457200"/>
-          </a:xfrm>
-          <a:prstGeom prst="rect">
-            <a:avLst/>
-          </a:prstGeom>
-          <a:noFill/>
-          <a:ln/>
-        </p:spPr>
-        <p:txBody>
-          <a:bodyPr wrap="square" lIns="0" tIns="0" rIns="0" bIns="0" rtlCol="0" anchor="ctr"/>
-          <a:lstStyle/>
-          <a:p>
-            <a:pPr indent="0" marL="0">
-              <a:buNone/>
-            </a:pPr>
-            <a:r>
-              <a:rPr lang="en-US" sz="1200" dirty="0">
-                <a:solidFill>
-                  <a:schemeClr val="accent6"/>
-                </a:solidFill>
-              </a:rPr>
-              <a:t>in email and SMS-attributed sales,</a:t>
-            </a:r>
-            <a:endParaRPr lang="en-US" sz="1200" dirty="0"/>
-          </a:p>
-          <a:p>
-            <a:pPr indent="0" marL="0">
-              <a:buNone/>
-            </a:pPr>
-            <a:r>
-              <a:rPr lang="en-US" sz="1200" dirty="0">
-                <a:solidFill>
-                  <a:schemeClr val="accent6"/>
-                </a:solidFill>
-              </a:rPr>
-              <a:t>Oct 1–14</a:t>
-            </a:r>
-            <a:endParaRPr lang="en-US" sz="1200" dirty="0"/>
-          </a:p>
-        </p:txBody>
-      </p:sp>
-      <p:sp>
-        <p:nvSpPr>
-          <p:cNvPr id="6" name="Text 4"/>
-          <p:cNvSpPr txBox="1"/>
-          <p:nvPr/>
-        </p:nvSpPr>
-        <p:spPr>
-          <a:xfrm>
-            <a:off x="685800" y="2468880"/>
-            <a:ext cx="2651760" cy="685800"/>
-          </a:xfrm>
-          <a:prstGeom prst="rect">
-            <a:avLst/>
-          </a:prstGeom>
-          <a:noFill/>
-          <a:ln/>
-        </p:spPr>
-        <p:txBody>
-          <a:bodyPr wrap="square" lIns="0" tIns="0" rIns="0" bIns="0" rtlCol="0" anchor="ctr"/>
-          <a:lstStyle/>
-          <a:p>
-            <a:pPr indent="0" marL="0">
-              <a:buNone/>
-            </a:pPr>
-            <a:r>
-              <a:rPr lang="en-US" sz="4000" b="1" dirty="0">
-                <a:solidFill>
-                  <a:schemeClr val="bg1"/>
-                </a:solidFill>
-                <a:latin typeface="Cambria" pitchFamily="34" charset="0"/>
-                <a:ea typeface="Cambria" pitchFamily="34" charset="-122"/>
-                <a:cs typeface="Cambria" pitchFamily="34" charset="-120"/>
-              </a:rPr>
-              <a:t>31</a:t>
-            </a:r>
-            <a:endParaRPr lang="en-US" sz="4000" dirty="0"/>
-          </a:p>
-        </p:txBody>
-      </p:sp>
-      <p:sp>
-        <p:nvSpPr>
-          <p:cNvPr id="7" name="Text 5"/>
-          <p:cNvSpPr txBox="1"/>
-          <p:nvPr/>
-        </p:nvSpPr>
-        <p:spPr>
-          <a:xfrm>
-            <a:off x="685800" y="3154680"/>
-            <a:ext cx="2651760" cy="457200"/>
-          </a:xfrm>
-          <a:prstGeom prst="rect">
-            <a:avLst/>
-          </a:prstGeom>
-          <a:noFill/>
-          <a:ln/>
-        </p:spPr>
-        <p:txBody>
-          <a:bodyPr wrap="square" lIns="0" tIns="0" rIns="0" bIns="0" rtlCol="0" anchor="ctr"/>
-          <a:lstStyle/>
-          <a:p>
-            <a:pPr indent="0" marL="0">
-              <a:buNone/>
-            </a:pPr>
-            <a:r>
-              <a:rPr lang="en-US" sz="1200" dirty="0">
-                <a:solidFill>
-                  <a:schemeClr val="accent6"/>
-                </a:solidFill>
-              </a:rPr>
-              <a:t>orders; 17 came in automatically through flows</a:t>
-            </a:r>
-            <a:endParaRPr lang="en-US" sz="1200" dirty="0"/>
-          </a:p>
-        </p:txBody>
-      </p:sp>
       <p:graphicFrame>
         <p:nvGraphicFramePr>
-          <p:cNvPr id="8" name="Sales by program chart" descr=""/>
+          <p:cNvPr id="3" name="Purchases chart" descr=""/>
           <p:cNvGraphicFramePr/>
           <p:nvPr/>
         </p:nvGraphicFramePr>
         <p:xfrm>
-          <a:off x="3840480" y="960120"/>
-          <a:ext cx="4846320" cy="2743200"/>
+          <a:off x="457200" y="960120"/>
+          <a:ext cx="4206240" cy="3429000"/>
         </p:xfrm>
         <a:graphic xmlns:a="http://schemas.openxmlformats.org/drawingml/2006/main">
           <a:graphicData uri="http://schemas.openxmlformats.org/drawingml/2006/chart">
@@ -6705,14 +7451,14 @@
       </p:graphicFrame>
       <p:sp>
         <p:nvSpPr>
-          <p:cNvPr id="9" name="Text 6"/>
+          <p:cNvPr id="4" name="Text 1"/>
           <p:cNvSpPr txBox="1"/>
           <p:nvPr/>
         </p:nvSpPr>
         <p:spPr>
           <a:xfrm>
-            <a:off x="3931920" y="3749040"/>
-            <a:ext cx="4754880" cy="548640"/>
+            <a:off x="4937760" y="1005840"/>
+            <a:ext cx="3749040" cy="320040"/>
           </a:xfrm>
           <a:prstGeom prst="rect">
             <a:avLst/>
@@ -6721,27 +7467,203 @@
           <a:ln/>
         </p:spPr>
         <p:txBody>
-          <a:bodyPr wrap="square" lIns="0" tIns="0" rIns="0" bIns="0" rtlCol="0" anchor="t"/>
+          <a:bodyPr wrap="square" lIns="0" tIns="0" rIns="0" bIns="0" rtlCol="0" anchor="ctr"/>
           <a:lstStyle/>
           <a:p>
             <a:pPr indent="0" marL="0">
               <a:buNone/>
             </a:pPr>
             <a:r>
+              <a:rPr lang="en-US" sz="1500" b="1" dirty="0">
+                <a:solidFill>
+                  <a:schemeClr val="accent2"/>
+                </a:solidFill>
+                <a:latin typeface="Cambria" pitchFamily="34" charset="0"/>
+                <a:ea typeface="Cambria" pitchFamily="34" charset="-122"/>
+                <a:cs typeface="Cambria" pitchFamily="34" charset="-120"/>
+              </a:rPr>
+              <a:t>What's working</a:t>
+            </a:r>
+            <a:endParaRPr lang="en-US" sz="1500" dirty="0"/>
+          </a:p>
+        </p:txBody>
+      </p:sp>
+      <p:sp>
+        <p:nvSpPr>
+          <p:cNvPr id="5" name="Text 2"/>
+          <p:cNvSpPr txBox="1"/>
+          <p:nvPr/>
+        </p:nvSpPr>
+        <p:spPr>
+          <a:xfrm>
+            <a:off x="4937760" y="1371600"/>
+            <a:ext cx="3749040" cy="1152144"/>
+          </a:xfrm>
+          <a:prstGeom prst="rect">
+            <a:avLst/>
+          </a:prstGeom>
+          <a:noFill/>
+          <a:ln/>
+        </p:spPr>
+        <p:txBody>
+          <a:bodyPr wrap="square" lIns="0" tIns="0" rIns="0" bIns="0" rtlCol="0" anchor="t"/>
+          <a:lstStyle/>
+          <a:p>
+            <a:pPr marL="342900" indent="-342900">
+              <a:spcAft>
+                <a:spcPts val="400"/>
+              </a:spcAft>
+              <a:buSzPct val="100000"/>
+              <a:buChar char="•"/>
+            </a:pPr>
+            <a:r>
               <a:rPr lang="en-US" sz="1200" dirty="0">
                 <a:solidFill>
                   <a:schemeClr val="tx1"/>
                 </a:solidFill>
               </a:rPr>
-              <a:t>Game Day had a 60% open rate. The Subscribe &amp; Save and Second Order flows have been live since Oct 7.</a:t>
+              <a:t>Ayoba new customers: $26 per purchase, 1.6x return</a:t>
             </a:r>
             <a:endParaRPr lang="en-US" sz="1200" dirty="0"/>
           </a:p>
+          <a:p>
+            <a:pPr marL="342900" indent="-342900">
+              <a:spcAft>
+                <a:spcPts val="400"/>
+              </a:spcAft>
+              <a:buSzPct val="100000"/>
+              <a:buChar char="•"/>
+            </a:pPr>
+            <a:r>
+              <a:rPr lang="en-US" sz="1200" dirty="0">
+                <a:solidFill>
+                  <a:schemeClr val="tx1"/>
+                </a:solidFill>
+              </a:rPr>
+              <a:t>Brooklyn dynamic retargeting: $26 per purchase, 2.9x return</a:t>
+            </a:r>
+            <a:endParaRPr lang="en-US" sz="1200" dirty="0"/>
+          </a:p>
+          <a:p>
+            <a:pPr marL="342900" indent="-342900">
+              <a:spcAft>
+                <a:spcPts val="400"/>
+              </a:spcAft>
+              <a:buSzPct val="100000"/>
+              <a:buChar char="•"/>
+            </a:pPr>
+            <a:r>
+              <a:rPr lang="en-US" sz="1200" dirty="0">
+                <a:solidFill>
+                  <a:schemeClr val="tx1"/>
+                </a:solidFill>
+              </a:rPr>
+              <a:t>Beg &amp; Barker dynamic retargeting: 3.1x return</a:t>
+            </a:r>
+            <a:endParaRPr lang="en-US" sz="1200" dirty="0"/>
+          </a:p>
         </p:txBody>
       </p:sp>
       <p:sp>
         <p:nvSpPr>
-          <p:cNvPr id="10" name="Text 7"/>
+          <p:cNvPr id="6" name="Text 3"/>
+          <p:cNvSpPr txBox="1"/>
+          <p:nvPr/>
+        </p:nvSpPr>
+        <p:spPr>
+          <a:xfrm>
+            <a:off x="4937760" y="2697480"/>
+            <a:ext cx="3749040" cy="320040"/>
+          </a:xfrm>
+          <a:prstGeom prst="rect">
+            <a:avLst/>
+          </a:prstGeom>
+          <a:noFill/>
+          <a:ln/>
+        </p:spPr>
+        <p:txBody>
+          <a:bodyPr wrap="square" lIns="0" tIns="0" rIns="0" bIns="0" rtlCol="0" anchor="ctr"/>
+          <a:lstStyle/>
+          <a:p>
+            <a:pPr indent="0" marL="0">
+              <a:buNone/>
+            </a:pPr>
+            <a:r>
+              <a:rPr lang="en-US" sz="1500" b="1" dirty="0">
+                <a:solidFill>
+                  <a:schemeClr val="accent1"/>
+                </a:solidFill>
+                <a:latin typeface="Cambria" pitchFamily="34" charset="0"/>
+                <a:ea typeface="Cambria" pitchFamily="34" charset="-122"/>
+                <a:cs typeface="Cambria" pitchFamily="34" charset="-120"/>
+              </a:rPr>
+              <a:t>What we're fixing</a:t>
+            </a:r>
+            <a:endParaRPr lang="en-US" sz="1500" dirty="0"/>
+          </a:p>
+        </p:txBody>
+      </p:sp>
+      <p:sp>
+        <p:nvSpPr>
+          <p:cNvPr id="7" name="Text 4"/>
+          <p:cNvSpPr txBox="1"/>
+          <p:nvPr/>
+        </p:nvSpPr>
+        <p:spPr>
+          <a:xfrm>
+            <a:off x="4937760" y="3063240"/>
+            <a:ext cx="3749040" cy="768096"/>
+          </a:xfrm>
+          <a:prstGeom prst="rect">
+            <a:avLst/>
+          </a:prstGeom>
+          <a:noFill/>
+          <a:ln/>
+        </p:spPr>
+        <p:txBody>
+          <a:bodyPr wrap="square" lIns="0" tIns="0" rIns="0" bIns="0" rtlCol="0" anchor="t"/>
+          <a:lstStyle/>
+          <a:p>
+            <a:pPr marL="342900" indent="-342900">
+              <a:spcAft>
+                <a:spcPts val="400"/>
+              </a:spcAft>
+              <a:buSzPct val="100000"/>
+              <a:buChar char="•"/>
+            </a:pPr>
+            <a:r>
+              <a:rPr lang="en-US" sz="1200" dirty="0">
+                <a:solidFill>
+                  <a:schemeClr val="tx1"/>
+                </a:solidFill>
+              </a:rPr>
+              <a:t>Brooklyn new customers: $170 per purchase → budget trimmed on Oct 13</a:t>
+            </a:r>
+            <a:endParaRPr lang="en-US" sz="1200" dirty="0"/>
+          </a:p>
+          <a:p>
+            <a:pPr marL="342900" indent="-342900">
+              <a:spcAft>
+                <a:spcPts val="400"/>
+              </a:spcAft>
+              <a:buSzPct val="100000"/>
+              <a:buChar char="•"/>
+            </a:pPr>
+            <a:r>
+              <a:rPr lang="en-US" sz="1200" dirty="0">
+                <a:solidFill>
+                  <a:schemeClr val="tx1"/>
+                </a:solidFill>
+              </a:rPr>
+              <a:t>New retargeting (since Oct 10) is still learning; budget raised for Ayoba and Beg &amp; Barker</a:t>
+            </a:r>
+            <a:endParaRPr lang="en-US" sz="1200" dirty="0"/>
+          </a:p>
+        </p:txBody>
+      </p:sp>
+      <p:sp>
+        <p:nvSpPr>
+          <p:cNvPr id="8" name="Text 5"/>
           <p:cNvSpPr txBox="1"/>
           <p:nvPr/>
         </p:nvSpPr>
@@ -6769,7 +7691,7 @@
                   <a:schemeClr val="accent4"/>
                 </a:solidFill>
               </a:rPr>
-              <a:t>Source: Klaviyo (Brooklyn Biltong), platform-attributed orders.</a:t>
+              <a:t>Source: Meta Ads Manager, platform-attributed purchases and return. Excludes Google Ads and total store sales (see dashboards).</a:t>
             </a:r>
             <a:endParaRPr lang="en-US" sz="900" dirty="0"/>
           </a:p>
@@ -6880,6 +7802,391 @@
                 <a:ea typeface="Cambria" pitchFamily="34" charset="-122"/>
                 <a:cs typeface="Cambria" pitchFamily="34" charset="-120"/>
               </a:rPr>
+              <a:t>Brooklyn: email and SMS are driving repeat sales</a:t>
+            </a:r>
+            <a:endParaRPr lang="en-US" sz="2600" dirty="0"/>
+          </a:p>
+        </p:txBody>
+      </p:sp>
+      <p:sp>
+        <p:nvSpPr>
+          <p:cNvPr id="3" name="Retention stat panel"/>
+          <p:cNvSpPr/>
+          <p:nvPr/>
+        </p:nvSpPr>
+        <p:spPr>
+          <a:xfrm>
+            <a:off x="457200" y="1005840"/>
+            <a:ext cx="3108960" cy="3291840"/>
+          </a:xfrm>
+          <a:prstGeom prst="roundRect">
+            <a:avLst>
+              <a:gd name="adj" fmla="val 2353"/>
+            </a:avLst>
+          </a:prstGeom>
+          <a:solidFill>
+            <a:schemeClr val="tx1"/>
+          </a:solidFill>
+          <a:ln/>
+        </p:spPr>
+      </p:sp>
+      <p:sp>
+        <p:nvSpPr>
+          <p:cNvPr id="4" name="Text 2"/>
+          <p:cNvSpPr txBox="1"/>
+          <p:nvPr/>
+        </p:nvSpPr>
+        <p:spPr>
+          <a:xfrm>
+            <a:off x="685800" y="1188720"/>
+            <a:ext cx="2651760" cy="685800"/>
+          </a:xfrm>
+          <a:prstGeom prst="rect">
+            <a:avLst/>
+          </a:prstGeom>
+          <a:noFill/>
+          <a:ln/>
+        </p:spPr>
+        <p:txBody>
+          <a:bodyPr wrap="square" lIns="0" tIns="0" rIns="0" bIns="0" rtlCol="0" anchor="ctr"/>
+          <a:lstStyle/>
+          <a:p>
+            <a:pPr indent="0" marL="0">
+              <a:buNone/>
+            </a:pPr>
+            <a:r>
+              <a:rPr lang="en-US" sz="4000" b="1" dirty="0">
+                <a:solidFill>
+                  <a:schemeClr val="bg1"/>
+                </a:solidFill>
+                <a:latin typeface="Cambria" pitchFamily="34" charset="0"/>
+                <a:ea typeface="Cambria" pitchFamily="34" charset="-122"/>
+                <a:cs typeface="Cambria" pitchFamily="34" charset="-120"/>
+              </a:rPr>
+              <a:t>$2,074</a:t>
+            </a:r>
+            <a:endParaRPr lang="en-US" sz="4000" dirty="0"/>
+          </a:p>
+        </p:txBody>
+      </p:sp>
+      <p:sp>
+        <p:nvSpPr>
+          <p:cNvPr id="5" name="Text 3"/>
+          <p:cNvSpPr txBox="1"/>
+          <p:nvPr/>
+        </p:nvSpPr>
+        <p:spPr>
+          <a:xfrm>
+            <a:off x="685800" y="1874520"/>
+            <a:ext cx="2651760" cy="457200"/>
+          </a:xfrm>
+          <a:prstGeom prst="rect">
+            <a:avLst/>
+          </a:prstGeom>
+          <a:noFill/>
+          <a:ln/>
+        </p:spPr>
+        <p:txBody>
+          <a:bodyPr wrap="square" lIns="0" tIns="0" rIns="0" bIns="0" rtlCol="0" anchor="ctr"/>
+          <a:lstStyle/>
+          <a:p>
+            <a:pPr indent="0" marL="0">
+              <a:buNone/>
+            </a:pPr>
+            <a:r>
+              <a:rPr lang="en-US" sz="1200" dirty="0">
+                <a:solidFill>
+                  <a:schemeClr val="accent6"/>
+                </a:solidFill>
+              </a:rPr>
+              <a:t>in email and SMS-attributed sales,</a:t>
+            </a:r>
+            <a:endParaRPr lang="en-US" sz="1200" dirty="0"/>
+          </a:p>
+          <a:p>
+            <a:pPr indent="0" marL="0">
+              <a:buNone/>
+            </a:pPr>
+            <a:r>
+              <a:rPr lang="en-US" sz="1200" dirty="0">
+                <a:solidFill>
+                  <a:schemeClr val="accent6"/>
+                </a:solidFill>
+              </a:rPr>
+              <a:t>Oct 1–14</a:t>
+            </a:r>
+            <a:endParaRPr lang="en-US" sz="1200" dirty="0"/>
+          </a:p>
+        </p:txBody>
+      </p:sp>
+      <p:sp>
+        <p:nvSpPr>
+          <p:cNvPr id="6" name="Text 4"/>
+          <p:cNvSpPr txBox="1"/>
+          <p:nvPr/>
+        </p:nvSpPr>
+        <p:spPr>
+          <a:xfrm>
+            <a:off x="685800" y="2468880"/>
+            <a:ext cx="2651760" cy="685800"/>
+          </a:xfrm>
+          <a:prstGeom prst="rect">
+            <a:avLst/>
+          </a:prstGeom>
+          <a:noFill/>
+          <a:ln/>
+        </p:spPr>
+        <p:txBody>
+          <a:bodyPr wrap="square" lIns="0" tIns="0" rIns="0" bIns="0" rtlCol="0" anchor="ctr"/>
+          <a:lstStyle/>
+          <a:p>
+            <a:pPr indent="0" marL="0">
+              <a:buNone/>
+            </a:pPr>
+            <a:r>
+              <a:rPr lang="en-US" sz="4000" b="1" dirty="0">
+                <a:solidFill>
+                  <a:schemeClr val="bg1"/>
+                </a:solidFill>
+                <a:latin typeface="Cambria" pitchFamily="34" charset="0"/>
+                <a:ea typeface="Cambria" pitchFamily="34" charset="-122"/>
+                <a:cs typeface="Cambria" pitchFamily="34" charset="-120"/>
+              </a:rPr>
+              <a:t>31</a:t>
+            </a:r>
+            <a:endParaRPr lang="en-US" sz="4000" dirty="0"/>
+          </a:p>
+        </p:txBody>
+      </p:sp>
+      <p:sp>
+        <p:nvSpPr>
+          <p:cNvPr id="7" name="Text 5"/>
+          <p:cNvSpPr txBox="1"/>
+          <p:nvPr/>
+        </p:nvSpPr>
+        <p:spPr>
+          <a:xfrm>
+            <a:off x="685800" y="3154680"/>
+            <a:ext cx="2651760" cy="457200"/>
+          </a:xfrm>
+          <a:prstGeom prst="rect">
+            <a:avLst/>
+          </a:prstGeom>
+          <a:noFill/>
+          <a:ln/>
+        </p:spPr>
+        <p:txBody>
+          <a:bodyPr wrap="square" lIns="0" tIns="0" rIns="0" bIns="0" rtlCol="0" anchor="ctr"/>
+          <a:lstStyle/>
+          <a:p>
+            <a:pPr indent="0" marL="0">
+              <a:buNone/>
+            </a:pPr>
+            <a:r>
+              <a:rPr lang="en-US" sz="1200" dirty="0">
+                <a:solidFill>
+                  <a:schemeClr val="accent6"/>
+                </a:solidFill>
+              </a:rPr>
+              <a:t>orders; 17 came in automatically through flows</a:t>
+            </a:r>
+            <a:endParaRPr lang="en-US" sz="1200" dirty="0"/>
+          </a:p>
+        </p:txBody>
+      </p:sp>
+      <p:graphicFrame>
+        <p:nvGraphicFramePr>
+          <p:cNvPr id="8" name="Sales by program chart" descr=""/>
+          <p:cNvGraphicFramePr/>
+          <p:nvPr/>
+        </p:nvGraphicFramePr>
+        <p:xfrm>
+          <a:off x="3840480" y="960120"/>
+          <a:ext cx="4846320" cy="2743200"/>
+        </p:xfrm>
+        <a:graphic xmlns:a="http://schemas.openxmlformats.org/drawingml/2006/main">
+          <a:graphicData uri="http://schemas.openxmlformats.org/drawingml/2006/chart">
+            <c:chart xmlns:c="http://schemas.openxmlformats.org/drawingml/2006/chart" r:id="rId1"/>
+          </a:graphicData>
+        </a:graphic>
+      </p:graphicFrame>
+      <p:sp>
+        <p:nvSpPr>
+          <p:cNvPr id="9" name="Text 6"/>
+          <p:cNvSpPr txBox="1"/>
+          <p:nvPr/>
+        </p:nvSpPr>
+        <p:spPr>
+          <a:xfrm>
+            <a:off x="3931920" y="3749040"/>
+            <a:ext cx="4754880" cy="548640"/>
+          </a:xfrm>
+          <a:prstGeom prst="rect">
+            <a:avLst/>
+          </a:prstGeom>
+          <a:noFill/>
+          <a:ln/>
+        </p:spPr>
+        <p:txBody>
+          <a:bodyPr wrap="square" lIns="0" tIns="0" rIns="0" bIns="0" rtlCol="0" anchor="t"/>
+          <a:lstStyle/>
+          <a:p>
+            <a:pPr indent="0" marL="0">
+              <a:buNone/>
+            </a:pPr>
+            <a:r>
+              <a:rPr lang="en-US" sz="1200" dirty="0">
+                <a:solidFill>
+                  <a:schemeClr val="tx1"/>
+                </a:solidFill>
+              </a:rPr>
+              <a:t>Game Day had a 60% open rate. The Subscribe &amp; Save and Second Order flows have been live since Oct 7.</a:t>
+            </a:r>
+            <a:endParaRPr lang="en-US" sz="1200" dirty="0"/>
+          </a:p>
+        </p:txBody>
+      </p:sp>
+      <p:sp>
+        <p:nvSpPr>
+          <p:cNvPr id="10" name="Text 7"/>
+          <p:cNvSpPr txBox="1"/>
+          <p:nvPr/>
+        </p:nvSpPr>
+        <p:spPr>
+          <a:xfrm>
+            <a:off x="457200" y="4434840"/>
+            <a:ext cx="8229600" cy="274320"/>
+          </a:xfrm>
+          <a:prstGeom prst="rect">
+            <a:avLst/>
+          </a:prstGeom>
+          <a:noFill/>
+          <a:ln/>
+        </p:spPr>
+        <p:txBody>
+          <a:bodyPr wrap="square" lIns="0" tIns="0" rIns="0" bIns="0" rtlCol="0" anchor="ctr"/>
+          <a:lstStyle/>
+          <a:p>
+            <a:pPr indent="0" marL="0">
+              <a:buNone/>
+            </a:pPr>
+            <a:r>
+              <a:rPr lang="en-US" sz="900" i="1" dirty="0">
+                <a:solidFill>
+                  <a:schemeClr val="accent4"/>
+                </a:solidFill>
+              </a:rPr>
+              <a:t>Source: Klaviyo (Brooklyn Biltong), platform-attributed orders.</a:t>
+            </a:r>
+            <a:endParaRPr lang="en-US" sz="900" dirty="0"/>
+          </a:p>
+        </p:txBody>
+      </p:sp>
+      <p:sp>
+        <p:nvSpPr>
+          <p:cNvPr id="25" name="Slide Number Placeholder 0"/>
+          <p:cNvSpPr>
+            <a:spLocks noGrp="1"/>
+          </p:cNvSpPr>
+          <p:nvPr>
+            <p:ph type="sldNum" sz="quarter" idx="4294967295"/>
+          </p:nvPr>
+        </p:nvSpPr>
+        <p:spPr>
+          <a:xfrm>
+            <a:off x="8321040" y="4800600"/>
+            <a:ext cx="365760" cy="228600"/>
+          </a:xfrm>
+          <a:prstGeom prst="rect">
+            <a:avLst/>
+          </a:prstGeom>
+          <a:extLst>
+            <a:ext uri="{C572A759-6A51-4108-AA02-DFA0A04FC94B}">
+              <ma14:wrappingTextBoxFlag xmlns:ma14="http://schemas.microsoft.com/office/mac/drawingml/2011/main" val="0"/>
+            </a:ext>
+          </a:extLst>
+        </p:spPr>
+        <p:txBody>
+          <a:bodyPr/>
+          <a:lstStyle>
+            <a:lvl1pPr>
+              <a:defRPr sz="900">
+                <a:solidFill>
+                  <a:schemeClr val="accent4"/>
+                </a:solidFill>
+              </a:defRPr>
+            </a:lvl1pPr>
+          </a:lstStyle>
+          <a:p>
+            <a:pPr algn="r"/>
+            <a:fld id="{F7021451-1387-4CA6-816F-3879F97B5CBC}" type="slidenum">
+              <a:rPr b="0" lang="en-US"/>
+              <a:t>6</a:t>
+            </a:fld>
+            <a:endParaRPr lang="en-US"/>
+          </a:p>
+        </p:txBody>
+      </p:sp>
+    </p:spTree>
+  </p:cSld>
+  <p:clrMapOvr>
+    <a:masterClrMapping/>
+  </p:clrMapOvr>
+</p:sld>
+</file>
+
+<file path=ppt/slides/slide7.xml><?xml version="1.0" encoding="utf-8"?>
+<p:sld xmlns:a="http://schemas.openxmlformats.org/drawingml/2006/main" xmlns:r="http://schemas.openxmlformats.org/officeDocument/2006/relationships" xmlns:p="http://schemas.openxmlformats.org/presentationml/2006/main">
+  <p:cSld name="Slide 7">
+    <p:spTree>
+      <p:nvGrpSpPr>
+        <p:cNvPr id="1" name=""/>
+        <p:cNvGrpSpPr/>
+        <p:nvPr/>
+      </p:nvGrpSpPr>
+      <p:grpSpPr>
+        <a:xfrm>
+          <a:off x="0" y="0"/>
+          <a:ext cx="0" cy="0"/>
+          <a:chOff x="0" y="0"/>
+          <a:chExt cx="0" cy="0"/>
+        </a:xfrm>
+      </p:grpSpPr>
+      <p:sp>
+        <p:nvSpPr>
+          <p:cNvPr id="2" name="Text 0"/>
+          <p:cNvSpPr/>
+          <p:nvPr>
+            <p:ph idx="100" type="title" hasCustomPrompt="1"/>
+          </p:nvPr>
+        </p:nvSpPr>
+        <p:spPr>
+          <a:xfrm>
+            <a:off x="457200" y="274320"/>
+            <a:ext cx="8229600" cy="594360"/>
+          </a:xfrm>
+          <a:prstGeom prst="rect">
+            <a:avLst/>
+          </a:prstGeom>
+          <a:noFill/>
+          <a:ln/>
+        </p:spPr>
+        <p:txBody>
+          <a:bodyPr wrap="square" lIns="0" tIns="0" rIns="0" bIns="0" rtlCol="0" anchor="ctr"/>
+          <a:lstStyle/>
+          <a:p>
+            <a:pPr algn="l" indent="0" marL="0">
+              <a:buNone/>
+            </a:pPr>
+            <a:r>
+              <a:rPr lang="en-US" sz="2600" b="1" dirty="0">
+                <a:solidFill>
+                  <a:schemeClr val="tx1"/>
+                </a:solidFill>
+                <a:latin typeface="Cambria" pitchFamily="34" charset="0"/>
+                <a:ea typeface="Cambria" pitchFamily="34" charset="-122"/>
+                <a:cs typeface="Cambria" pitchFamily="34" charset="-120"/>
+              </a:rPr>
               <a:t>Next two weeks</a:t>
             </a:r>
             <a:endParaRPr lang="en-US" sz="2600" dirty="0"/>
@@ -7560,6 +8867,21 @@
                   <a:schemeClr val="tx1"/>
                 </a:solidFill>
               </a:rPr>
+              <a:t>Plan to restore email volume: ~14K sends a week today vs. ~23K in August–September</a:t>
+            </a:r>
+            <a:endParaRPr lang="en-US" sz="1200" dirty="0"/>
+          </a:p>
+          <a:p>
+            <a:pPr marL="342900" indent="-342900">
+              <a:buSzPct val="100000"/>
+              <a:buChar char="•"/>
+            </a:pPr>
+            <a:r>
+              <a:rPr lang="en-US" sz="1200" dirty="0">
+                <a:solidFill>
+                  <a:schemeClr val="tx1"/>
+                </a:solidFill>
+              </a:rPr>
               <a:t>Fast Sale results vs. September's promotional week</a:t>
             </a:r>
             <a:endParaRPr lang="en-US" sz="1200" dirty="0"/>
@@ -7605,7 +8927,7 @@
             <a:pPr algn="r"/>
             <a:fld id="{F7021451-1387-4CA6-816F-3879F97B5CBC}" type="slidenum">
               <a:rPr b="0" lang="en-US"/>
-              <a:t>6</a:t>
+              <a:t>7</a:t>
             </a:fld>
             <a:endParaRPr lang="en-US"/>
           </a:p>

</xml_diff>

<commit_message>
Reframe CEO deck next steps as action plan with one-week follow-up
Co-Authored-By: Claude Opus 5.5 <noreply@anthropic.com>
Claude-Session: https://claude.ai/code/session_01QGMjcfWM6zwQECSVCibDW3
</commit_message>
<xml_diff>
--- a/status_ceo/Stormberg_Status_CEO_Oct2026_EN.pptx
+++ b/status_ceo/Stormberg_Status_CEO_Oct2026_EN.pptx
@@ -113,21 +113,21 @@
   <p:extLst>
     <p:ext uri="{521415D9-36F7-43E2-AB2F-B90AF26B5E84}">
       <p14:sectionLst xmlns:p14="http://schemas.microsoft.com/office/powerpoint/2010/main">
-        <p14:section name="Summary" id="{49eee990-77be-4823-f4c8-397520ab78ab}">
+        <p14:section name="Summary" id="{3b3c418f-a539-8205-1f21-ec47a0773fa8}">
           <p14:sldIdLst>
             <p14:sldId id="256"/>
             <p14:sldId id="257"/>
             <p14:sldId id="258"/>
           </p14:sldIdLst>
         </p14:section>
-        <p14:section name="Progress" id="{0cca0d4a-b40a-4843-8a8e-ebf1d2940598}">
+        <p14:section name="Progress" id="{550a7bf0-6b17-fed7-4732-7561b82689aa}">
           <p14:sldIdLst>
             <p14:sldId id="259"/>
             <p14:sldId id="260"/>
             <p14:sldId id="261"/>
           </p14:sldIdLst>
         </p14:section>
-        <p14:section name="Next steps" id="{544b7951-04fe-846f-3628-73b8303ed710}">
+        <p14:section name="Next steps" id="{3fe92e93-6554-2452-bfbd-ff4ab6d09887}">
           <p14:sldIdLst>
             <p14:sldId id="262"/>
           </p14:sldIdLst>
@@ -8187,7 +8187,7 @@
                 <a:ea typeface="Cambria" pitchFamily="34" charset="-122"/>
                 <a:cs typeface="Cambria" pitchFamily="34" charset="-120"/>
               </a:rPr>
-              <a:t>Next two weeks</a:t>
+              <a:t>What we'll do this week</a:t>
             </a:r>
             <a:endParaRPr lang="en-US" sz="2600" dirty="0"/>
           </a:p>
@@ -8195,37 +8195,36 @@
       </p:sp>
       <p:sp>
         <p:nvSpPr>
-          <p:cNvPr id="3" name="Timeline line"/>
+          <p:cNvPr id="3" name="Plan card 1"/>
           <p:cNvSpPr/>
           <p:nvPr/>
         </p:nvSpPr>
         <p:spPr>
           <a:xfrm>
-            <a:off x="777240" y="1463040"/>
-            <a:ext cx="7589520" cy="0"/>
+            <a:off x="457200" y="1005840"/>
+            <a:ext cx="2651760" cy="2377440"/>
           </a:xfrm>
-          <a:prstGeom prst="line">
-            <a:avLst/>
+          <a:prstGeom prst="roundRect">
+            <a:avLst>
+              <a:gd name="adj" fmla="val 3077"/>
+            </a:avLst>
           </a:prstGeom>
-          <a:noFill/>
-          <a:ln w="25400">
-            <a:solidFill>
-              <a:schemeClr val="accent6"/>
-            </a:solidFill>
-            <a:prstDash val="solid"/>
-          </a:ln>
+          <a:solidFill>
+            <a:schemeClr val="bg2"/>
+          </a:solidFill>
+          <a:ln/>
         </p:spPr>
       </p:sp>
       <p:sp>
         <p:nvSpPr>
-          <p:cNvPr id="4" name="Timeline dot 1"/>
+          <p:cNvPr id="4" name="Plan dot 1"/>
           <p:cNvSpPr/>
           <p:nvPr/>
         </p:nvSpPr>
         <p:spPr>
           <a:xfrm>
-            <a:off x="594360" y="1280160"/>
-            <a:ext cx="365760" cy="365760"/>
+            <a:off x="640080" y="1188720"/>
+            <a:ext cx="274320" cy="274320"/>
           </a:xfrm>
           <a:prstGeom prst="ellipse">
             <a:avLst/>
@@ -8233,12 +8232,7 @@
           <a:solidFill>
             <a:schemeClr val="accent1"/>
           </a:solidFill>
-          <a:ln w="25400">
-            <a:solidFill>
-              <a:schemeClr val="bg1"/>
-            </a:solidFill>
-            <a:prstDash val="solid"/>
-          </a:ln>
+          <a:ln/>
         </p:spPr>
       </p:sp>
       <p:sp>
@@ -8249,8 +8243,8 @@
         </p:nvSpPr>
         <p:spPr>
           <a:xfrm>
-            <a:off x="457200" y="1783080"/>
-            <a:ext cx="2011680" cy="274320"/>
+            <a:off x="1005840" y="1143000"/>
+            <a:ext cx="1965960" cy="365760"/>
           </a:xfrm>
           <a:prstGeom prst="rect">
             <a:avLst/>
@@ -8266,14 +8260,17 @@
               <a:buNone/>
             </a:pPr>
             <a:r>
-              <a:rPr lang="en-US" sz="1200" b="1" dirty="0">
-                <a:solidFill>
-                  <a:schemeClr val="accent1"/>
-                </a:solidFill>
+              <a:rPr lang="en-US" sz="1500" b="1" dirty="0">
+                <a:solidFill>
+                  <a:schemeClr val="tx1"/>
+                </a:solidFill>
+                <a:latin typeface="Cambria" pitchFamily="34" charset="0"/>
+                <a:ea typeface="Cambria" pitchFamily="34" charset="-122"/>
+                <a:cs typeface="Cambria" pitchFamily="34" charset="-120"/>
               </a:rPr>
-              <a:t>Oct 15</a:t>
+              <a:t>Brooklyn Biltong</a:t>
             </a:r>
-            <a:endParaRPr lang="en-US" sz="1200" dirty="0"/>
+            <a:endParaRPr lang="en-US" sz="1500" dirty="0"/>
           </a:p>
         </p:txBody>
       </p:sp>
@@ -8285,8 +8282,126 @@
         </p:nvSpPr>
         <p:spPr>
           <a:xfrm>
-            <a:off x="457200" y="2057400"/>
-            <a:ext cx="1920240" cy="320040"/>
+            <a:off x="640080" y="1600200"/>
+            <a:ext cx="2331720" cy="1691640"/>
+          </a:xfrm>
+          <a:prstGeom prst="rect">
+            <a:avLst/>
+          </a:prstGeom>
+          <a:noFill/>
+          <a:ln/>
+        </p:spPr>
+        <p:txBody>
+          <a:bodyPr wrap="square" lIns="0" tIns="0" rIns="0" bIns="0" rtlCol="0" anchor="t"/>
+          <a:lstStyle/>
+          <a:p>
+            <a:pPr marL="342900" indent="-342900">
+              <a:spcAft>
+                <a:spcPts val="500"/>
+              </a:spcAft>
+              <a:buSzPct val="100000"/>
+              <a:buChar char="•"/>
+            </a:pPr>
+            <a:r>
+              <a:rPr lang="en-US" sz="1100" dirty="0">
+                <a:solidFill>
+                  <a:schemeClr val="tx1"/>
+                </a:solidFill>
+              </a:rPr>
+              <a:t>Fast Sale: VIP 20% and list 15% (Oct 15), reminder Oct 16, last call Oct 18</a:t>
+            </a:r>
+            <a:endParaRPr lang="en-US" sz="1100" dirty="0"/>
+          </a:p>
+          <a:p>
+            <a:pPr marL="342900" indent="-342900">
+              <a:spcAft>
+                <a:spcPts val="500"/>
+              </a:spcAft>
+              <a:buSzPct val="100000"/>
+              <a:buChar char="•"/>
+            </a:pPr>
+            <a:r>
+              <a:rPr lang="en-US" sz="1100" dirty="0">
+                <a:solidFill>
+                  <a:schemeClr val="tx1"/>
+                </a:solidFill>
+              </a:rPr>
+              <a:t>Scale dynamic retargeting and Smile; tune new-customer campaigns by cost per purchase</a:t>
+            </a:r>
+            <a:endParaRPr lang="en-US" sz="1100" dirty="0"/>
+          </a:p>
+          <a:p>
+            <a:pPr marL="342900" indent="-342900">
+              <a:spcAft>
+                <a:spcPts val="500"/>
+              </a:spcAft>
+              <a:buSzPct val="100000"/>
+              <a:buChar char="•"/>
+            </a:pPr>
+            <a:r>
+              <a:rPr lang="en-US" sz="1100" dirty="0">
+                <a:solidFill>
+                  <a:schemeClr val="tx1"/>
+                </a:solidFill>
+              </a:rPr>
+              <a:t>Restore email frequency and activate the Recurring → Subscription flow</a:t>
+            </a:r>
+            <a:endParaRPr lang="en-US" sz="1100" dirty="0"/>
+          </a:p>
+        </p:txBody>
+      </p:sp>
+      <p:sp>
+        <p:nvSpPr>
+          <p:cNvPr id="7" name="Plan card 2"/>
+          <p:cNvSpPr/>
+          <p:nvPr/>
+        </p:nvSpPr>
+        <p:spPr>
+          <a:xfrm>
+            <a:off x="3246120" y="1005840"/>
+            <a:ext cx="2651760" cy="2377440"/>
+          </a:xfrm>
+          <a:prstGeom prst="roundRect">
+            <a:avLst>
+              <a:gd name="adj" fmla="val 3077"/>
+            </a:avLst>
+          </a:prstGeom>
+          <a:solidFill>
+            <a:schemeClr val="bg2"/>
+          </a:solidFill>
+          <a:ln/>
+        </p:spPr>
+      </p:sp>
+      <p:sp>
+        <p:nvSpPr>
+          <p:cNvPr id="8" name="Plan dot 2"/>
+          <p:cNvSpPr/>
+          <p:nvPr/>
+        </p:nvSpPr>
+        <p:spPr>
+          <a:xfrm>
+            <a:off x="3429000" y="1188720"/>
+            <a:ext cx="274320" cy="274320"/>
+          </a:xfrm>
+          <a:prstGeom prst="ellipse">
+            <a:avLst/>
+          </a:prstGeom>
+          <a:solidFill>
+            <a:schemeClr val="tx2"/>
+          </a:solidFill>
+          <a:ln/>
+        </p:spPr>
+      </p:sp>
+      <p:sp>
+        <p:nvSpPr>
+          <p:cNvPr id="9" name="Text 7"/>
+          <p:cNvSpPr txBox="1"/>
+          <p:nvPr/>
+        </p:nvSpPr>
+        <p:spPr>
+          <a:xfrm>
+            <a:off x="3794760" y="1143000"/>
+            <a:ext cx="1965960" cy="365760"/>
           </a:xfrm>
           <a:prstGeom prst="rect">
             <a:avLst/>
@@ -8302,7 +8417,7 @@
               <a:buNone/>
             </a:pPr>
             <a:r>
-              <a:rPr lang="en-US" sz="1400" b="1" dirty="0">
+              <a:rPr lang="en-US" sz="1500" b="1" dirty="0">
                 <a:solidFill>
                   <a:schemeClr val="tx1"/>
                 </a:solidFill>
@@ -8310,22 +8425,22 @@
                 <a:ea typeface="Cambria" pitchFamily="34" charset="-122"/>
                 <a:cs typeface="Cambria" pitchFamily="34" charset="-120"/>
               </a:rPr>
-              <a:t>Brooklyn Fast Sale</a:t>
+              <a:t>Ayoba Foods</a:t>
             </a:r>
-            <a:endParaRPr lang="en-US" sz="1400" dirty="0"/>
+            <a:endParaRPr lang="en-US" sz="1500" dirty="0"/>
           </a:p>
         </p:txBody>
       </p:sp>
       <p:sp>
         <p:nvSpPr>
-          <p:cNvPr id="7" name="Text 5"/>
+          <p:cNvPr id="10" name="Text 8"/>
           <p:cNvSpPr txBox="1"/>
           <p:nvPr/>
         </p:nvSpPr>
         <p:spPr>
           <a:xfrm>
-            <a:off x="457200" y="2395728"/>
-            <a:ext cx="1874520" cy="822960"/>
+            <a:off x="3429000" y="1600200"/>
+            <a:ext cx="2331720" cy="1691640"/>
           </a:xfrm>
           <a:prstGeom prst="rect">
             <a:avLst/>
@@ -8337,8 +8452,12 @@
           <a:bodyPr wrap="square" lIns="0" tIns="0" rIns="0" bIns="0" rtlCol="0" anchor="t"/>
           <a:lstStyle/>
           <a:p>
-            <a:pPr indent="0" marL="0">
-              <a:buNone/>
+            <a:pPr marL="342900" indent="-342900">
+              <a:spcAft>
+                <a:spcPts val="500"/>
+              </a:spcAft>
+              <a:buSzPct val="100000"/>
+              <a:buChar char="•"/>
             </a:pPr>
             <a:r>
               <a:rPr lang="en-US" sz="1100" dirty="0">
@@ -8346,47 +8465,100 @@
                   <a:schemeClr val="tx1"/>
                 </a:solidFill>
               </a:rPr>
-              <a:t>VIP (2+ orders) 20%, rest of list 15%</a:t>
+              <a:t>Scale the new-customer campaign, the lowest cost per purchase in the portfolio</a:t>
             </a:r>
             <a:endParaRPr lang="en-US" sz="1100" dirty="0"/>
           </a:p>
+          <a:p>
+            <a:pPr marL="342900" indent="-342900">
+              <a:spcAft>
+                <a:spcPts val="500"/>
+              </a:spcAft>
+              <a:buSzPct val="100000"/>
+              <a:buChar char="•"/>
+            </a:pPr>
+            <a:r>
+              <a:rPr lang="en-US" sz="1100" dirty="0">
+                <a:solidFill>
+                  <a:schemeClr val="tx1"/>
+                </a:solidFill>
+              </a:rPr>
+              <a:t>Activate the retention flows so they run automatically</a:t>
+            </a:r>
+            <a:endParaRPr lang="en-US" sz="1100" dirty="0"/>
+          </a:p>
+          <a:p>
+            <a:pPr marL="342900" indent="-342900">
+              <a:spcAft>
+                <a:spcPts val="500"/>
+              </a:spcAft>
+              <a:buSzPct val="100000"/>
+              <a:buChar char="•"/>
+            </a:pPr>
+            <a:r>
+              <a:rPr lang="en-US" sz="1100" dirty="0">
+                <a:solidFill>
+                  <a:schemeClr val="tx1"/>
+                </a:solidFill>
+              </a:rPr>
+              <a:t>Campaigns: Spicy Taco Night, Droëwors Oktoberfest and Cabin Weekend</a:t>
+            </a:r>
+            <a:endParaRPr lang="en-US" sz="1100" dirty="0"/>
+          </a:p>
         </p:txBody>
       </p:sp>
       <p:sp>
         <p:nvSpPr>
-          <p:cNvPr id="8" name="Timeline dot 2"/>
+          <p:cNvPr id="11" name="Plan card 3"/>
           <p:cNvSpPr/>
           <p:nvPr/>
         </p:nvSpPr>
         <p:spPr>
           <a:xfrm>
-            <a:off x="2667305" y="1280160"/>
-            <a:ext cx="365760" cy="365760"/>
+            <a:off x="6035040" y="1005840"/>
+            <a:ext cx="2651760" cy="2377440"/>
+          </a:xfrm>
+          <a:prstGeom prst="roundRect">
+            <a:avLst>
+              <a:gd name="adj" fmla="val 3077"/>
+            </a:avLst>
+          </a:prstGeom>
+          <a:solidFill>
+            <a:schemeClr val="bg2"/>
+          </a:solidFill>
+          <a:ln/>
+        </p:spPr>
+      </p:sp>
+      <p:sp>
+        <p:nvSpPr>
+          <p:cNvPr id="12" name="Plan dot 3"/>
+          <p:cNvSpPr/>
+          <p:nvPr/>
+        </p:nvSpPr>
+        <p:spPr>
+          <a:xfrm>
+            <a:off x="6217920" y="1188720"/>
+            <a:ext cx="274320" cy="274320"/>
           </a:xfrm>
           <a:prstGeom prst="ellipse">
             <a:avLst/>
           </a:prstGeom>
           <a:solidFill>
-            <a:schemeClr val="accent1"/>
+            <a:schemeClr val="tx2"/>
           </a:solidFill>
-          <a:ln w="25400">
-            <a:solidFill>
-              <a:schemeClr val="bg1"/>
-            </a:solidFill>
-            <a:prstDash val="solid"/>
-          </a:ln>
+          <a:ln/>
         </p:spPr>
       </p:sp>
       <p:sp>
         <p:nvSpPr>
-          <p:cNvPr id="9" name="Text 7"/>
+          <p:cNvPr id="13" name="Text 11"/>
           <p:cNvSpPr txBox="1"/>
           <p:nvPr/>
         </p:nvSpPr>
         <p:spPr>
           <a:xfrm>
-            <a:off x="2530145" y="1783080"/>
-            <a:ext cx="2011680" cy="274320"/>
+            <a:off x="6583680" y="1143000"/>
+            <a:ext cx="1965960" cy="365760"/>
           </a:xfrm>
           <a:prstGeom prst="rect">
             <a:avLst/>
@@ -8402,43 +8574,7 @@
               <a:buNone/>
             </a:pPr>
             <a:r>
-              <a:rPr lang="en-US" sz="1200" b="1" dirty="0">
-                <a:solidFill>
-                  <a:schemeClr val="accent1"/>
-                </a:solidFill>
-              </a:rPr>
-              <a:t>Oct 16–18</a:t>
-            </a:r>
-            <a:endParaRPr lang="en-US" sz="1200" dirty="0"/>
-          </a:p>
-        </p:txBody>
-      </p:sp>
-      <p:sp>
-        <p:nvSpPr>
-          <p:cNvPr id="10" name="Text 8"/>
-          <p:cNvSpPr txBox="1"/>
-          <p:nvPr/>
-        </p:nvSpPr>
-        <p:spPr>
-          <a:xfrm>
-            <a:off x="2530145" y="2057400"/>
-            <a:ext cx="1920240" cy="320040"/>
-          </a:xfrm>
-          <a:prstGeom prst="rect">
-            <a:avLst/>
-          </a:prstGeom>
-          <a:noFill/>
-          <a:ln/>
-        </p:spPr>
-        <p:txBody>
-          <a:bodyPr wrap="square" lIns="0" tIns="0" rIns="0" bIns="0" rtlCol="0" anchor="ctr"/>
-          <a:lstStyle/>
-          <a:p>
-            <a:pPr indent="0" marL="0">
-              <a:buNone/>
-            </a:pPr>
-            <a:r>
-              <a:rPr lang="en-US" sz="1400" b="1" dirty="0">
+              <a:rPr lang="en-US" sz="1500" b="1" dirty="0">
                 <a:solidFill>
                   <a:schemeClr val="tx1"/>
                 </a:solidFill>
@@ -8446,22 +8582,22 @@
                 <a:ea typeface="Cambria" pitchFamily="34" charset="-122"/>
                 <a:cs typeface="Cambria" pitchFamily="34" charset="-120"/>
               </a:rPr>
-              <a:t>Reminder and last call</a:t>
+              <a:t>Beg &amp; Barker</a:t>
             </a:r>
-            <a:endParaRPr lang="en-US" sz="1400" dirty="0"/>
+            <a:endParaRPr lang="en-US" sz="1500" dirty="0"/>
           </a:p>
         </p:txBody>
       </p:sp>
       <p:sp>
         <p:nvSpPr>
-          <p:cNvPr id="11" name="Text 9"/>
+          <p:cNvPr id="14" name="Text 12"/>
           <p:cNvSpPr txBox="1"/>
           <p:nvPr/>
         </p:nvSpPr>
         <p:spPr>
           <a:xfrm>
-            <a:off x="2530145" y="2395728"/>
-            <a:ext cx="1874520" cy="822960"/>
+            <a:off x="6217920" y="1600200"/>
+            <a:ext cx="2331720" cy="1691640"/>
           </a:xfrm>
           <a:prstGeom prst="rect">
             <a:avLst/>
@@ -8473,8 +8609,12 @@
           <a:bodyPr wrap="square" lIns="0" tIns="0" rIns="0" bIns="0" rtlCol="0" anchor="t"/>
           <a:lstStyle/>
           <a:p>
-            <a:pPr indent="0" marL="0">
-              <a:buNone/>
+            <a:pPr marL="342900" indent="-342900">
+              <a:spcAft>
+                <a:spcPts val="500"/>
+              </a:spcAft>
+              <a:buSzPct val="100000"/>
+              <a:buChar char="•"/>
             </a:pPr>
             <a:r>
               <a:rPr lang="en-US" sz="1100" dirty="0">
@@ -8482,135 +8622,17 @@
                   <a:schemeClr val="tx1"/>
                 </a:solidFill>
               </a:rPr>
-              <a:t>Email to VIP and full list</a:t>
+              <a:t>Scale the new-customer campaign as it gathers data</a:t>
             </a:r>
             <a:endParaRPr lang="en-US" sz="1100" dirty="0"/>
           </a:p>
-        </p:txBody>
-      </p:sp>
-      <p:sp>
-        <p:nvSpPr>
-          <p:cNvPr id="12" name="Timeline dot 3"/>
-          <p:cNvSpPr/>
-          <p:nvPr/>
-        </p:nvSpPr>
-        <p:spPr>
-          <a:xfrm>
-            <a:off x="4740250" y="1280160"/>
-            <a:ext cx="365760" cy="365760"/>
-          </a:xfrm>
-          <a:prstGeom prst="ellipse">
-            <a:avLst/>
-          </a:prstGeom>
-          <a:solidFill>
-            <a:schemeClr val="tx2"/>
-          </a:solidFill>
-          <a:ln w="25400">
-            <a:solidFill>
-              <a:schemeClr val="bg1"/>
-            </a:solidFill>
-            <a:prstDash val="solid"/>
-          </a:ln>
-        </p:spPr>
-      </p:sp>
-      <p:sp>
-        <p:nvSpPr>
-          <p:cNvPr id="13" name="Text 11"/>
-          <p:cNvSpPr txBox="1"/>
-          <p:nvPr/>
-        </p:nvSpPr>
-        <p:spPr>
-          <a:xfrm>
-            <a:off x="4603090" y="1783080"/>
-            <a:ext cx="2011680" cy="274320"/>
-          </a:xfrm>
-          <a:prstGeom prst="rect">
-            <a:avLst/>
-          </a:prstGeom>
-          <a:noFill/>
-          <a:ln/>
-        </p:spPr>
-        <p:txBody>
-          <a:bodyPr wrap="square" lIns="0" tIns="0" rIns="0" bIns="0" rtlCol="0" anchor="ctr"/>
-          <a:lstStyle/>
-          <a:p>
-            <a:pPr indent="0" marL="0">
-              <a:buNone/>
-            </a:pPr>
-            <a:r>
-              <a:rPr lang="en-US" sz="1200" b="1" dirty="0">
-                <a:solidFill>
-                  <a:schemeClr val="tx2"/>
-                </a:solidFill>
-              </a:rPr>
-              <a:t>Week of Oct 20</a:t>
-            </a:r>
-            <a:endParaRPr lang="en-US" sz="1200" dirty="0"/>
-          </a:p>
-        </p:txBody>
-      </p:sp>
-      <p:sp>
-        <p:nvSpPr>
-          <p:cNvPr id="14" name="Text 12"/>
-          <p:cNvSpPr txBox="1"/>
-          <p:nvPr/>
-        </p:nvSpPr>
-        <p:spPr>
-          <a:xfrm>
-            <a:off x="4603090" y="2057400"/>
-            <a:ext cx="1920240" cy="320040"/>
-          </a:xfrm>
-          <a:prstGeom prst="rect">
-            <a:avLst/>
-          </a:prstGeom>
-          <a:noFill/>
-          <a:ln/>
-        </p:spPr>
-        <p:txBody>
-          <a:bodyPr wrap="square" lIns="0" tIns="0" rIns="0" bIns="0" rtlCol="0" anchor="ctr"/>
-          <a:lstStyle/>
-          <a:p>
-            <a:pPr indent="0" marL="0">
-              <a:buNone/>
-            </a:pPr>
-            <a:r>
-              <a:rPr lang="en-US" sz="1400" b="1" dirty="0">
-                <a:solidFill>
-                  <a:schemeClr val="tx1"/>
-                </a:solidFill>
-                <a:latin typeface="Cambria" pitchFamily="34" charset="0"/>
-                <a:ea typeface="Cambria" pitchFamily="34" charset="-122"/>
-                <a:cs typeface="Cambria" pitchFamily="34" charset="-120"/>
-              </a:rPr>
-              <a:t>Scale the winners</a:t>
-            </a:r>
-            <a:endParaRPr lang="en-US" sz="1400" dirty="0"/>
-          </a:p>
-        </p:txBody>
-      </p:sp>
-      <p:sp>
-        <p:nvSpPr>
-          <p:cNvPr id="15" name="Text 13"/>
-          <p:cNvSpPr txBox="1"/>
-          <p:nvPr/>
-        </p:nvSpPr>
-        <p:spPr>
-          <a:xfrm>
-            <a:off x="4603090" y="2395728"/>
-            <a:ext cx="1874520" cy="822960"/>
-          </a:xfrm>
-          <a:prstGeom prst="rect">
-            <a:avLst/>
-          </a:prstGeom>
-          <a:noFill/>
-          <a:ln/>
-        </p:spPr>
-        <p:txBody>
-          <a:bodyPr wrap="square" lIns="0" tIns="0" rIns="0" bIns="0" rtlCol="0" anchor="t"/>
-          <a:lstStyle/>
-          <a:p>
-            <a:pPr indent="0" marL="0">
-              <a:buNone/>
+          <a:p>
+            <a:pPr marL="342900" indent="-342900">
+              <a:spcAft>
+                <a:spcPts val="500"/>
+              </a:spcAft>
+              <a:buSzPct val="100000"/>
+              <a:buChar char="•"/>
             </a:pPr>
             <a:r>
               <a:rPr lang="en-US" sz="1100" dirty="0">
@@ -8618,135 +8640,17 @@
                   <a:schemeClr val="tx1"/>
                 </a:solidFill>
               </a:rPr>
-              <a:t>More budget to retargeting and Ayoba new customers; less to what's expensive</a:t>
+              <a:t>Launch the SMS Welcome Series and track the new BARK15 Welcome</a:t>
             </a:r>
             <a:endParaRPr lang="en-US" sz="1100" dirty="0"/>
           </a:p>
-        </p:txBody>
-      </p:sp>
-      <p:sp>
-        <p:nvSpPr>
-          <p:cNvPr id="16" name="Timeline dot 4"/>
-          <p:cNvSpPr/>
-          <p:nvPr/>
-        </p:nvSpPr>
-        <p:spPr>
-          <a:xfrm>
-            <a:off x="6813194" y="1280160"/>
-            <a:ext cx="365760" cy="365760"/>
-          </a:xfrm>
-          <a:prstGeom prst="ellipse">
-            <a:avLst/>
-          </a:prstGeom>
-          <a:solidFill>
-            <a:schemeClr val="tx2"/>
-          </a:solidFill>
-          <a:ln w="25400">
-            <a:solidFill>
-              <a:schemeClr val="bg1"/>
-            </a:solidFill>
-            <a:prstDash val="solid"/>
-          </a:ln>
-        </p:spPr>
-      </p:sp>
-      <p:sp>
-        <p:nvSpPr>
-          <p:cNvPr id="17" name="Text 15"/>
-          <p:cNvSpPr txBox="1"/>
-          <p:nvPr/>
-        </p:nvSpPr>
-        <p:spPr>
-          <a:xfrm>
-            <a:off x="6676034" y="1783080"/>
-            <a:ext cx="2011680" cy="274320"/>
-          </a:xfrm>
-          <a:prstGeom prst="rect">
-            <a:avLst/>
-          </a:prstGeom>
-          <a:noFill/>
-          <a:ln/>
-        </p:spPr>
-        <p:txBody>
-          <a:bodyPr wrap="square" lIns="0" tIns="0" rIns="0" bIns="0" rtlCol="0" anchor="ctr"/>
-          <a:lstStyle/>
-          <a:p>
-            <a:pPr indent="0" marL="0">
-              <a:buNone/>
-            </a:pPr>
-            <a:r>
-              <a:rPr lang="en-US" sz="1200" b="1" dirty="0">
-                <a:solidFill>
-                  <a:schemeClr val="tx2"/>
-                </a:solidFill>
-              </a:rPr>
-              <a:t>October</a:t>
-            </a:r>
-            <a:endParaRPr lang="en-US" sz="1200" dirty="0"/>
-          </a:p>
-        </p:txBody>
-      </p:sp>
-      <p:sp>
-        <p:nvSpPr>
-          <p:cNvPr id="18" name="Text 16"/>
-          <p:cNvSpPr txBox="1"/>
-          <p:nvPr/>
-        </p:nvSpPr>
-        <p:spPr>
-          <a:xfrm>
-            <a:off x="6676034" y="2057400"/>
-            <a:ext cx="1920240" cy="320040"/>
-          </a:xfrm>
-          <a:prstGeom prst="rect">
-            <a:avLst/>
-          </a:prstGeom>
-          <a:noFill/>
-          <a:ln/>
-        </p:spPr>
-        <p:txBody>
-          <a:bodyPr wrap="square" lIns="0" tIns="0" rIns="0" bIns="0" rtlCol="0" anchor="ctr"/>
-          <a:lstStyle/>
-          <a:p>
-            <a:pPr indent="0" marL="0">
-              <a:buNone/>
-            </a:pPr>
-            <a:r>
-              <a:rPr lang="en-US" sz="1400" b="1" dirty="0">
-                <a:solidFill>
-                  <a:schemeClr val="tx1"/>
-                </a:solidFill>
-                <a:latin typeface="Cambria" pitchFamily="34" charset="0"/>
-                <a:ea typeface="Cambria" pitchFamily="34" charset="-122"/>
-                <a:cs typeface="Cambria" pitchFamily="34" charset="-120"/>
-              </a:rPr>
-              <a:t>Retention</a:t>
-            </a:r>
-            <a:endParaRPr lang="en-US" sz="1400" dirty="0"/>
-          </a:p>
-        </p:txBody>
-      </p:sp>
-      <p:sp>
-        <p:nvSpPr>
-          <p:cNvPr id="19" name="Text 17"/>
-          <p:cNvSpPr txBox="1"/>
-          <p:nvPr/>
-        </p:nvSpPr>
-        <p:spPr>
-          <a:xfrm>
-            <a:off x="6676034" y="2395728"/>
-            <a:ext cx="1874520" cy="822960"/>
-          </a:xfrm>
-          <a:prstGeom prst="rect">
-            <a:avLst/>
-          </a:prstGeom>
-          <a:noFill/>
-          <a:ln/>
-        </p:spPr>
-        <p:txBody>
-          <a:bodyPr wrap="square" lIns="0" tIns="0" rIns="0" bIns="0" rtlCol="0" anchor="t"/>
-          <a:lstStyle/>
-          <a:p>
-            <a:pPr indent="0" marL="0">
-              <a:buNone/>
+          <a:p>
+            <a:pPr marL="342900" indent="-342900">
+              <a:spcAft>
+                <a:spcPts val="500"/>
+              </a:spcAft>
+              <a:buSzPct val="100000"/>
+              <a:buChar char="•"/>
             </a:pPr>
             <a:r>
               <a:rPr lang="en-US" sz="1100" dirty="0">
@@ -8754,7 +8658,7 @@
                   <a:schemeClr val="tx1"/>
                 </a:solidFill>
               </a:rPr>
-              <a:t>Recurring → Subscription (Brooklyn), SMS Welcome (Beg &amp; Barker), Ayoba flows</a:t>
+              <a:t>Sustain dynamic retargeting at its new budget</a:t>
             </a:r>
             <a:endParaRPr lang="en-US" sz="1100" dirty="0"/>
           </a:p>
@@ -8762,35 +8666,35 @@
       </p:sp>
       <p:sp>
         <p:nvSpPr>
-          <p:cNvPr id="20" name="Meeting asks panel"/>
+          <p:cNvPr id="15" name="Follow-up panel"/>
           <p:cNvSpPr/>
           <p:nvPr/>
         </p:nvSpPr>
         <p:spPr>
           <a:xfrm>
-            <a:off x="457200" y="3429000"/>
-            <a:ext cx="8229600" cy="1051560"/>
+            <a:off x="457200" y="3566160"/>
+            <a:ext cx="8229600" cy="960120"/>
           </a:xfrm>
           <a:prstGeom prst="roundRect">
             <a:avLst>
-              <a:gd name="adj" fmla="val 6957"/>
+              <a:gd name="adj" fmla="val 7619"/>
             </a:avLst>
           </a:prstGeom>
           <a:solidFill>
-            <a:schemeClr val="bg2"/>
+            <a:schemeClr val="tx1"/>
           </a:solidFill>
           <a:ln/>
         </p:spPr>
       </p:sp>
       <p:sp>
         <p:nvSpPr>
-          <p:cNvPr id="21" name="Text 19"/>
+          <p:cNvPr id="16" name="Text 14"/>
           <p:cNvSpPr txBox="1"/>
           <p:nvPr/>
         </p:nvSpPr>
         <p:spPr>
           <a:xfrm>
-            <a:off x="685800" y="3520440"/>
+            <a:off x="685800" y="3657600"/>
             <a:ext cx="7772400" cy="320040"/>
           </a:xfrm>
           <a:prstGeom prst="rect">
@@ -8807,30 +8711,30 @@
               <a:buNone/>
             </a:pPr>
             <a:r>
-              <a:rPr lang="en-US" sz="1400" b="1" dirty="0">
-                <a:solidFill>
-                  <a:schemeClr val="accent1"/>
+              <a:rPr lang="en-US" sz="1500" b="1" dirty="0">
+                <a:solidFill>
+                  <a:schemeClr val="bg1"/>
                 </a:solidFill>
                 <a:latin typeface="Cambria" pitchFamily="34" charset="0"/>
                 <a:ea typeface="Cambria" pitchFamily="34" charset="-122"/>
                 <a:cs typeface="Cambria" pitchFamily="34" charset="-120"/>
               </a:rPr>
-              <a:t>Proposed for Wednesday's meeting</a:t>
+              <a:t>Next follow-up: October 21</a:t>
             </a:r>
-            <a:endParaRPr lang="en-US" sz="1400" dirty="0"/>
+            <a:endParaRPr lang="en-US" sz="1500" dirty="0"/>
           </a:p>
         </p:txBody>
       </p:sp>
       <p:sp>
         <p:nvSpPr>
-          <p:cNvPr id="22" name="Text 20"/>
+          <p:cNvPr id="17" name="Text 15"/>
           <p:cNvSpPr txBox="1"/>
           <p:nvPr/>
         </p:nvSpPr>
         <p:spPr>
           <a:xfrm>
-            <a:off x="685800" y="3840480"/>
-            <a:ext cx="7772400" cy="548640"/>
+            <a:off x="685800" y="3995928"/>
+            <a:ext cx="7772400" cy="457200"/>
           </a:xfrm>
           <a:prstGeom prst="rect">
             <a:avLst/>
@@ -8842,47 +8746,16 @@
           <a:bodyPr wrap="square" lIns="0" tIns="0" rIns="0" bIns="0" rtlCol="0" anchor="t"/>
           <a:lstStyle/>
           <a:p>
-            <a:pPr marL="342900" indent="-342900">
-              <a:buSzPct val="100000"/>
-              <a:buChar char="•"/>
+            <a:pPr indent="0" marL="0">
+              <a:buNone/>
             </a:pPr>
             <a:r>
               <a:rPr lang="en-US" sz="1200" dirty="0">
                 <a:solidFill>
-                  <a:schemeClr val="tx1"/>
+                  <a:schemeClr val="accent6"/>
                 </a:solidFill>
               </a:rPr>
-              <a:t>Target cost per new-customer purchase by brand</a:t>
-            </a:r>
-            <a:endParaRPr lang="en-US" sz="1200" dirty="0"/>
-          </a:p>
-          <a:p>
-            <a:pPr marL="342900" indent="-342900">
-              <a:buSzPct val="100000"/>
-              <a:buChar char="•"/>
-            </a:pPr>
-            <a:r>
-              <a:rPr lang="en-US" sz="1200" dirty="0">
-                <a:solidFill>
-                  <a:schemeClr val="tx1"/>
-                </a:solidFill>
-              </a:rPr>
-              <a:t>Plan to restore email volume: ~14K sends a week today vs. ~23K in August–September</a:t>
-            </a:r>
-            <a:endParaRPr lang="en-US" sz="1200" dirty="0"/>
-          </a:p>
-          <a:p>
-            <a:pPr marL="342900" indent="-342900">
-              <a:buSzPct val="100000"/>
-              <a:buChar char="•"/>
-            </a:pPr>
-            <a:r>
-              <a:rPr lang="en-US" sz="1200" dirty="0">
-                <a:solidFill>
-                  <a:schemeClr val="tx1"/>
-                </a:solidFill>
-              </a:rPr>
-              <a:t>Fast Sale results vs. September's promotional week</a:t>
+              <a:t>We'll share the results of Brooklyn's Fast Sale (sales, orders, and VIP vs. list response) and how the new-customer campaigns are progressing across all 3 brands.</a:t>
             </a:r>
             <a:endParaRPr lang="en-US" sz="1200" dirty="0"/>
           </a:p>

</xml_diff>

<commit_message>
Add Brooklyn profit stability to CEO deck positives
Co-Authored-By: Claude Opus 5.5 <noreply@anthropic.com>
Claude-Session: https://claude.ai/code/session_01QGMjcfWM6zwQECSVCibDW3
</commit_message>
<xml_diff>
--- a/status_ceo/Stormberg_Status_CEO_Oct2026_EN.pptx
+++ b/status_ceo/Stormberg_Status_CEO_Oct2026_EN.pptx
@@ -113,21 +113,21 @@
   <p:extLst>
     <p:ext uri="{521415D9-36F7-43E2-AB2F-B90AF26B5E84}">
       <p14:sectionLst xmlns:p14="http://schemas.microsoft.com/office/powerpoint/2010/main">
-        <p14:section name="Summary" id="{3b3c418f-a539-8205-1f21-ec47a0773fa8}">
+        <p14:section name="Summary" id="{91a4e569-9686-72de-3af1-c3ca9aaf1d8a}">
           <p14:sldIdLst>
             <p14:sldId id="256"/>
             <p14:sldId id="257"/>
             <p14:sldId id="258"/>
           </p14:sldIdLst>
         </p14:section>
-        <p14:section name="Progress" id="{550a7bf0-6b17-fed7-4732-7561b82689aa}">
+        <p14:section name="Progress" id="{75029ded-0c89-0dde-179d-9c3331ae3792}">
           <p14:sldIdLst>
             <p14:sldId id="259"/>
             <p14:sldId id="260"/>
             <p14:sldId id="261"/>
           </p14:sldIdLst>
         </p14:section>
-        <p14:section name="Next steps" id="{3fe92e93-6554-2452-bfbd-ff4ab6d09887}">
+        <p14:section name="Next steps" id="{5e50ee56-9579-90a5-6d2a-ebf7bb4a9c28}">
           <p14:sldIdLst>
             <p14:sldId id="262"/>
           </p14:sldIdLst>
@@ -3632,7 +3632,7 @@
                   <a:schemeClr val="tx1"/>
                 </a:solidFill>
               </a:rPr>
-              <a:t>Brooklyn sold $1,745 a day from October 10 to 12, nearly double the first nine days of the month, right as Meta came on.</a:t>
+              <a:t>Brooklyn sold $1,745 a day from October 10 to 12, nearly double the first nine days of the month, right as Meta came on. Monthly profit holds at $4.5–5K on nearly half the media investment.</a:t>
             </a:r>
             <a:endParaRPr lang="en-US" sz="1400" dirty="0"/>
           </a:p>
@@ -3861,7 +3861,48 @@
         <p:spPr>
           <a:xfrm>
             <a:off x="457200" y="3611880"/>
-            <a:ext cx="1737360" cy="685800"/>
+            <a:ext cx="1828800" cy="685800"/>
+          </a:xfrm>
+          <a:prstGeom prst="rect">
+            <a:avLst/>
+          </a:prstGeom>
+          <a:noFill/>
+          <a:ln/>
+        </p:spPr>
+        <p:txBody>
+          <a:bodyPr wrap="square" lIns="0" tIns="0" rIns="0" bIns="0" rtlCol="0" anchor="ctr">
+            <a:normAutofit/>
+          </a:bodyPr>
+          <a:lstStyle/>
+          <a:p>
+            <a:pPr indent="0" marL="0">
+              <a:buNone/>
+            </a:pPr>
+            <a:r>
+              <a:rPr lang="en-US" sz="2800" b="1" dirty="0">
+                <a:solidFill>
+                  <a:schemeClr val="accent2"/>
+                </a:solidFill>
+                <a:latin typeface="Cambria" pitchFamily="34" charset="0"/>
+                <a:ea typeface="Cambria" pitchFamily="34" charset="-122"/>
+                <a:cs typeface="Cambria" pitchFamily="34" charset="-120"/>
+              </a:rPr>
+              <a:t>$4.5–5K</a:t>
+            </a:r>
+            <a:endParaRPr lang="en-US" sz="2800" dirty="0"/>
+          </a:p>
+        </p:txBody>
+      </p:sp>
+      <p:sp>
+        <p:nvSpPr>
+          <p:cNvPr id="5" name="Text 2"/>
+          <p:cNvSpPr txBox="1"/>
+          <p:nvPr/>
+        </p:nvSpPr>
+        <p:spPr>
+          <a:xfrm>
+            <a:off x="2377440" y="3611880"/>
+            <a:ext cx="2377440" cy="685800"/>
           </a:xfrm>
           <a:prstGeom prst="rect">
             <a:avLst/>
@@ -3877,51 +3918,12 @@
               <a:buNone/>
             </a:pPr>
             <a:r>
-              <a:rPr lang="en-US" sz="3200" b="1" dirty="0">
-                <a:solidFill>
-                  <a:schemeClr val="accent2"/>
-                </a:solidFill>
-                <a:latin typeface="Cambria" pitchFamily="34" charset="0"/>
-                <a:ea typeface="Cambria" pitchFamily="34" charset="-122"/>
-                <a:cs typeface="Cambria" pitchFamily="34" charset="-120"/>
+              <a:rPr lang="en-US" sz="1200" dirty="0">
+                <a:solidFill>
+                  <a:schemeClr val="tx1"/>
+                </a:solidFill>
               </a:rPr>
-              <a:t>$1,745</a:t>
-            </a:r>
-            <a:endParaRPr lang="en-US" sz="3200" dirty="0"/>
-          </a:p>
-        </p:txBody>
-      </p:sp>
-      <p:sp>
-        <p:nvSpPr>
-          <p:cNvPr id="5" name="Text 2"/>
-          <p:cNvSpPr txBox="1"/>
-          <p:nvPr/>
-        </p:nvSpPr>
-        <p:spPr>
-          <a:xfrm>
-            <a:off x="2240280" y="3611880"/>
-            <a:ext cx="2514600" cy="685800"/>
-          </a:xfrm>
-          <a:prstGeom prst="rect">
-            <a:avLst/>
-          </a:prstGeom>
-          <a:noFill/>
-          <a:ln/>
-        </p:spPr>
-        <p:txBody>
-          <a:bodyPr wrap="square" lIns="0" tIns="0" rIns="0" bIns="0" rtlCol="0" anchor="ctr"/>
-          <a:lstStyle/>
-          <a:p>
-            <a:pPr indent="0" marL="0">
-              <a:buNone/>
-            </a:pPr>
-            <a:r>
-              <a:rPr lang="en-US" sz="1200" dirty="0">
-                <a:solidFill>
-                  <a:schemeClr val="tx1"/>
-                </a:solidFill>
-              </a:rPr>
-              <a:t>average daily sales Oct 10–12, vs. $919 Oct 1–9</a:t>
+              <a:t>in steady monthly profit since May, on nearly half the media investment</a:t>
             </a:r>
             <a:endParaRPr lang="en-US" sz="1200" dirty="0"/>
           </a:p>
@@ -4433,7 +4435,7 @@
                   <a:schemeClr val="accent4"/>
                 </a:solidFill>
               </a:rPr>
-              <a:t>Source: Klaviyo (Brooklyn Biltong) for store sales, flows and Smile. Subscriptions and Google: team platform reports.</a:t>
+              <a:t>Source: Klaviyo (Brooklyn Biltong) for store sales, flows and Smile. Profit: Brooklyn financial analysis. Subscriptions and Google: team platform reports.</a:t>
             </a:r>
             <a:endParaRPr lang="en-US" sz="900" dirty="0"/>
           </a:p>

</xml_diff>

<commit_message>
Add Beg & Barker positives slide to CEO deck
Co-Authored-By: Claude Opus 5.5 <noreply@anthropic.com>
Claude-Session: https://claude.ai/code/session_01QGMjcfWM6zwQECSVCibDW3
</commit_message>
<xml_diff>
--- a/status_ceo/Stormberg_Status_CEO_Oct2026_EN.pptx
+++ b/status_ceo/Stormberg_Status_CEO_Oct2026_EN.pptx
@@ -12,9 +12,10 @@
     <p:sldId id="260" r:id="rId6"/>
     <p:sldId id="261" r:id="rId7"/>
     <p:sldId id="262" r:id="rId8"/>
+    <p:sldId id="263" r:id="rId9"/>
   </p:sldIdLst>
   <p:notesMasterIdLst>
-    <p:notesMasterId r:id="rId9"/>
+    <p:notesMasterId r:id="rId10"/>
   </p:notesMasterIdLst>
   <p:sldSz cx="9144000" cy="5143500"/>
   <p:notesSz cx="5143500" cy="9144000"/>
@@ -113,23 +114,24 @@
   <p:extLst>
     <p:ext uri="{521415D9-36F7-43E2-AB2F-B90AF26B5E84}">
       <p14:sectionLst xmlns:p14="http://schemas.microsoft.com/office/powerpoint/2010/main">
-        <p14:section name="Summary" id="{91a4e569-9686-72de-3af1-c3ca9aaf1d8a}">
+        <p14:section name="Summary" id="{d06c6a32-342a-2586-9cf1-8231bbec9472}">
           <p14:sldIdLst>
             <p14:sldId id="256"/>
             <p14:sldId id="257"/>
             <p14:sldId id="258"/>
+            <p14:sldId id="259"/>
           </p14:sldIdLst>
         </p14:section>
-        <p14:section name="Progress" id="{75029ded-0c89-0dde-179d-9c3331ae3792}">
+        <p14:section name="Progress" id="{54b547cd-fc4b-4cec-d0c4-7c8e3ddc6578}">
           <p14:sldIdLst>
-            <p14:sldId id="259"/>
             <p14:sldId id="260"/>
             <p14:sldId id="261"/>
+            <p14:sldId id="262"/>
           </p14:sldIdLst>
         </p14:section>
-        <p14:section name="Next steps" id="{5e50ee56-9579-90a5-6d2a-ebf7bb4a9c28}">
+        <p14:section name="Next steps" id="{88e3939c-1370-8b37-aeda-1b56901fcde8}">
           <p14:sldIdLst>
-            <p14:sldId id="262"/>
+            <p14:sldId id="263"/>
           </p14:sldIdLst>
         </p14:section>
       </p14:sectionLst>
@@ -2217,6 +2219,94 @@
 </p:notes>
 </file>
 
+<file path=ppt/notesSlides/notesSlide8.xml><?xml version="1.0" encoding="utf-8"?>
+<p:notes xmlns:a="http://schemas.openxmlformats.org/drawingml/2006/main" xmlns:r="http://schemas.openxmlformats.org/officeDocument/2006/relationships" xmlns:p="http://schemas.openxmlformats.org/presentationml/2006/main">
+  <p:cSld>
+    <p:spTree>
+      <p:nvGrpSpPr>
+        <p:cNvPr id="1" name=""/>
+        <p:cNvGrpSpPr/>
+        <p:nvPr/>
+      </p:nvGrpSpPr>
+      <p:grpSpPr>
+        <a:xfrm>
+          <a:off x="0" y="0"/>
+          <a:ext cx="0" cy="0"/>
+          <a:chOff x="0" y="0"/>
+          <a:chExt cx="0" cy="0"/>
+        </a:xfrm>
+      </p:grpSpPr>
+      <p:sp>
+        <p:nvSpPr>
+          <p:cNvPr id="2" name="Slide Image Placeholder 1"/>
+          <p:cNvSpPr>
+            <a:spLocks noGrp="1" noRot="1" noChangeAspect="1"/>
+          </p:cNvSpPr>
+          <p:nvPr>
+            <p:ph type="sldImg"/>
+          </p:nvPr>
+        </p:nvSpPr>
+        <p:spPr/>
+      </p:sp>
+      <p:sp>
+        <p:nvSpPr>
+          <p:cNvPr id="3" name="Notes Placeholder 2"/>
+          <p:cNvSpPr>
+            <a:spLocks noGrp="1"/>
+          </p:cNvSpPr>
+          <p:nvPr>
+            <p:ph type="body" idx="1"/>
+          </p:nvPr>
+        </p:nvSpPr>
+        <p:spPr/>
+        <p:txBody>
+          <a:bodyPr/>
+          <a:lstStyle/>
+          <a:p>
+            <a:r>
+              <a:rPr lang="en-US" dirty="0"/>
+              <a:t/>
+            </a:r>
+            <a:endParaRPr lang="en-US" dirty="0"/>
+          </a:p>
+        </p:txBody>
+      </p:sp>
+      <p:sp>
+        <p:nvSpPr>
+          <p:cNvPr id="4" name="Slide Number Placeholder 3"/>
+          <p:cNvSpPr>
+            <a:spLocks noGrp="1"/>
+          </p:cNvSpPr>
+          <p:nvPr>
+            <p:ph type="sldNum" sz="quarter" idx="10"/>
+          </p:nvPr>
+        </p:nvSpPr>
+        <p:spPr/>
+        <p:txBody>
+          <a:bodyPr/>
+          <a:lstStyle/>
+          <a:p>
+            <a:fld id="{F7021451-1387-4CA6-816F-3879F97B5CBC}" type="slidenum">
+              <a:rPr lang="en-US"/>
+              <a:t>8</a:t>
+            </a:fld>
+            <a:endParaRPr lang="en-US"/>
+          </a:p>
+        </p:txBody>
+      </p:sp>
+    </p:spTree>
+    <p:extLst>
+      <p:ext uri="{BB962C8B-B14F-4D97-AF65-F5344CB8AC3E}">
+        <p14:creationId xmlns:p14="http://schemas.microsoft.com/office/powerpoint/2010/main" val="1024086991"/>
+      </p:ext>
+    </p:extLst>
+  </p:cSld>
+  <p:clrMapOvr>
+    <a:masterClrMapping/>
+  </p:clrMapOvr>
+</p:notes>
+</file>
+
 <file path=ppt/slideLayouts/slideLayout1.xml><?xml version="1.0" encoding="utf-8"?>
 <p:sldLayout xmlns:a="http://schemas.openxmlformats.org/drawingml/2006/main" xmlns:r="http://schemas.openxmlformats.org/officeDocument/2006/relationships" xmlns:p="http://schemas.openxmlformats.org/presentationml/2006/main" preserve="1">
   <p:cSld name="DEFAULT">
@@ -3830,7 +3920,7 @@
                 <a:ea typeface="Cambria" pitchFamily="34" charset="-122"/>
                 <a:cs typeface="Cambria" pitchFamily="34" charset="-120"/>
               </a:rPr>
-              <a:t>Positive signals from the last week</a:t>
+              <a:t>Brooklyn: positive signals from the last week</a:t>
             </a:r>
             <a:endParaRPr lang="en-US" sz="2600" dirty="0"/>
           </a:p>
@@ -4546,6 +4636,926 @@
                 <a:ea typeface="Cambria" pitchFamily="34" charset="-122"/>
                 <a:cs typeface="Cambria" pitchFamily="34" charset="-120"/>
               </a:rPr>
+              <a:t>Beg &amp; Barker: a solid, recurring base</a:t>
+            </a:r>
+            <a:endParaRPr lang="en-US" sz="2600" dirty="0"/>
+          </a:p>
+        </p:txBody>
+      </p:sp>
+      <p:sp>
+        <p:nvSpPr>
+          <p:cNvPr id="3" name="BB stat 1"/>
+          <p:cNvSpPr/>
+          <p:nvPr/>
+        </p:nvSpPr>
+        <p:spPr>
+          <a:xfrm>
+            <a:off x="457200" y="1005840"/>
+            <a:ext cx="4206240" cy="1005840"/>
+          </a:xfrm>
+          <a:prstGeom prst="roundRect">
+            <a:avLst>
+              <a:gd name="adj" fmla="val 7273"/>
+            </a:avLst>
+          </a:prstGeom>
+          <a:solidFill>
+            <a:schemeClr val="bg2"/>
+          </a:solidFill>
+          <a:ln/>
+        </p:spPr>
+      </p:sp>
+      <p:sp>
+        <p:nvSpPr>
+          <p:cNvPr id="4" name="Text 2"/>
+          <p:cNvSpPr txBox="1"/>
+          <p:nvPr/>
+        </p:nvSpPr>
+        <p:spPr>
+          <a:xfrm>
+            <a:off x="640080" y="1097280"/>
+            <a:ext cx="1463040" cy="822960"/>
+          </a:xfrm>
+          <a:prstGeom prst="rect">
+            <a:avLst/>
+          </a:prstGeom>
+          <a:noFill/>
+          <a:ln/>
+        </p:spPr>
+        <p:txBody>
+          <a:bodyPr wrap="square" lIns="0" tIns="0" rIns="0" bIns="0" rtlCol="0" anchor="ctr">
+            <a:normAutofit/>
+          </a:bodyPr>
+          <a:lstStyle/>
+          <a:p>
+            <a:pPr indent="0" marL="0">
+              <a:buNone/>
+            </a:pPr>
+            <a:r>
+              <a:rPr lang="en-US" sz="3000" b="1" dirty="0">
+                <a:solidFill>
+                  <a:schemeClr val="tx2"/>
+                </a:solidFill>
+                <a:latin typeface="Cambria" pitchFamily="34" charset="0"/>
+                <a:ea typeface="Cambria" pitchFamily="34" charset="-122"/>
+                <a:cs typeface="Cambria" pitchFamily="34" charset="-120"/>
+              </a:rPr>
+              <a:t>$89.9K</a:t>
+            </a:r>
+            <a:endParaRPr lang="en-US" sz="3000" dirty="0"/>
+          </a:p>
+        </p:txBody>
+      </p:sp>
+      <p:sp>
+        <p:nvSpPr>
+          <p:cNvPr id="5" name="Text 3"/>
+          <p:cNvSpPr txBox="1"/>
+          <p:nvPr/>
+        </p:nvSpPr>
+        <p:spPr>
+          <a:xfrm>
+            <a:off x="2194560" y="1097280"/>
+            <a:ext cx="2331720" cy="822960"/>
+          </a:xfrm>
+          <a:prstGeom prst="rect">
+            <a:avLst/>
+          </a:prstGeom>
+          <a:noFill/>
+          <a:ln/>
+        </p:spPr>
+        <p:txBody>
+          <a:bodyPr wrap="square" lIns="0" tIns="0" rIns="0" bIns="0" rtlCol="0" anchor="ctr"/>
+          <a:lstStyle/>
+          <a:p>
+            <a:pPr indent="0" marL="0">
+              <a:buNone/>
+            </a:pPr>
+            <a:r>
+              <a:rPr lang="en-US" sz="1200" dirty="0">
+                <a:solidFill>
+                  <a:schemeClr val="tx1"/>
+                </a:solidFill>
+              </a:rPr>
+              <a:t>in sales year to date, from 1,181 orders at a $76 average ticket</a:t>
+            </a:r>
+            <a:endParaRPr lang="en-US" sz="1200" dirty="0"/>
+          </a:p>
+        </p:txBody>
+      </p:sp>
+      <p:sp>
+        <p:nvSpPr>
+          <p:cNvPr id="6" name="BB stat 2"/>
+          <p:cNvSpPr/>
+          <p:nvPr/>
+        </p:nvSpPr>
+        <p:spPr>
+          <a:xfrm>
+            <a:off x="457200" y="2148840"/>
+            <a:ext cx="4206240" cy="1005840"/>
+          </a:xfrm>
+          <a:prstGeom prst="roundRect">
+            <a:avLst>
+              <a:gd name="adj" fmla="val 7273"/>
+            </a:avLst>
+          </a:prstGeom>
+          <a:solidFill>
+            <a:schemeClr val="bg2"/>
+          </a:solidFill>
+          <a:ln/>
+        </p:spPr>
+      </p:sp>
+      <p:sp>
+        <p:nvSpPr>
+          <p:cNvPr id="7" name="Text 5"/>
+          <p:cNvSpPr txBox="1"/>
+          <p:nvPr/>
+        </p:nvSpPr>
+        <p:spPr>
+          <a:xfrm>
+            <a:off x="640080" y="2240280"/>
+            <a:ext cx="1463040" cy="822960"/>
+          </a:xfrm>
+          <a:prstGeom prst="rect">
+            <a:avLst/>
+          </a:prstGeom>
+          <a:noFill/>
+          <a:ln/>
+        </p:spPr>
+        <p:txBody>
+          <a:bodyPr wrap="square" lIns="0" tIns="0" rIns="0" bIns="0" rtlCol="0" anchor="ctr">
+            <a:normAutofit/>
+          </a:bodyPr>
+          <a:lstStyle/>
+          <a:p>
+            <a:pPr indent="0" marL="0">
+              <a:buNone/>
+            </a:pPr>
+            <a:r>
+              <a:rPr lang="en-US" sz="3000" b="1" dirty="0">
+                <a:solidFill>
+                  <a:schemeClr val="accent2"/>
+                </a:solidFill>
+                <a:latin typeface="Cambria" pitchFamily="34" charset="0"/>
+                <a:ea typeface="Cambria" pitchFamily="34" charset="-122"/>
+                <a:cs typeface="Cambria" pitchFamily="34" charset="-120"/>
+              </a:rPr>
+              <a:t>44%</a:t>
+            </a:r>
+            <a:endParaRPr lang="en-US" sz="3000" dirty="0"/>
+          </a:p>
+        </p:txBody>
+      </p:sp>
+      <p:sp>
+        <p:nvSpPr>
+          <p:cNvPr id="8" name="Text 6"/>
+          <p:cNvSpPr txBox="1"/>
+          <p:nvPr/>
+        </p:nvSpPr>
+        <p:spPr>
+          <a:xfrm>
+            <a:off x="2194560" y="2240280"/>
+            <a:ext cx="2331720" cy="822960"/>
+          </a:xfrm>
+          <a:prstGeom prst="rect">
+            <a:avLst/>
+          </a:prstGeom>
+          <a:noFill/>
+          <a:ln/>
+        </p:spPr>
+        <p:txBody>
+          <a:bodyPr wrap="square" lIns="0" tIns="0" rIns="0" bIns="0" rtlCol="0" anchor="ctr"/>
+          <a:lstStyle/>
+          <a:p>
+            <a:pPr indent="0" marL="0">
+              <a:buNone/>
+            </a:pPr>
+            <a:r>
+              <a:rPr lang="en-US" sz="1200" dirty="0">
+                <a:solidFill>
+                  <a:schemeClr val="tx1"/>
+                </a:solidFill>
+              </a:rPr>
+              <a:t>of sales are subscription renewals: $40K in recurring revenue this year</a:t>
+            </a:r>
+            <a:endParaRPr lang="en-US" sz="1200" dirty="0"/>
+          </a:p>
+        </p:txBody>
+      </p:sp>
+      <p:sp>
+        <p:nvSpPr>
+          <p:cNvPr id="9" name="BB stat 3"/>
+          <p:cNvSpPr/>
+          <p:nvPr/>
+        </p:nvSpPr>
+        <p:spPr>
+          <a:xfrm>
+            <a:off x="457200" y="3291840"/>
+            <a:ext cx="4206240" cy="1005840"/>
+          </a:xfrm>
+          <a:prstGeom prst="roundRect">
+            <a:avLst>
+              <a:gd name="adj" fmla="val 7273"/>
+            </a:avLst>
+          </a:prstGeom>
+          <a:solidFill>
+            <a:schemeClr val="bg2"/>
+          </a:solidFill>
+          <a:ln/>
+        </p:spPr>
+      </p:sp>
+      <p:sp>
+        <p:nvSpPr>
+          <p:cNvPr id="10" name="Text 8"/>
+          <p:cNvSpPr txBox="1"/>
+          <p:nvPr/>
+        </p:nvSpPr>
+        <p:spPr>
+          <a:xfrm>
+            <a:off x="640080" y="3383280"/>
+            <a:ext cx="1463040" cy="822960"/>
+          </a:xfrm>
+          <a:prstGeom prst="rect">
+            <a:avLst/>
+          </a:prstGeom>
+          <a:noFill/>
+          <a:ln/>
+        </p:spPr>
+        <p:txBody>
+          <a:bodyPr wrap="square" lIns="0" tIns="0" rIns="0" bIns="0" rtlCol="0" anchor="ctr">
+            <a:normAutofit/>
+          </a:bodyPr>
+          <a:lstStyle/>
+          <a:p>
+            <a:pPr indent="0" marL="0">
+              <a:buNone/>
+            </a:pPr>
+            <a:r>
+              <a:rPr lang="en-US" sz="3000" b="1" dirty="0">
+                <a:solidFill>
+                  <a:schemeClr val="accent1"/>
+                </a:solidFill>
+                <a:latin typeface="Cambria" pitchFamily="34" charset="0"/>
+                <a:ea typeface="Cambria" pitchFamily="34" charset="-122"/>
+                <a:cs typeface="Cambria" pitchFamily="34" charset="-120"/>
+              </a:rPr>
+              <a:t>$2.21</a:t>
+            </a:r>
+            <a:endParaRPr lang="en-US" sz="3000" dirty="0"/>
+          </a:p>
+        </p:txBody>
+      </p:sp>
+      <p:sp>
+        <p:nvSpPr>
+          <p:cNvPr id="11" name="Text 9"/>
+          <p:cNvSpPr txBox="1"/>
+          <p:nvPr/>
+        </p:nvSpPr>
+        <p:spPr>
+          <a:xfrm>
+            <a:off x="2194560" y="3383280"/>
+            <a:ext cx="2331720" cy="822960"/>
+          </a:xfrm>
+          <a:prstGeom prst="rect">
+            <a:avLst/>
+          </a:prstGeom>
+          <a:noFill/>
+          <a:ln/>
+        </p:spPr>
+        <p:txBody>
+          <a:bodyPr wrap="square" lIns="0" tIns="0" rIns="0" bIns="0" rtlCol="0" anchor="ctr"/>
+          <a:lstStyle/>
+          <a:p>
+            <a:pPr indent="0" marL="0">
+              <a:buNone/>
+            </a:pPr>
+            <a:r>
+              <a:rPr lang="en-US" sz="1200" dirty="0">
+                <a:solidFill>
+                  <a:schemeClr val="tx1"/>
+                </a:solidFill>
+              </a:rPr>
+              <a:t>per recipient from automated flows, 13 times more than campaigns</a:t>
+            </a:r>
+            <a:endParaRPr lang="en-US" sz="1200" dirty="0"/>
+          </a:p>
+        </p:txBody>
+      </p:sp>
+      <p:sp>
+        <p:nvSpPr>
+          <p:cNvPr id="12" name="BB card 1"/>
+          <p:cNvSpPr/>
+          <p:nvPr/>
+        </p:nvSpPr>
+        <p:spPr>
+          <a:xfrm>
+            <a:off x="5029200" y="1005840"/>
+            <a:ext cx="1783080" cy="1554480"/>
+          </a:xfrm>
+          <a:prstGeom prst="roundRect">
+            <a:avLst>
+              <a:gd name="adj" fmla="val 4706"/>
+            </a:avLst>
+          </a:prstGeom>
+          <a:solidFill>
+            <a:schemeClr val="bg2"/>
+          </a:solidFill>
+          <a:ln/>
+        </p:spPr>
+      </p:sp>
+      <p:sp>
+        <p:nvSpPr>
+          <p:cNvPr id="13" name="BB dot 1"/>
+          <p:cNvSpPr/>
+          <p:nvPr/>
+        </p:nvSpPr>
+        <p:spPr>
+          <a:xfrm>
+            <a:off x="5166360" y="1143000"/>
+            <a:ext cx="256032" cy="256032"/>
+          </a:xfrm>
+          <a:prstGeom prst="ellipse">
+            <a:avLst/>
+          </a:prstGeom>
+          <a:solidFill>
+            <a:schemeClr val="accent2"/>
+          </a:solidFill>
+          <a:ln/>
+        </p:spPr>
+      </p:sp>
+      <p:sp>
+        <p:nvSpPr>
+          <p:cNvPr id="14" name="Text 12"/>
+          <p:cNvSpPr txBox="1"/>
+          <p:nvPr/>
+        </p:nvSpPr>
+        <p:spPr>
+          <a:xfrm>
+            <a:off x="5486400" y="1097280"/>
+            <a:ext cx="1261872" cy="365760"/>
+          </a:xfrm>
+          <a:prstGeom prst="rect">
+            <a:avLst/>
+          </a:prstGeom>
+          <a:noFill/>
+          <a:ln/>
+        </p:spPr>
+        <p:txBody>
+          <a:bodyPr wrap="square" lIns="0" tIns="0" rIns="0" bIns="0" rtlCol="0" anchor="ctr">
+            <a:normAutofit/>
+          </a:bodyPr>
+          <a:lstStyle/>
+          <a:p>
+            <a:pPr indent="0" marL="0">
+              <a:buNone/>
+            </a:pPr>
+            <a:r>
+              <a:rPr lang="en-US" sz="1200" b="1" dirty="0">
+                <a:solidFill>
+                  <a:schemeClr val="tx1"/>
+                </a:solidFill>
+                <a:latin typeface="Cambria" pitchFamily="34" charset="0"/>
+                <a:ea typeface="Cambria" pitchFamily="34" charset="-122"/>
+                <a:cs typeface="Cambria" pitchFamily="34" charset="-120"/>
+              </a:rPr>
+              <a:t>Steady sales</a:t>
+            </a:r>
+            <a:endParaRPr lang="en-US" sz="1200" dirty="0"/>
+          </a:p>
+        </p:txBody>
+      </p:sp>
+      <p:sp>
+        <p:nvSpPr>
+          <p:cNvPr id="15" name="Text 13"/>
+          <p:cNvSpPr txBox="1"/>
+          <p:nvPr/>
+        </p:nvSpPr>
+        <p:spPr>
+          <a:xfrm>
+            <a:off x="5166360" y="1508760"/>
+            <a:ext cx="1536192" cy="987552"/>
+          </a:xfrm>
+          <a:prstGeom prst="rect">
+            <a:avLst/>
+          </a:prstGeom>
+          <a:noFill/>
+          <a:ln/>
+        </p:spPr>
+        <p:txBody>
+          <a:bodyPr wrap="square" lIns="0" tIns="0" rIns="0" bIns="0" rtlCol="0" anchor="t"/>
+          <a:lstStyle/>
+          <a:p>
+            <a:pPr indent="0" marL="0">
+              <a:buNone/>
+            </a:pPr>
+            <a:r>
+              <a:rPr lang="en-US" sz="1100" dirty="0">
+                <a:solidFill>
+                  <a:schemeClr val="tx1"/>
+                </a:solidFill>
+              </a:rPr>
+              <a:t>~$9.3K a month in Q1 and ~$9.7K from April to September</a:t>
+            </a:r>
+            <a:endParaRPr lang="en-US" sz="1100" dirty="0"/>
+          </a:p>
+        </p:txBody>
+      </p:sp>
+      <p:sp>
+        <p:nvSpPr>
+          <p:cNvPr id="16" name="BB card 2"/>
+          <p:cNvSpPr/>
+          <p:nvPr/>
+        </p:nvSpPr>
+        <p:spPr>
+          <a:xfrm>
+            <a:off x="6903720" y="1005840"/>
+            <a:ext cx="1783080" cy="1554480"/>
+          </a:xfrm>
+          <a:prstGeom prst="roundRect">
+            <a:avLst>
+              <a:gd name="adj" fmla="val 4706"/>
+            </a:avLst>
+          </a:prstGeom>
+          <a:solidFill>
+            <a:schemeClr val="bg2"/>
+          </a:solidFill>
+          <a:ln/>
+        </p:spPr>
+      </p:sp>
+      <p:sp>
+        <p:nvSpPr>
+          <p:cNvPr id="17" name="BB dot 2"/>
+          <p:cNvSpPr/>
+          <p:nvPr/>
+        </p:nvSpPr>
+        <p:spPr>
+          <a:xfrm>
+            <a:off x="7040880" y="1143000"/>
+            <a:ext cx="256032" cy="256032"/>
+          </a:xfrm>
+          <a:prstGeom prst="ellipse">
+            <a:avLst/>
+          </a:prstGeom>
+          <a:solidFill>
+            <a:schemeClr val="accent2"/>
+          </a:solidFill>
+          <a:ln/>
+        </p:spPr>
+      </p:sp>
+      <p:sp>
+        <p:nvSpPr>
+          <p:cNvPr id="18" name="Text 16"/>
+          <p:cNvSpPr txBox="1"/>
+          <p:nvPr/>
+        </p:nvSpPr>
+        <p:spPr>
+          <a:xfrm>
+            <a:off x="7360920" y="1097280"/>
+            <a:ext cx="1261872" cy="365760"/>
+          </a:xfrm>
+          <a:prstGeom prst="rect">
+            <a:avLst/>
+          </a:prstGeom>
+          <a:noFill/>
+          <a:ln/>
+        </p:spPr>
+        <p:txBody>
+          <a:bodyPr wrap="square" lIns="0" tIns="0" rIns="0" bIns="0" rtlCol="0" anchor="ctr">
+            <a:normAutofit/>
+          </a:bodyPr>
+          <a:lstStyle/>
+          <a:p>
+            <a:pPr indent="0" marL="0">
+              <a:buNone/>
+            </a:pPr>
+            <a:r>
+              <a:rPr lang="en-US" sz="1200" b="1" dirty="0">
+                <a:solidFill>
+                  <a:schemeClr val="tx1"/>
+                </a:solidFill>
+                <a:latin typeface="Cambria" pitchFamily="34" charset="0"/>
+                <a:ea typeface="Cambria" pitchFamily="34" charset="-122"/>
+                <a:cs typeface="Cambria" pitchFamily="34" charset="-120"/>
+              </a:rPr>
+              <a:t>Brand search</a:t>
+            </a:r>
+            <a:endParaRPr lang="en-US" sz="1200" dirty="0"/>
+          </a:p>
+        </p:txBody>
+      </p:sp>
+      <p:sp>
+        <p:nvSpPr>
+          <p:cNvPr id="19" name="Text 17"/>
+          <p:cNvSpPr txBox="1"/>
+          <p:nvPr/>
+        </p:nvSpPr>
+        <p:spPr>
+          <a:xfrm>
+            <a:off x="7040880" y="1508760"/>
+            <a:ext cx="1536192" cy="987552"/>
+          </a:xfrm>
+          <a:prstGeom prst="rect">
+            <a:avLst/>
+          </a:prstGeom>
+          <a:noFill/>
+          <a:ln/>
+        </p:spPr>
+        <p:txBody>
+          <a:bodyPr wrap="square" lIns="0" tIns="0" rIns="0" bIns="0" rtlCol="0" anchor="t"/>
+          <a:lstStyle/>
+          <a:p>
+            <a:pPr indent="0" marL="0">
+              <a:buNone/>
+            </a:pPr>
+            <a:r>
+              <a:rPr lang="en-US" sz="1100" dirty="0">
+                <a:solidFill>
+                  <a:schemeClr val="tx1"/>
+                </a:solidFill>
+              </a:rPr>
+              <a:t>Google's most profitable line, with a return close to 3x</a:t>
+            </a:r>
+            <a:endParaRPr lang="en-US" sz="1100" dirty="0"/>
+          </a:p>
+        </p:txBody>
+      </p:sp>
+      <p:sp>
+        <p:nvSpPr>
+          <p:cNvPr id="20" name="BB card 3"/>
+          <p:cNvSpPr/>
+          <p:nvPr/>
+        </p:nvSpPr>
+        <p:spPr>
+          <a:xfrm>
+            <a:off x="5029200" y="2697480"/>
+            <a:ext cx="1783080" cy="1554480"/>
+          </a:xfrm>
+          <a:prstGeom prst="roundRect">
+            <a:avLst>
+              <a:gd name="adj" fmla="val 4706"/>
+            </a:avLst>
+          </a:prstGeom>
+          <a:solidFill>
+            <a:schemeClr val="bg2"/>
+          </a:solidFill>
+          <a:ln/>
+        </p:spPr>
+      </p:sp>
+      <p:sp>
+        <p:nvSpPr>
+          <p:cNvPr id="21" name="BB dot 3"/>
+          <p:cNvSpPr/>
+          <p:nvPr/>
+        </p:nvSpPr>
+        <p:spPr>
+          <a:xfrm>
+            <a:off x="5166360" y="2834640"/>
+            <a:ext cx="256032" cy="256032"/>
+          </a:xfrm>
+          <a:prstGeom prst="ellipse">
+            <a:avLst/>
+          </a:prstGeom>
+          <a:solidFill>
+            <a:schemeClr val="accent2"/>
+          </a:solidFill>
+          <a:ln/>
+        </p:spPr>
+      </p:sp>
+      <p:sp>
+        <p:nvSpPr>
+          <p:cNvPr id="22" name="Text 20"/>
+          <p:cNvSpPr txBox="1"/>
+          <p:nvPr/>
+        </p:nvSpPr>
+        <p:spPr>
+          <a:xfrm>
+            <a:off x="5486400" y="2788920"/>
+            <a:ext cx="1261872" cy="365760"/>
+          </a:xfrm>
+          <a:prstGeom prst="rect">
+            <a:avLst/>
+          </a:prstGeom>
+          <a:noFill/>
+          <a:ln/>
+        </p:spPr>
+        <p:txBody>
+          <a:bodyPr wrap="square" lIns="0" tIns="0" rIns="0" bIns="0" rtlCol="0" anchor="ctr">
+            <a:normAutofit/>
+          </a:bodyPr>
+          <a:lstStyle/>
+          <a:p>
+            <a:pPr indent="0" marL="0">
+              <a:buNone/>
+            </a:pPr>
+            <a:r>
+              <a:rPr lang="en-US" sz="1200" b="1" dirty="0">
+                <a:solidFill>
+                  <a:schemeClr val="tx1"/>
+                </a:solidFill>
+                <a:latin typeface="Cambria" pitchFamily="34" charset="0"/>
+                <a:ea typeface="Cambria" pitchFamily="34" charset="-122"/>
+                <a:cs typeface="Cambria" pitchFamily="34" charset="-120"/>
+              </a:rPr>
+              <a:t>Dynamic retargeting</a:t>
+            </a:r>
+            <a:endParaRPr lang="en-US" sz="1200" dirty="0"/>
+          </a:p>
+        </p:txBody>
+      </p:sp>
+      <p:sp>
+        <p:nvSpPr>
+          <p:cNvPr id="23" name="Text 21"/>
+          <p:cNvSpPr txBox="1"/>
+          <p:nvPr/>
+        </p:nvSpPr>
+        <p:spPr>
+          <a:xfrm>
+            <a:off x="5166360" y="3200400"/>
+            <a:ext cx="1536192" cy="987552"/>
+          </a:xfrm>
+          <a:prstGeom prst="rect">
+            <a:avLst/>
+          </a:prstGeom>
+          <a:noFill/>
+          <a:ln/>
+        </p:spPr>
+        <p:txBody>
+          <a:bodyPr wrap="square" lIns="0" tIns="0" rIns="0" bIns="0" rtlCol="0" anchor="t"/>
+          <a:lstStyle/>
+          <a:p>
+            <a:pPr indent="0" marL="0">
+              <a:buNone/>
+            </a:pPr>
+            <a:r>
+              <a:rPr lang="en-US" sz="1100" dirty="0">
+                <a:solidFill>
+                  <a:schemeClr val="tx1"/>
+                </a:solidFill>
+              </a:rPr>
+              <a:t>3.1x return on Meta ahead of the Oct 10 restructure</a:t>
+            </a:r>
+            <a:endParaRPr lang="en-US" sz="1100" dirty="0"/>
+          </a:p>
+        </p:txBody>
+      </p:sp>
+      <p:sp>
+        <p:nvSpPr>
+          <p:cNvPr id="24" name="BB card 4"/>
+          <p:cNvSpPr/>
+          <p:nvPr/>
+        </p:nvSpPr>
+        <p:spPr>
+          <a:xfrm>
+            <a:off x="6903720" y="2697480"/>
+            <a:ext cx="1783080" cy="1554480"/>
+          </a:xfrm>
+          <a:prstGeom prst="roundRect">
+            <a:avLst>
+              <a:gd name="adj" fmla="val 4706"/>
+            </a:avLst>
+          </a:prstGeom>
+          <a:solidFill>
+            <a:schemeClr val="bg2"/>
+          </a:solidFill>
+          <a:ln/>
+        </p:spPr>
+      </p:sp>
+      <p:sp>
+        <p:nvSpPr>
+          <p:cNvPr id="25" name="BB dot 4"/>
+          <p:cNvSpPr/>
+          <p:nvPr/>
+        </p:nvSpPr>
+        <p:spPr>
+          <a:xfrm>
+            <a:off x="7040880" y="2834640"/>
+            <a:ext cx="256032" cy="256032"/>
+          </a:xfrm>
+          <a:prstGeom prst="ellipse">
+            <a:avLst/>
+          </a:prstGeom>
+          <a:solidFill>
+            <a:schemeClr val="accent2"/>
+          </a:solidFill>
+          <a:ln/>
+        </p:spPr>
+      </p:sp>
+      <p:sp>
+        <p:nvSpPr>
+          <p:cNvPr id="26" name="Text 24"/>
+          <p:cNvSpPr txBox="1"/>
+          <p:nvPr/>
+        </p:nvSpPr>
+        <p:spPr>
+          <a:xfrm>
+            <a:off x="7360920" y="2788920"/>
+            <a:ext cx="1261872" cy="365760"/>
+          </a:xfrm>
+          <a:prstGeom prst="rect">
+            <a:avLst/>
+          </a:prstGeom>
+          <a:noFill/>
+          <a:ln/>
+        </p:spPr>
+        <p:txBody>
+          <a:bodyPr wrap="square" lIns="0" tIns="0" rIns="0" bIns="0" rtlCol="0" anchor="ctr">
+            <a:normAutofit/>
+          </a:bodyPr>
+          <a:lstStyle/>
+          <a:p>
+            <a:pPr indent="0" marL="0">
+              <a:buNone/>
+            </a:pPr>
+            <a:r>
+              <a:rPr lang="en-US" sz="1200" b="1" dirty="0">
+                <a:solidFill>
+                  <a:schemeClr val="tx1"/>
+                </a:solidFill>
+                <a:latin typeface="Cambria" pitchFamily="34" charset="0"/>
+                <a:ea typeface="Cambria" pitchFamily="34" charset="-122"/>
+                <a:cs typeface="Cambria" pitchFamily="34" charset="-120"/>
+              </a:rPr>
+              <a:t>Refreshed welcome</a:t>
+            </a:r>
+            <a:endParaRPr lang="en-US" sz="1200" dirty="0"/>
+          </a:p>
+        </p:txBody>
+      </p:sp>
+      <p:sp>
+        <p:nvSpPr>
+          <p:cNvPr id="27" name="Text 25"/>
+          <p:cNvSpPr txBox="1"/>
+          <p:nvPr/>
+        </p:nvSpPr>
+        <p:spPr>
+          <a:xfrm>
+            <a:off x="7040880" y="3200400"/>
+            <a:ext cx="1536192" cy="987552"/>
+          </a:xfrm>
+          <a:prstGeom prst="rect">
+            <a:avLst/>
+          </a:prstGeom>
+          <a:noFill/>
+          <a:ln/>
+        </p:spPr>
+        <p:txBody>
+          <a:bodyPr wrap="square" lIns="0" tIns="0" rIns="0" bIns="0" rtlCol="0" anchor="t"/>
+          <a:lstStyle/>
+          <a:p>
+            <a:pPr indent="0" marL="0">
+              <a:buNone/>
+            </a:pPr>
+            <a:r>
+              <a:rPr lang="en-US" sz="1100" dirty="0">
+                <a:solidFill>
+                  <a:schemeClr val="tx1"/>
+                </a:solidFill>
+              </a:rPr>
+              <a:t>BARK15 Welcome live since Oct 6; SMS Welcome on the way</a:t>
+            </a:r>
+            <a:endParaRPr lang="en-US" sz="1100" dirty="0"/>
+          </a:p>
+        </p:txBody>
+      </p:sp>
+      <p:sp>
+        <p:nvSpPr>
+          <p:cNvPr id="28" name="Text 26"/>
+          <p:cNvSpPr txBox="1"/>
+          <p:nvPr/>
+        </p:nvSpPr>
+        <p:spPr>
+          <a:xfrm>
+            <a:off x="457200" y="4434840"/>
+            <a:ext cx="8229600" cy="274320"/>
+          </a:xfrm>
+          <a:prstGeom prst="rect">
+            <a:avLst/>
+          </a:prstGeom>
+          <a:noFill/>
+          <a:ln/>
+        </p:spPr>
+        <p:txBody>
+          <a:bodyPr wrap="square" lIns="0" tIns="0" rIns="0" bIns="0" rtlCol="0" anchor="ctr"/>
+          <a:lstStyle/>
+          <a:p>
+            <a:pPr indent="0" marL="0">
+              <a:buNone/>
+            </a:pPr>
+            <a:r>
+              <a:rPr lang="en-US" sz="900" i="1" dirty="0">
+                <a:solidFill>
+                  <a:schemeClr val="accent4"/>
+                </a:solidFill>
+              </a:rPr>
+              <a:t>Source: store dashboard (Jan 1 – Oct 13, 2026), Klaviyo, Google Ads (brand return estimated) and Meta Ads Manager.</a:t>
+            </a:r>
+            <a:endParaRPr lang="en-US" sz="900" dirty="0"/>
+          </a:p>
+        </p:txBody>
+      </p:sp>
+      <p:sp>
+        <p:nvSpPr>
+          <p:cNvPr id="25" name="Slide Number Placeholder 0"/>
+          <p:cNvSpPr>
+            <a:spLocks noGrp="1"/>
+          </p:cNvSpPr>
+          <p:nvPr>
+            <p:ph type="sldNum" sz="quarter" idx="4294967295"/>
+          </p:nvPr>
+        </p:nvSpPr>
+        <p:spPr>
+          <a:xfrm>
+            <a:off x="8321040" y="4800600"/>
+            <a:ext cx="365760" cy="228600"/>
+          </a:xfrm>
+          <a:prstGeom prst="rect">
+            <a:avLst/>
+          </a:prstGeom>
+          <a:extLst>
+            <a:ext uri="{C572A759-6A51-4108-AA02-DFA0A04FC94B}">
+              <ma14:wrappingTextBoxFlag xmlns:ma14="http://schemas.microsoft.com/office/mac/drawingml/2011/main" val="0"/>
+            </a:ext>
+          </a:extLst>
+        </p:spPr>
+        <p:txBody>
+          <a:bodyPr/>
+          <a:lstStyle>
+            <a:lvl1pPr>
+              <a:defRPr sz="900">
+                <a:solidFill>
+                  <a:schemeClr val="accent4"/>
+                </a:solidFill>
+              </a:defRPr>
+            </a:lvl1pPr>
+          </a:lstStyle>
+          <a:p>
+            <a:pPr algn="r"/>
+            <a:fld id="{F7021451-1387-4CA6-816F-3879F97B5CBC}" type="slidenum">
+              <a:rPr b="0" lang="en-US"/>
+              <a:t>4</a:t>
+            </a:fld>
+            <a:endParaRPr lang="en-US"/>
+          </a:p>
+        </p:txBody>
+      </p:sp>
+    </p:spTree>
+  </p:cSld>
+  <p:clrMapOvr>
+    <a:masterClrMapping/>
+  </p:clrMapOvr>
+</p:sld>
+</file>
+
+<file path=ppt/slides/slide5.xml><?xml version="1.0" encoding="utf-8"?>
+<p:sld xmlns:a="http://schemas.openxmlformats.org/drawingml/2006/main" xmlns:r="http://schemas.openxmlformats.org/officeDocument/2006/relationships" xmlns:p="http://schemas.openxmlformats.org/presentationml/2006/main">
+  <p:cSld name="Slide 5">
+    <p:spTree>
+      <p:nvGrpSpPr>
+        <p:cNvPr id="1" name=""/>
+        <p:cNvGrpSpPr/>
+        <p:nvPr/>
+      </p:nvGrpSpPr>
+      <p:grpSpPr>
+        <a:xfrm>
+          <a:off x="0" y="0"/>
+          <a:ext cx="0" cy="0"/>
+          <a:chOff x="0" y="0"/>
+          <a:chExt cx="0" cy="0"/>
+        </a:xfrm>
+      </p:grpSpPr>
+      <p:sp>
+        <p:nvSpPr>
+          <p:cNvPr id="2" name="Text 0"/>
+          <p:cNvSpPr/>
+          <p:nvPr>
+            <p:ph idx="100" type="title" hasCustomPrompt="1"/>
+          </p:nvPr>
+        </p:nvSpPr>
+        <p:spPr>
+          <a:xfrm>
+            <a:off x="457200" y="274320"/>
+            <a:ext cx="8229600" cy="594360"/>
+          </a:xfrm>
+          <a:prstGeom prst="rect">
+            <a:avLst/>
+          </a:prstGeom>
+          <a:noFill/>
+          <a:ln/>
+        </p:spPr>
+        <p:txBody>
+          <a:bodyPr wrap="square" lIns="0" tIns="0" rIns="0" bIns="0" rtlCol="0" anchor="ctr"/>
+          <a:lstStyle/>
+          <a:p>
+            <a:pPr algn="l" indent="0" marL="0">
+              <a:buNone/>
+            </a:pPr>
+            <a:r>
+              <a:rPr lang="en-US" sz="2600" b="1" dirty="0">
+                <a:solidFill>
+                  <a:schemeClr val="tx1"/>
+                </a:solidFill>
+                <a:latin typeface="Cambria" pitchFamily="34" charset="0"/>
+                <a:ea typeface="Cambria" pitchFamily="34" charset="-122"/>
+                <a:cs typeface="Cambria" pitchFamily="34" charset="-120"/>
+              </a:rPr>
               <a:t>October 9 commitments: status by brand</a:t>
             </a:r>
             <a:endParaRPr lang="en-US" sz="2600" dirty="0"/>
@@ -4554,7 +5564,7 @@
       </p:sp>
       <p:graphicFrame>
         <p:nvGraphicFramePr>
-          <p:cNvPr id="5" name="Commitment tracker"/>
+          <p:cNvPr id="6" name="Commitment tracker"/>
           <p:cNvGraphicFramePr>
             <a:graphicFrameLocks noGrp="1"/>
           </p:cNvGraphicFramePr>
@@ -7363,381 +8373,6 @@
             <a:pPr algn="r"/>
             <a:fld id="{F7021451-1387-4CA6-816F-3879F97B5CBC}" type="slidenum">
               <a:rPr b="0" lang="en-US"/>
-              <a:t>4</a:t>
-            </a:fld>
-            <a:endParaRPr lang="en-US"/>
-          </a:p>
-        </p:txBody>
-      </p:sp>
-    </p:spTree>
-  </p:cSld>
-  <p:clrMapOvr>
-    <a:masterClrMapping/>
-  </p:clrMapOvr>
-</p:sld>
-</file>
-
-<file path=ppt/slides/slide5.xml><?xml version="1.0" encoding="utf-8"?>
-<p:sld xmlns:a="http://schemas.openxmlformats.org/drawingml/2006/main" xmlns:r="http://schemas.openxmlformats.org/officeDocument/2006/relationships" xmlns:p="http://schemas.openxmlformats.org/presentationml/2006/main">
-  <p:cSld name="Slide 5">
-    <p:spTree>
-      <p:nvGrpSpPr>
-        <p:cNvPr id="1" name=""/>
-        <p:cNvGrpSpPr/>
-        <p:nvPr/>
-      </p:nvGrpSpPr>
-      <p:grpSpPr>
-        <a:xfrm>
-          <a:off x="0" y="0"/>
-          <a:ext cx="0" cy="0"/>
-          <a:chOff x="0" y="0"/>
-          <a:chExt cx="0" cy="0"/>
-        </a:xfrm>
-      </p:grpSpPr>
-      <p:sp>
-        <p:nvSpPr>
-          <p:cNvPr id="2" name="Text 0"/>
-          <p:cNvSpPr/>
-          <p:nvPr>
-            <p:ph idx="100" type="title" hasCustomPrompt="1"/>
-          </p:nvPr>
-        </p:nvSpPr>
-        <p:spPr>
-          <a:xfrm>
-            <a:off x="457200" y="274320"/>
-            <a:ext cx="8229600" cy="594360"/>
-          </a:xfrm>
-          <a:prstGeom prst="rect">
-            <a:avLst/>
-          </a:prstGeom>
-          <a:noFill/>
-          <a:ln/>
-        </p:spPr>
-        <p:txBody>
-          <a:bodyPr wrap="square" lIns="0" tIns="0" rIns="0" bIns="0" rtlCol="0" anchor="ctr"/>
-          <a:lstStyle/>
-          <a:p>
-            <a:pPr algn="l" indent="0" marL="0">
-              <a:buNone/>
-            </a:pPr>
-            <a:r>
-              <a:rPr lang="en-US" sz="2600" b="1" dirty="0">
-                <a:solidFill>
-                  <a:schemeClr val="tx1"/>
-                </a:solidFill>
-                <a:latin typeface="Cambria" pitchFamily="34" charset="0"/>
-                <a:ea typeface="Cambria" pitchFamily="34" charset="-122"/>
-                <a:cs typeface="Cambria" pitchFamily="34" charset="-120"/>
-              </a:rPr>
-              <a:t>Meta: more volume, efficiency still being built</a:t>
-            </a:r>
-            <a:endParaRPr lang="en-US" sz="2600" dirty="0"/>
-          </a:p>
-        </p:txBody>
-      </p:sp>
-      <p:graphicFrame>
-        <p:nvGraphicFramePr>
-          <p:cNvPr id="3" name="Purchases chart" descr=""/>
-          <p:cNvGraphicFramePr/>
-          <p:nvPr/>
-        </p:nvGraphicFramePr>
-        <p:xfrm>
-          <a:off x="457200" y="960120"/>
-          <a:ext cx="4206240" cy="3429000"/>
-        </p:xfrm>
-        <a:graphic xmlns:a="http://schemas.openxmlformats.org/drawingml/2006/main">
-          <a:graphicData uri="http://schemas.openxmlformats.org/drawingml/2006/chart">
-            <c:chart xmlns:c="http://schemas.openxmlformats.org/drawingml/2006/chart" r:id="rId1"/>
-          </a:graphicData>
-        </a:graphic>
-      </p:graphicFrame>
-      <p:sp>
-        <p:nvSpPr>
-          <p:cNvPr id="4" name="Text 1"/>
-          <p:cNvSpPr txBox="1"/>
-          <p:nvPr/>
-        </p:nvSpPr>
-        <p:spPr>
-          <a:xfrm>
-            <a:off x="4937760" y="1005840"/>
-            <a:ext cx="3749040" cy="320040"/>
-          </a:xfrm>
-          <a:prstGeom prst="rect">
-            <a:avLst/>
-          </a:prstGeom>
-          <a:noFill/>
-          <a:ln/>
-        </p:spPr>
-        <p:txBody>
-          <a:bodyPr wrap="square" lIns="0" tIns="0" rIns="0" bIns="0" rtlCol="0" anchor="ctr"/>
-          <a:lstStyle/>
-          <a:p>
-            <a:pPr indent="0" marL="0">
-              <a:buNone/>
-            </a:pPr>
-            <a:r>
-              <a:rPr lang="en-US" sz="1500" b="1" dirty="0">
-                <a:solidFill>
-                  <a:schemeClr val="accent2"/>
-                </a:solidFill>
-                <a:latin typeface="Cambria" pitchFamily="34" charset="0"/>
-                <a:ea typeface="Cambria" pitchFamily="34" charset="-122"/>
-                <a:cs typeface="Cambria" pitchFamily="34" charset="-120"/>
-              </a:rPr>
-              <a:t>What's working</a:t>
-            </a:r>
-            <a:endParaRPr lang="en-US" sz="1500" dirty="0"/>
-          </a:p>
-        </p:txBody>
-      </p:sp>
-      <p:sp>
-        <p:nvSpPr>
-          <p:cNvPr id="5" name="Text 2"/>
-          <p:cNvSpPr txBox="1"/>
-          <p:nvPr/>
-        </p:nvSpPr>
-        <p:spPr>
-          <a:xfrm>
-            <a:off x="4937760" y="1371600"/>
-            <a:ext cx="3749040" cy="1152144"/>
-          </a:xfrm>
-          <a:prstGeom prst="rect">
-            <a:avLst/>
-          </a:prstGeom>
-          <a:noFill/>
-          <a:ln/>
-        </p:spPr>
-        <p:txBody>
-          <a:bodyPr wrap="square" lIns="0" tIns="0" rIns="0" bIns="0" rtlCol="0" anchor="t"/>
-          <a:lstStyle/>
-          <a:p>
-            <a:pPr marL="342900" indent="-342900">
-              <a:spcAft>
-                <a:spcPts val="400"/>
-              </a:spcAft>
-              <a:buSzPct val="100000"/>
-              <a:buChar char="•"/>
-            </a:pPr>
-            <a:r>
-              <a:rPr lang="en-US" sz="1200" dirty="0">
-                <a:solidFill>
-                  <a:schemeClr val="tx1"/>
-                </a:solidFill>
-              </a:rPr>
-              <a:t>Ayoba new customers: $26 per purchase, 1.6x return</a:t>
-            </a:r>
-            <a:endParaRPr lang="en-US" sz="1200" dirty="0"/>
-          </a:p>
-          <a:p>
-            <a:pPr marL="342900" indent="-342900">
-              <a:spcAft>
-                <a:spcPts val="400"/>
-              </a:spcAft>
-              <a:buSzPct val="100000"/>
-              <a:buChar char="•"/>
-            </a:pPr>
-            <a:r>
-              <a:rPr lang="en-US" sz="1200" dirty="0">
-                <a:solidFill>
-                  <a:schemeClr val="tx1"/>
-                </a:solidFill>
-              </a:rPr>
-              <a:t>Brooklyn dynamic retargeting: $26 per purchase, 2.9x return</a:t>
-            </a:r>
-            <a:endParaRPr lang="en-US" sz="1200" dirty="0"/>
-          </a:p>
-          <a:p>
-            <a:pPr marL="342900" indent="-342900">
-              <a:spcAft>
-                <a:spcPts val="400"/>
-              </a:spcAft>
-              <a:buSzPct val="100000"/>
-              <a:buChar char="•"/>
-            </a:pPr>
-            <a:r>
-              <a:rPr lang="en-US" sz="1200" dirty="0">
-                <a:solidFill>
-                  <a:schemeClr val="tx1"/>
-                </a:solidFill>
-              </a:rPr>
-              <a:t>Beg &amp; Barker dynamic retargeting: 3.1x return</a:t>
-            </a:r>
-            <a:endParaRPr lang="en-US" sz="1200" dirty="0"/>
-          </a:p>
-        </p:txBody>
-      </p:sp>
-      <p:sp>
-        <p:nvSpPr>
-          <p:cNvPr id="6" name="Text 3"/>
-          <p:cNvSpPr txBox="1"/>
-          <p:nvPr/>
-        </p:nvSpPr>
-        <p:spPr>
-          <a:xfrm>
-            <a:off x="4937760" y="2697480"/>
-            <a:ext cx="3749040" cy="320040"/>
-          </a:xfrm>
-          <a:prstGeom prst="rect">
-            <a:avLst/>
-          </a:prstGeom>
-          <a:noFill/>
-          <a:ln/>
-        </p:spPr>
-        <p:txBody>
-          <a:bodyPr wrap="square" lIns="0" tIns="0" rIns="0" bIns="0" rtlCol="0" anchor="ctr"/>
-          <a:lstStyle/>
-          <a:p>
-            <a:pPr indent="0" marL="0">
-              <a:buNone/>
-            </a:pPr>
-            <a:r>
-              <a:rPr lang="en-US" sz="1500" b="1" dirty="0">
-                <a:solidFill>
-                  <a:schemeClr val="accent1"/>
-                </a:solidFill>
-                <a:latin typeface="Cambria" pitchFamily="34" charset="0"/>
-                <a:ea typeface="Cambria" pitchFamily="34" charset="-122"/>
-                <a:cs typeface="Cambria" pitchFamily="34" charset="-120"/>
-              </a:rPr>
-              <a:t>What we're fixing</a:t>
-            </a:r>
-            <a:endParaRPr lang="en-US" sz="1500" dirty="0"/>
-          </a:p>
-        </p:txBody>
-      </p:sp>
-      <p:sp>
-        <p:nvSpPr>
-          <p:cNvPr id="7" name="Text 4"/>
-          <p:cNvSpPr txBox="1"/>
-          <p:nvPr/>
-        </p:nvSpPr>
-        <p:spPr>
-          <a:xfrm>
-            <a:off x="4937760" y="3063240"/>
-            <a:ext cx="3749040" cy="768096"/>
-          </a:xfrm>
-          <a:prstGeom prst="rect">
-            <a:avLst/>
-          </a:prstGeom>
-          <a:noFill/>
-          <a:ln/>
-        </p:spPr>
-        <p:txBody>
-          <a:bodyPr wrap="square" lIns="0" tIns="0" rIns="0" bIns="0" rtlCol="0" anchor="t"/>
-          <a:lstStyle/>
-          <a:p>
-            <a:pPr marL="342900" indent="-342900">
-              <a:spcAft>
-                <a:spcPts val="400"/>
-              </a:spcAft>
-              <a:buSzPct val="100000"/>
-              <a:buChar char="•"/>
-            </a:pPr>
-            <a:r>
-              <a:rPr lang="en-US" sz="1200" dirty="0">
-                <a:solidFill>
-                  <a:schemeClr val="tx1"/>
-                </a:solidFill>
-              </a:rPr>
-              <a:t>Brooklyn new customers: $170 per purchase → budget trimmed on Oct 13</a:t>
-            </a:r>
-            <a:endParaRPr lang="en-US" sz="1200" dirty="0"/>
-          </a:p>
-          <a:p>
-            <a:pPr marL="342900" indent="-342900">
-              <a:spcAft>
-                <a:spcPts val="400"/>
-              </a:spcAft>
-              <a:buSzPct val="100000"/>
-              <a:buChar char="•"/>
-            </a:pPr>
-            <a:r>
-              <a:rPr lang="en-US" sz="1200" dirty="0">
-                <a:solidFill>
-                  <a:schemeClr val="tx1"/>
-                </a:solidFill>
-              </a:rPr>
-              <a:t>New retargeting (since Oct 10) is still learning; budget raised for Ayoba and Beg &amp; Barker</a:t>
-            </a:r>
-            <a:endParaRPr lang="en-US" sz="1200" dirty="0"/>
-          </a:p>
-        </p:txBody>
-      </p:sp>
-      <p:sp>
-        <p:nvSpPr>
-          <p:cNvPr id="8" name="Text 5"/>
-          <p:cNvSpPr txBox="1"/>
-          <p:nvPr/>
-        </p:nvSpPr>
-        <p:spPr>
-          <a:xfrm>
-            <a:off x="457200" y="4434840"/>
-            <a:ext cx="8229600" cy="274320"/>
-          </a:xfrm>
-          <a:prstGeom prst="rect">
-            <a:avLst/>
-          </a:prstGeom>
-          <a:noFill/>
-          <a:ln/>
-        </p:spPr>
-        <p:txBody>
-          <a:bodyPr wrap="square" lIns="0" tIns="0" rIns="0" bIns="0" rtlCol="0" anchor="ctr"/>
-          <a:lstStyle/>
-          <a:p>
-            <a:pPr indent="0" marL="0">
-              <a:buNone/>
-            </a:pPr>
-            <a:r>
-              <a:rPr lang="en-US" sz="900" i="1" dirty="0">
-                <a:solidFill>
-                  <a:schemeClr val="accent4"/>
-                </a:solidFill>
-              </a:rPr>
-              <a:t>Source: Meta Ads Manager, platform-attributed purchases and return. Excludes Google Ads and total store sales (see dashboards).</a:t>
-            </a:r>
-            <a:endParaRPr lang="en-US" sz="900" dirty="0"/>
-          </a:p>
-        </p:txBody>
-      </p:sp>
-      <p:sp>
-        <p:nvSpPr>
-          <p:cNvPr id="25" name="Slide Number Placeholder 0"/>
-          <p:cNvSpPr>
-            <a:spLocks noGrp="1"/>
-          </p:cNvSpPr>
-          <p:nvPr>
-            <p:ph type="sldNum" sz="quarter" idx="4294967295"/>
-          </p:nvPr>
-        </p:nvSpPr>
-        <p:spPr>
-          <a:xfrm>
-            <a:off x="8321040" y="4800600"/>
-            <a:ext cx="365760" cy="228600"/>
-          </a:xfrm>
-          <a:prstGeom prst="rect">
-            <a:avLst/>
-          </a:prstGeom>
-          <a:extLst>
-            <a:ext uri="{C572A759-6A51-4108-AA02-DFA0A04FC94B}">
-              <ma14:wrappingTextBoxFlag xmlns:ma14="http://schemas.microsoft.com/office/mac/drawingml/2011/main" val="0"/>
-            </a:ext>
-          </a:extLst>
-        </p:spPr>
-        <p:txBody>
-          <a:bodyPr/>
-          <a:lstStyle>
-            <a:lvl1pPr>
-              <a:defRPr sz="900">
-                <a:solidFill>
-                  <a:schemeClr val="accent4"/>
-                </a:solidFill>
-              </a:defRPr>
-            </a:lvl1pPr>
-          </a:lstStyle>
-          <a:p>
-            <a:pPr algn="r"/>
-            <a:fld id="{F7021451-1387-4CA6-816F-3879F97B5CBC}" type="slidenum">
-              <a:rPr b="0" lang="en-US"/>
               <a:t>5</a:t>
             </a:fld>
             <a:endParaRPr lang="en-US"/>
@@ -7804,207 +8439,21 @@
                 <a:ea typeface="Cambria" pitchFamily="34" charset="-122"/>
                 <a:cs typeface="Cambria" pitchFamily="34" charset="-120"/>
               </a:rPr>
-              <a:t>Brooklyn: email and SMS are driving repeat sales</a:t>
+              <a:t>Meta: more volume, efficiency still being built</a:t>
             </a:r>
             <a:endParaRPr lang="en-US" sz="2600" dirty="0"/>
           </a:p>
         </p:txBody>
       </p:sp>
-      <p:sp>
-        <p:nvSpPr>
-          <p:cNvPr id="3" name="Retention stat panel"/>
-          <p:cNvSpPr/>
-          <p:nvPr/>
-        </p:nvSpPr>
-        <p:spPr>
-          <a:xfrm>
-            <a:off x="457200" y="1005840"/>
-            <a:ext cx="3108960" cy="3291840"/>
-          </a:xfrm>
-          <a:prstGeom prst="roundRect">
-            <a:avLst>
-              <a:gd name="adj" fmla="val 2353"/>
-            </a:avLst>
-          </a:prstGeom>
-          <a:solidFill>
-            <a:schemeClr val="tx1"/>
-          </a:solidFill>
-          <a:ln/>
-        </p:spPr>
-      </p:sp>
-      <p:sp>
-        <p:nvSpPr>
-          <p:cNvPr id="4" name="Text 2"/>
-          <p:cNvSpPr txBox="1"/>
-          <p:nvPr/>
-        </p:nvSpPr>
-        <p:spPr>
-          <a:xfrm>
-            <a:off x="685800" y="1188720"/>
-            <a:ext cx="2651760" cy="685800"/>
-          </a:xfrm>
-          <a:prstGeom prst="rect">
-            <a:avLst/>
-          </a:prstGeom>
-          <a:noFill/>
-          <a:ln/>
-        </p:spPr>
-        <p:txBody>
-          <a:bodyPr wrap="square" lIns="0" tIns="0" rIns="0" bIns="0" rtlCol="0" anchor="ctr"/>
-          <a:lstStyle/>
-          <a:p>
-            <a:pPr indent="0" marL="0">
-              <a:buNone/>
-            </a:pPr>
-            <a:r>
-              <a:rPr lang="en-US" sz="4000" b="1" dirty="0">
-                <a:solidFill>
-                  <a:schemeClr val="bg1"/>
-                </a:solidFill>
-                <a:latin typeface="Cambria" pitchFamily="34" charset="0"/>
-                <a:ea typeface="Cambria" pitchFamily="34" charset="-122"/>
-                <a:cs typeface="Cambria" pitchFamily="34" charset="-120"/>
-              </a:rPr>
-              <a:t>$2,074</a:t>
-            </a:r>
-            <a:endParaRPr lang="en-US" sz="4000" dirty="0"/>
-          </a:p>
-        </p:txBody>
-      </p:sp>
-      <p:sp>
-        <p:nvSpPr>
-          <p:cNvPr id="5" name="Text 3"/>
-          <p:cNvSpPr txBox="1"/>
-          <p:nvPr/>
-        </p:nvSpPr>
-        <p:spPr>
-          <a:xfrm>
-            <a:off x="685800" y="1874520"/>
-            <a:ext cx="2651760" cy="457200"/>
-          </a:xfrm>
-          <a:prstGeom prst="rect">
-            <a:avLst/>
-          </a:prstGeom>
-          <a:noFill/>
-          <a:ln/>
-        </p:spPr>
-        <p:txBody>
-          <a:bodyPr wrap="square" lIns="0" tIns="0" rIns="0" bIns="0" rtlCol="0" anchor="ctr"/>
-          <a:lstStyle/>
-          <a:p>
-            <a:pPr indent="0" marL="0">
-              <a:buNone/>
-            </a:pPr>
-            <a:r>
-              <a:rPr lang="en-US" sz="1200" dirty="0">
-                <a:solidFill>
-                  <a:schemeClr val="accent6"/>
-                </a:solidFill>
-              </a:rPr>
-              <a:t>in email and SMS-attributed sales,</a:t>
-            </a:r>
-            <a:endParaRPr lang="en-US" sz="1200" dirty="0"/>
-          </a:p>
-          <a:p>
-            <a:pPr indent="0" marL="0">
-              <a:buNone/>
-            </a:pPr>
-            <a:r>
-              <a:rPr lang="en-US" sz="1200" dirty="0">
-                <a:solidFill>
-                  <a:schemeClr val="accent6"/>
-                </a:solidFill>
-              </a:rPr>
-              <a:t>Oct 1–14</a:t>
-            </a:r>
-            <a:endParaRPr lang="en-US" sz="1200" dirty="0"/>
-          </a:p>
-        </p:txBody>
-      </p:sp>
-      <p:sp>
-        <p:nvSpPr>
-          <p:cNvPr id="6" name="Text 4"/>
-          <p:cNvSpPr txBox="1"/>
-          <p:nvPr/>
-        </p:nvSpPr>
-        <p:spPr>
-          <a:xfrm>
-            <a:off x="685800" y="2468880"/>
-            <a:ext cx="2651760" cy="685800"/>
-          </a:xfrm>
-          <a:prstGeom prst="rect">
-            <a:avLst/>
-          </a:prstGeom>
-          <a:noFill/>
-          <a:ln/>
-        </p:spPr>
-        <p:txBody>
-          <a:bodyPr wrap="square" lIns="0" tIns="0" rIns="0" bIns="0" rtlCol="0" anchor="ctr"/>
-          <a:lstStyle/>
-          <a:p>
-            <a:pPr indent="0" marL="0">
-              <a:buNone/>
-            </a:pPr>
-            <a:r>
-              <a:rPr lang="en-US" sz="4000" b="1" dirty="0">
-                <a:solidFill>
-                  <a:schemeClr val="bg1"/>
-                </a:solidFill>
-                <a:latin typeface="Cambria" pitchFamily="34" charset="0"/>
-                <a:ea typeface="Cambria" pitchFamily="34" charset="-122"/>
-                <a:cs typeface="Cambria" pitchFamily="34" charset="-120"/>
-              </a:rPr>
-              <a:t>31</a:t>
-            </a:r>
-            <a:endParaRPr lang="en-US" sz="4000" dirty="0"/>
-          </a:p>
-        </p:txBody>
-      </p:sp>
-      <p:sp>
-        <p:nvSpPr>
-          <p:cNvPr id="7" name="Text 5"/>
-          <p:cNvSpPr txBox="1"/>
-          <p:nvPr/>
-        </p:nvSpPr>
-        <p:spPr>
-          <a:xfrm>
-            <a:off x="685800" y="3154680"/>
-            <a:ext cx="2651760" cy="457200"/>
-          </a:xfrm>
-          <a:prstGeom prst="rect">
-            <a:avLst/>
-          </a:prstGeom>
-          <a:noFill/>
-          <a:ln/>
-        </p:spPr>
-        <p:txBody>
-          <a:bodyPr wrap="square" lIns="0" tIns="0" rIns="0" bIns="0" rtlCol="0" anchor="ctr"/>
-          <a:lstStyle/>
-          <a:p>
-            <a:pPr indent="0" marL="0">
-              <a:buNone/>
-            </a:pPr>
-            <a:r>
-              <a:rPr lang="en-US" sz="1200" dirty="0">
-                <a:solidFill>
-                  <a:schemeClr val="accent6"/>
-                </a:solidFill>
-              </a:rPr>
-              <a:t>orders; 17 came in automatically through flows</a:t>
-            </a:r>
-            <a:endParaRPr lang="en-US" sz="1200" dirty="0"/>
-          </a:p>
-        </p:txBody>
-      </p:sp>
       <p:graphicFrame>
         <p:nvGraphicFramePr>
-          <p:cNvPr id="8" name="Sales by program chart" descr=""/>
+          <p:cNvPr id="3" name="Purchases chart" descr=""/>
           <p:cNvGraphicFramePr/>
           <p:nvPr/>
         </p:nvGraphicFramePr>
         <p:xfrm>
-          <a:off x="3840480" y="960120"/>
-          <a:ext cx="4846320" cy="2743200"/>
+          <a:off x="457200" y="960120"/>
+          <a:ext cx="4206240" cy="3429000"/>
         </p:xfrm>
         <a:graphic xmlns:a="http://schemas.openxmlformats.org/drawingml/2006/main">
           <a:graphicData uri="http://schemas.openxmlformats.org/drawingml/2006/chart">
@@ -8014,14 +8463,14 @@
       </p:graphicFrame>
       <p:sp>
         <p:nvSpPr>
-          <p:cNvPr id="9" name="Text 6"/>
+          <p:cNvPr id="4" name="Text 1"/>
           <p:cNvSpPr txBox="1"/>
           <p:nvPr/>
         </p:nvSpPr>
         <p:spPr>
           <a:xfrm>
-            <a:off x="3931920" y="3749040"/>
-            <a:ext cx="4754880" cy="548640"/>
+            <a:off x="4937760" y="1005840"/>
+            <a:ext cx="3749040" cy="320040"/>
           </a:xfrm>
           <a:prstGeom prst="rect">
             <a:avLst/>
@@ -8030,27 +8479,203 @@
           <a:ln/>
         </p:spPr>
         <p:txBody>
-          <a:bodyPr wrap="square" lIns="0" tIns="0" rIns="0" bIns="0" rtlCol="0" anchor="t"/>
+          <a:bodyPr wrap="square" lIns="0" tIns="0" rIns="0" bIns="0" rtlCol="0" anchor="ctr"/>
           <a:lstStyle/>
           <a:p>
             <a:pPr indent="0" marL="0">
               <a:buNone/>
             </a:pPr>
             <a:r>
+              <a:rPr lang="en-US" sz="1500" b="1" dirty="0">
+                <a:solidFill>
+                  <a:schemeClr val="accent2"/>
+                </a:solidFill>
+                <a:latin typeface="Cambria" pitchFamily="34" charset="0"/>
+                <a:ea typeface="Cambria" pitchFamily="34" charset="-122"/>
+                <a:cs typeface="Cambria" pitchFamily="34" charset="-120"/>
+              </a:rPr>
+              <a:t>What's working</a:t>
+            </a:r>
+            <a:endParaRPr lang="en-US" sz="1500" dirty="0"/>
+          </a:p>
+        </p:txBody>
+      </p:sp>
+      <p:sp>
+        <p:nvSpPr>
+          <p:cNvPr id="5" name="Text 2"/>
+          <p:cNvSpPr txBox="1"/>
+          <p:nvPr/>
+        </p:nvSpPr>
+        <p:spPr>
+          <a:xfrm>
+            <a:off x="4937760" y="1371600"/>
+            <a:ext cx="3749040" cy="1152144"/>
+          </a:xfrm>
+          <a:prstGeom prst="rect">
+            <a:avLst/>
+          </a:prstGeom>
+          <a:noFill/>
+          <a:ln/>
+        </p:spPr>
+        <p:txBody>
+          <a:bodyPr wrap="square" lIns="0" tIns="0" rIns="0" bIns="0" rtlCol="0" anchor="t"/>
+          <a:lstStyle/>
+          <a:p>
+            <a:pPr marL="342900" indent="-342900">
+              <a:spcAft>
+                <a:spcPts val="400"/>
+              </a:spcAft>
+              <a:buSzPct val="100000"/>
+              <a:buChar char="•"/>
+            </a:pPr>
+            <a:r>
               <a:rPr lang="en-US" sz="1200" dirty="0">
                 <a:solidFill>
                   <a:schemeClr val="tx1"/>
                 </a:solidFill>
               </a:rPr>
-              <a:t>Game Day had a 60% open rate. The Subscribe &amp; Save and Second Order flows have been live since Oct 7.</a:t>
+              <a:t>Ayoba new customers: $26 per purchase, 1.6x return</a:t>
             </a:r>
             <a:endParaRPr lang="en-US" sz="1200" dirty="0"/>
           </a:p>
+          <a:p>
+            <a:pPr marL="342900" indent="-342900">
+              <a:spcAft>
+                <a:spcPts val="400"/>
+              </a:spcAft>
+              <a:buSzPct val="100000"/>
+              <a:buChar char="•"/>
+            </a:pPr>
+            <a:r>
+              <a:rPr lang="en-US" sz="1200" dirty="0">
+                <a:solidFill>
+                  <a:schemeClr val="tx1"/>
+                </a:solidFill>
+              </a:rPr>
+              <a:t>Brooklyn dynamic retargeting: $26 per purchase, 2.9x return</a:t>
+            </a:r>
+            <a:endParaRPr lang="en-US" sz="1200" dirty="0"/>
+          </a:p>
+          <a:p>
+            <a:pPr marL="342900" indent="-342900">
+              <a:spcAft>
+                <a:spcPts val="400"/>
+              </a:spcAft>
+              <a:buSzPct val="100000"/>
+              <a:buChar char="•"/>
+            </a:pPr>
+            <a:r>
+              <a:rPr lang="en-US" sz="1200" dirty="0">
+                <a:solidFill>
+                  <a:schemeClr val="tx1"/>
+                </a:solidFill>
+              </a:rPr>
+              <a:t>Beg &amp; Barker dynamic retargeting: 3.1x return</a:t>
+            </a:r>
+            <a:endParaRPr lang="en-US" sz="1200" dirty="0"/>
+          </a:p>
         </p:txBody>
       </p:sp>
       <p:sp>
         <p:nvSpPr>
-          <p:cNvPr id="10" name="Text 7"/>
+          <p:cNvPr id="6" name="Text 3"/>
+          <p:cNvSpPr txBox="1"/>
+          <p:nvPr/>
+        </p:nvSpPr>
+        <p:spPr>
+          <a:xfrm>
+            <a:off x="4937760" y="2697480"/>
+            <a:ext cx="3749040" cy="320040"/>
+          </a:xfrm>
+          <a:prstGeom prst="rect">
+            <a:avLst/>
+          </a:prstGeom>
+          <a:noFill/>
+          <a:ln/>
+        </p:spPr>
+        <p:txBody>
+          <a:bodyPr wrap="square" lIns="0" tIns="0" rIns="0" bIns="0" rtlCol="0" anchor="ctr"/>
+          <a:lstStyle/>
+          <a:p>
+            <a:pPr indent="0" marL="0">
+              <a:buNone/>
+            </a:pPr>
+            <a:r>
+              <a:rPr lang="en-US" sz="1500" b="1" dirty="0">
+                <a:solidFill>
+                  <a:schemeClr val="accent1"/>
+                </a:solidFill>
+                <a:latin typeface="Cambria" pitchFamily="34" charset="0"/>
+                <a:ea typeface="Cambria" pitchFamily="34" charset="-122"/>
+                <a:cs typeface="Cambria" pitchFamily="34" charset="-120"/>
+              </a:rPr>
+              <a:t>What we're fixing</a:t>
+            </a:r>
+            <a:endParaRPr lang="en-US" sz="1500" dirty="0"/>
+          </a:p>
+        </p:txBody>
+      </p:sp>
+      <p:sp>
+        <p:nvSpPr>
+          <p:cNvPr id="7" name="Text 4"/>
+          <p:cNvSpPr txBox="1"/>
+          <p:nvPr/>
+        </p:nvSpPr>
+        <p:spPr>
+          <a:xfrm>
+            <a:off x="4937760" y="3063240"/>
+            <a:ext cx="3749040" cy="768096"/>
+          </a:xfrm>
+          <a:prstGeom prst="rect">
+            <a:avLst/>
+          </a:prstGeom>
+          <a:noFill/>
+          <a:ln/>
+        </p:spPr>
+        <p:txBody>
+          <a:bodyPr wrap="square" lIns="0" tIns="0" rIns="0" bIns="0" rtlCol="0" anchor="t"/>
+          <a:lstStyle/>
+          <a:p>
+            <a:pPr marL="342900" indent="-342900">
+              <a:spcAft>
+                <a:spcPts val="400"/>
+              </a:spcAft>
+              <a:buSzPct val="100000"/>
+              <a:buChar char="•"/>
+            </a:pPr>
+            <a:r>
+              <a:rPr lang="en-US" sz="1200" dirty="0">
+                <a:solidFill>
+                  <a:schemeClr val="tx1"/>
+                </a:solidFill>
+              </a:rPr>
+              <a:t>Brooklyn new customers: $170 per purchase → budget trimmed on Oct 13</a:t>
+            </a:r>
+            <a:endParaRPr lang="en-US" sz="1200" dirty="0"/>
+          </a:p>
+          <a:p>
+            <a:pPr marL="342900" indent="-342900">
+              <a:spcAft>
+                <a:spcPts val="400"/>
+              </a:spcAft>
+              <a:buSzPct val="100000"/>
+              <a:buChar char="•"/>
+            </a:pPr>
+            <a:r>
+              <a:rPr lang="en-US" sz="1200" dirty="0">
+                <a:solidFill>
+                  <a:schemeClr val="tx1"/>
+                </a:solidFill>
+              </a:rPr>
+              <a:t>New retargeting (since Oct 10) is still learning; budget raised for Ayoba and Beg &amp; Barker</a:t>
+            </a:r>
+            <a:endParaRPr lang="en-US" sz="1200" dirty="0"/>
+          </a:p>
+        </p:txBody>
+      </p:sp>
+      <p:sp>
+        <p:nvSpPr>
+          <p:cNvPr id="8" name="Text 5"/>
           <p:cNvSpPr txBox="1"/>
           <p:nvPr/>
         </p:nvSpPr>
@@ -8078,7 +8703,7 @@
                   <a:schemeClr val="accent4"/>
                 </a:solidFill>
               </a:rPr>
-              <a:t>Source: Klaviyo (Brooklyn Biltong), platform-attributed orders.</a:t>
+              <a:t>Source: Meta Ads Manager, platform-attributed purchases and return. Excludes Google Ads and total store sales (see dashboards).</a:t>
             </a:r>
             <a:endParaRPr lang="en-US" sz="900" dirty="0"/>
           </a:p>
@@ -8189,6 +8814,391 @@
                 <a:ea typeface="Cambria" pitchFamily="34" charset="-122"/>
                 <a:cs typeface="Cambria" pitchFamily="34" charset="-120"/>
               </a:rPr>
+              <a:t>Brooklyn: email and SMS are driving repeat sales</a:t>
+            </a:r>
+            <a:endParaRPr lang="en-US" sz="2600" dirty="0"/>
+          </a:p>
+        </p:txBody>
+      </p:sp>
+      <p:sp>
+        <p:nvSpPr>
+          <p:cNvPr id="3" name="Retention stat panel"/>
+          <p:cNvSpPr/>
+          <p:nvPr/>
+        </p:nvSpPr>
+        <p:spPr>
+          <a:xfrm>
+            <a:off x="457200" y="1005840"/>
+            <a:ext cx="3108960" cy="3291840"/>
+          </a:xfrm>
+          <a:prstGeom prst="roundRect">
+            <a:avLst>
+              <a:gd name="adj" fmla="val 2353"/>
+            </a:avLst>
+          </a:prstGeom>
+          <a:solidFill>
+            <a:schemeClr val="tx1"/>
+          </a:solidFill>
+          <a:ln/>
+        </p:spPr>
+      </p:sp>
+      <p:sp>
+        <p:nvSpPr>
+          <p:cNvPr id="4" name="Text 2"/>
+          <p:cNvSpPr txBox="1"/>
+          <p:nvPr/>
+        </p:nvSpPr>
+        <p:spPr>
+          <a:xfrm>
+            <a:off x="685800" y="1188720"/>
+            <a:ext cx="2651760" cy="685800"/>
+          </a:xfrm>
+          <a:prstGeom prst="rect">
+            <a:avLst/>
+          </a:prstGeom>
+          <a:noFill/>
+          <a:ln/>
+        </p:spPr>
+        <p:txBody>
+          <a:bodyPr wrap="square" lIns="0" tIns="0" rIns="0" bIns="0" rtlCol="0" anchor="ctr"/>
+          <a:lstStyle/>
+          <a:p>
+            <a:pPr indent="0" marL="0">
+              <a:buNone/>
+            </a:pPr>
+            <a:r>
+              <a:rPr lang="en-US" sz="4000" b="1" dirty="0">
+                <a:solidFill>
+                  <a:schemeClr val="bg1"/>
+                </a:solidFill>
+                <a:latin typeface="Cambria" pitchFamily="34" charset="0"/>
+                <a:ea typeface="Cambria" pitchFamily="34" charset="-122"/>
+                <a:cs typeface="Cambria" pitchFamily="34" charset="-120"/>
+              </a:rPr>
+              <a:t>$2,074</a:t>
+            </a:r>
+            <a:endParaRPr lang="en-US" sz="4000" dirty="0"/>
+          </a:p>
+        </p:txBody>
+      </p:sp>
+      <p:sp>
+        <p:nvSpPr>
+          <p:cNvPr id="5" name="Text 3"/>
+          <p:cNvSpPr txBox="1"/>
+          <p:nvPr/>
+        </p:nvSpPr>
+        <p:spPr>
+          <a:xfrm>
+            <a:off x="685800" y="1874520"/>
+            <a:ext cx="2651760" cy="457200"/>
+          </a:xfrm>
+          <a:prstGeom prst="rect">
+            <a:avLst/>
+          </a:prstGeom>
+          <a:noFill/>
+          <a:ln/>
+        </p:spPr>
+        <p:txBody>
+          <a:bodyPr wrap="square" lIns="0" tIns="0" rIns="0" bIns="0" rtlCol="0" anchor="ctr"/>
+          <a:lstStyle/>
+          <a:p>
+            <a:pPr indent="0" marL="0">
+              <a:buNone/>
+            </a:pPr>
+            <a:r>
+              <a:rPr lang="en-US" sz="1200" dirty="0">
+                <a:solidFill>
+                  <a:schemeClr val="accent6"/>
+                </a:solidFill>
+              </a:rPr>
+              <a:t>in email and SMS-attributed sales,</a:t>
+            </a:r>
+            <a:endParaRPr lang="en-US" sz="1200" dirty="0"/>
+          </a:p>
+          <a:p>
+            <a:pPr indent="0" marL="0">
+              <a:buNone/>
+            </a:pPr>
+            <a:r>
+              <a:rPr lang="en-US" sz="1200" dirty="0">
+                <a:solidFill>
+                  <a:schemeClr val="accent6"/>
+                </a:solidFill>
+              </a:rPr>
+              <a:t>Oct 1–14</a:t>
+            </a:r>
+            <a:endParaRPr lang="en-US" sz="1200" dirty="0"/>
+          </a:p>
+        </p:txBody>
+      </p:sp>
+      <p:sp>
+        <p:nvSpPr>
+          <p:cNvPr id="6" name="Text 4"/>
+          <p:cNvSpPr txBox="1"/>
+          <p:nvPr/>
+        </p:nvSpPr>
+        <p:spPr>
+          <a:xfrm>
+            <a:off x="685800" y="2468880"/>
+            <a:ext cx="2651760" cy="685800"/>
+          </a:xfrm>
+          <a:prstGeom prst="rect">
+            <a:avLst/>
+          </a:prstGeom>
+          <a:noFill/>
+          <a:ln/>
+        </p:spPr>
+        <p:txBody>
+          <a:bodyPr wrap="square" lIns="0" tIns="0" rIns="0" bIns="0" rtlCol="0" anchor="ctr"/>
+          <a:lstStyle/>
+          <a:p>
+            <a:pPr indent="0" marL="0">
+              <a:buNone/>
+            </a:pPr>
+            <a:r>
+              <a:rPr lang="en-US" sz="4000" b="1" dirty="0">
+                <a:solidFill>
+                  <a:schemeClr val="bg1"/>
+                </a:solidFill>
+                <a:latin typeface="Cambria" pitchFamily="34" charset="0"/>
+                <a:ea typeface="Cambria" pitchFamily="34" charset="-122"/>
+                <a:cs typeface="Cambria" pitchFamily="34" charset="-120"/>
+              </a:rPr>
+              <a:t>31</a:t>
+            </a:r>
+            <a:endParaRPr lang="en-US" sz="4000" dirty="0"/>
+          </a:p>
+        </p:txBody>
+      </p:sp>
+      <p:sp>
+        <p:nvSpPr>
+          <p:cNvPr id="7" name="Text 5"/>
+          <p:cNvSpPr txBox="1"/>
+          <p:nvPr/>
+        </p:nvSpPr>
+        <p:spPr>
+          <a:xfrm>
+            <a:off x="685800" y="3154680"/>
+            <a:ext cx="2651760" cy="457200"/>
+          </a:xfrm>
+          <a:prstGeom prst="rect">
+            <a:avLst/>
+          </a:prstGeom>
+          <a:noFill/>
+          <a:ln/>
+        </p:spPr>
+        <p:txBody>
+          <a:bodyPr wrap="square" lIns="0" tIns="0" rIns="0" bIns="0" rtlCol="0" anchor="ctr"/>
+          <a:lstStyle/>
+          <a:p>
+            <a:pPr indent="0" marL="0">
+              <a:buNone/>
+            </a:pPr>
+            <a:r>
+              <a:rPr lang="en-US" sz="1200" dirty="0">
+                <a:solidFill>
+                  <a:schemeClr val="accent6"/>
+                </a:solidFill>
+              </a:rPr>
+              <a:t>orders; 17 came in automatically through flows</a:t>
+            </a:r>
+            <a:endParaRPr lang="en-US" sz="1200" dirty="0"/>
+          </a:p>
+        </p:txBody>
+      </p:sp>
+      <p:graphicFrame>
+        <p:nvGraphicFramePr>
+          <p:cNvPr id="8" name="Sales by program chart" descr=""/>
+          <p:cNvGraphicFramePr/>
+          <p:nvPr/>
+        </p:nvGraphicFramePr>
+        <p:xfrm>
+          <a:off x="3840480" y="960120"/>
+          <a:ext cx="4846320" cy="2743200"/>
+        </p:xfrm>
+        <a:graphic xmlns:a="http://schemas.openxmlformats.org/drawingml/2006/main">
+          <a:graphicData uri="http://schemas.openxmlformats.org/drawingml/2006/chart">
+            <c:chart xmlns:c="http://schemas.openxmlformats.org/drawingml/2006/chart" r:id="rId1"/>
+          </a:graphicData>
+        </a:graphic>
+      </p:graphicFrame>
+      <p:sp>
+        <p:nvSpPr>
+          <p:cNvPr id="9" name="Text 6"/>
+          <p:cNvSpPr txBox="1"/>
+          <p:nvPr/>
+        </p:nvSpPr>
+        <p:spPr>
+          <a:xfrm>
+            <a:off x="3931920" y="3749040"/>
+            <a:ext cx="4754880" cy="548640"/>
+          </a:xfrm>
+          <a:prstGeom prst="rect">
+            <a:avLst/>
+          </a:prstGeom>
+          <a:noFill/>
+          <a:ln/>
+        </p:spPr>
+        <p:txBody>
+          <a:bodyPr wrap="square" lIns="0" tIns="0" rIns="0" bIns="0" rtlCol="0" anchor="t"/>
+          <a:lstStyle/>
+          <a:p>
+            <a:pPr indent="0" marL="0">
+              <a:buNone/>
+            </a:pPr>
+            <a:r>
+              <a:rPr lang="en-US" sz="1200" dirty="0">
+                <a:solidFill>
+                  <a:schemeClr val="tx1"/>
+                </a:solidFill>
+              </a:rPr>
+              <a:t>Game Day had a 60% open rate. The Subscribe &amp; Save and Second Order flows have been live since Oct 7.</a:t>
+            </a:r>
+            <a:endParaRPr lang="en-US" sz="1200" dirty="0"/>
+          </a:p>
+        </p:txBody>
+      </p:sp>
+      <p:sp>
+        <p:nvSpPr>
+          <p:cNvPr id="10" name="Text 7"/>
+          <p:cNvSpPr txBox="1"/>
+          <p:nvPr/>
+        </p:nvSpPr>
+        <p:spPr>
+          <a:xfrm>
+            <a:off x="457200" y="4434840"/>
+            <a:ext cx="8229600" cy="274320"/>
+          </a:xfrm>
+          <a:prstGeom prst="rect">
+            <a:avLst/>
+          </a:prstGeom>
+          <a:noFill/>
+          <a:ln/>
+        </p:spPr>
+        <p:txBody>
+          <a:bodyPr wrap="square" lIns="0" tIns="0" rIns="0" bIns="0" rtlCol="0" anchor="ctr"/>
+          <a:lstStyle/>
+          <a:p>
+            <a:pPr indent="0" marL="0">
+              <a:buNone/>
+            </a:pPr>
+            <a:r>
+              <a:rPr lang="en-US" sz="900" i="1" dirty="0">
+                <a:solidFill>
+                  <a:schemeClr val="accent4"/>
+                </a:solidFill>
+              </a:rPr>
+              <a:t>Source: Klaviyo (Brooklyn Biltong), platform-attributed orders.</a:t>
+            </a:r>
+            <a:endParaRPr lang="en-US" sz="900" dirty="0"/>
+          </a:p>
+        </p:txBody>
+      </p:sp>
+      <p:sp>
+        <p:nvSpPr>
+          <p:cNvPr id="25" name="Slide Number Placeholder 0"/>
+          <p:cNvSpPr>
+            <a:spLocks noGrp="1"/>
+          </p:cNvSpPr>
+          <p:nvPr>
+            <p:ph type="sldNum" sz="quarter" idx="4294967295"/>
+          </p:nvPr>
+        </p:nvSpPr>
+        <p:spPr>
+          <a:xfrm>
+            <a:off x="8321040" y="4800600"/>
+            <a:ext cx="365760" cy="228600"/>
+          </a:xfrm>
+          <a:prstGeom prst="rect">
+            <a:avLst/>
+          </a:prstGeom>
+          <a:extLst>
+            <a:ext uri="{C572A759-6A51-4108-AA02-DFA0A04FC94B}">
+              <ma14:wrappingTextBoxFlag xmlns:ma14="http://schemas.microsoft.com/office/mac/drawingml/2011/main" val="0"/>
+            </a:ext>
+          </a:extLst>
+        </p:spPr>
+        <p:txBody>
+          <a:bodyPr/>
+          <a:lstStyle>
+            <a:lvl1pPr>
+              <a:defRPr sz="900">
+                <a:solidFill>
+                  <a:schemeClr val="accent4"/>
+                </a:solidFill>
+              </a:defRPr>
+            </a:lvl1pPr>
+          </a:lstStyle>
+          <a:p>
+            <a:pPr algn="r"/>
+            <a:fld id="{F7021451-1387-4CA6-816F-3879F97B5CBC}" type="slidenum">
+              <a:rPr b="0" lang="en-US"/>
+              <a:t>7</a:t>
+            </a:fld>
+            <a:endParaRPr lang="en-US"/>
+          </a:p>
+        </p:txBody>
+      </p:sp>
+    </p:spTree>
+  </p:cSld>
+  <p:clrMapOvr>
+    <a:masterClrMapping/>
+  </p:clrMapOvr>
+</p:sld>
+</file>
+
+<file path=ppt/slides/slide8.xml><?xml version="1.0" encoding="utf-8"?>
+<p:sld xmlns:a="http://schemas.openxmlformats.org/drawingml/2006/main" xmlns:r="http://schemas.openxmlformats.org/officeDocument/2006/relationships" xmlns:p="http://schemas.openxmlformats.org/presentationml/2006/main">
+  <p:cSld name="Slide 8">
+    <p:spTree>
+      <p:nvGrpSpPr>
+        <p:cNvPr id="1" name=""/>
+        <p:cNvGrpSpPr/>
+        <p:nvPr/>
+      </p:nvGrpSpPr>
+      <p:grpSpPr>
+        <a:xfrm>
+          <a:off x="0" y="0"/>
+          <a:ext cx="0" cy="0"/>
+          <a:chOff x="0" y="0"/>
+          <a:chExt cx="0" cy="0"/>
+        </a:xfrm>
+      </p:grpSpPr>
+      <p:sp>
+        <p:nvSpPr>
+          <p:cNvPr id="2" name="Text 0"/>
+          <p:cNvSpPr/>
+          <p:nvPr>
+            <p:ph idx="100" type="title" hasCustomPrompt="1"/>
+          </p:nvPr>
+        </p:nvSpPr>
+        <p:spPr>
+          <a:xfrm>
+            <a:off x="457200" y="274320"/>
+            <a:ext cx="8229600" cy="594360"/>
+          </a:xfrm>
+          <a:prstGeom prst="rect">
+            <a:avLst/>
+          </a:prstGeom>
+          <a:noFill/>
+          <a:ln/>
+        </p:spPr>
+        <p:txBody>
+          <a:bodyPr wrap="square" lIns="0" tIns="0" rIns="0" bIns="0" rtlCol="0" anchor="ctr"/>
+          <a:lstStyle/>
+          <a:p>
+            <a:pPr algn="l" indent="0" marL="0">
+              <a:buNone/>
+            </a:pPr>
+            <a:r>
+              <a:rPr lang="en-US" sz="2600" b="1" dirty="0">
+                <a:solidFill>
+                  <a:schemeClr val="tx1"/>
+                </a:solidFill>
+                <a:latin typeface="Cambria" pitchFamily="34" charset="0"/>
+                <a:ea typeface="Cambria" pitchFamily="34" charset="-122"/>
+                <a:cs typeface="Cambria" pitchFamily="34" charset="-120"/>
+              </a:rPr>
               <a:t>What we'll do this week</a:t>
             </a:r>
             <a:endParaRPr lang="en-US" sz="2600" dirty="0"/>
@@ -8802,7 +9812,7 @@
             <a:pPr algn="r"/>
             <a:fld id="{F7021451-1387-4CA6-816F-3879F97B5CBC}" type="slidenum">
               <a:rPr b="0" lang="en-US"/>
-              <a:t>7</a:t>
+              <a:t>8</a:t>
             </a:fld>
             <a:endParaRPr lang="en-US"/>
           </a:p>

</xml_diff>

<commit_message>
Add Ayoba positives slide to CEO deck
Co-Authored-By: Claude Opus 5.5 <noreply@anthropic.com>
Claude-Session: https://claude.ai/code/session_01QGMjcfWM6zwQECSVCibDW3
</commit_message>
<xml_diff>
--- a/status_ceo/Stormberg_Status_CEO_Oct2026_EN.pptx
+++ b/status_ceo/Stormberg_Status_CEO_Oct2026_EN.pptx
@@ -13,9 +13,10 @@
     <p:sldId id="261" r:id="rId7"/>
     <p:sldId id="262" r:id="rId8"/>
     <p:sldId id="263" r:id="rId9"/>
+    <p:sldId id="264" r:id="rId10"/>
   </p:sldIdLst>
   <p:notesMasterIdLst>
-    <p:notesMasterId r:id="rId10"/>
+    <p:notesMasterId r:id="rId11"/>
   </p:notesMasterIdLst>
   <p:sldSz cx="9144000" cy="5143500"/>
   <p:notesSz cx="5143500" cy="9144000"/>
@@ -114,24 +115,25 @@
   <p:extLst>
     <p:ext uri="{521415D9-36F7-43E2-AB2F-B90AF26B5E84}">
       <p14:sectionLst xmlns:p14="http://schemas.microsoft.com/office/powerpoint/2010/main">
-        <p14:section name="Summary" id="{d06c6a32-342a-2586-9cf1-8231bbec9472}">
+        <p14:section name="Summary" id="{6ddd3e20-ba4f-a2e5-abb9-7a459fc7910d}">
           <p14:sldIdLst>
             <p14:sldId id="256"/>
             <p14:sldId id="257"/>
             <p14:sldId id="258"/>
             <p14:sldId id="259"/>
+            <p14:sldId id="260"/>
           </p14:sldIdLst>
         </p14:section>
-        <p14:section name="Progress" id="{54b547cd-fc4b-4cec-d0c4-7c8e3ddc6578}">
+        <p14:section name="Progress" id="{217d69fd-4748-e67e-981b-d6294cc815d8}">
           <p14:sldIdLst>
-            <p14:sldId id="260"/>
             <p14:sldId id="261"/>
             <p14:sldId id="262"/>
+            <p14:sldId id="263"/>
           </p14:sldIdLst>
         </p14:section>
-        <p14:section name="Next steps" id="{88e3939c-1370-8b37-aeda-1b56901fcde8}">
+        <p14:section name="Next steps" id="{f60ca293-36d5-fe1d-e3ea-6a39e4452cd9}">
           <p14:sldIdLst>
-            <p14:sldId id="263"/>
+            <p14:sldId id="264"/>
           </p14:sldIdLst>
         </p14:section>
       </p14:sectionLst>
@@ -2307,6 +2309,94 @@
 </p:notes>
 </file>
 
+<file path=ppt/notesSlides/notesSlide9.xml><?xml version="1.0" encoding="utf-8"?>
+<p:notes xmlns:a="http://schemas.openxmlformats.org/drawingml/2006/main" xmlns:r="http://schemas.openxmlformats.org/officeDocument/2006/relationships" xmlns:p="http://schemas.openxmlformats.org/presentationml/2006/main">
+  <p:cSld>
+    <p:spTree>
+      <p:nvGrpSpPr>
+        <p:cNvPr id="1" name=""/>
+        <p:cNvGrpSpPr/>
+        <p:nvPr/>
+      </p:nvGrpSpPr>
+      <p:grpSpPr>
+        <a:xfrm>
+          <a:off x="0" y="0"/>
+          <a:ext cx="0" cy="0"/>
+          <a:chOff x="0" y="0"/>
+          <a:chExt cx="0" cy="0"/>
+        </a:xfrm>
+      </p:grpSpPr>
+      <p:sp>
+        <p:nvSpPr>
+          <p:cNvPr id="2" name="Slide Image Placeholder 1"/>
+          <p:cNvSpPr>
+            <a:spLocks noGrp="1" noRot="1" noChangeAspect="1"/>
+          </p:cNvSpPr>
+          <p:nvPr>
+            <p:ph type="sldImg"/>
+          </p:nvPr>
+        </p:nvSpPr>
+        <p:spPr/>
+      </p:sp>
+      <p:sp>
+        <p:nvSpPr>
+          <p:cNvPr id="3" name="Notes Placeholder 2"/>
+          <p:cNvSpPr>
+            <a:spLocks noGrp="1"/>
+          </p:cNvSpPr>
+          <p:nvPr>
+            <p:ph type="body" idx="1"/>
+          </p:nvPr>
+        </p:nvSpPr>
+        <p:spPr/>
+        <p:txBody>
+          <a:bodyPr/>
+          <a:lstStyle/>
+          <a:p>
+            <a:r>
+              <a:rPr lang="en-US" dirty="0"/>
+              <a:t/>
+            </a:r>
+            <a:endParaRPr lang="en-US" dirty="0"/>
+          </a:p>
+        </p:txBody>
+      </p:sp>
+      <p:sp>
+        <p:nvSpPr>
+          <p:cNvPr id="4" name="Slide Number Placeholder 3"/>
+          <p:cNvSpPr>
+            <a:spLocks noGrp="1"/>
+          </p:cNvSpPr>
+          <p:nvPr>
+            <p:ph type="sldNum" sz="quarter" idx="10"/>
+          </p:nvPr>
+        </p:nvSpPr>
+        <p:spPr/>
+        <p:txBody>
+          <a:bodyPr/>
+          <a:lstStyle/>
+          <a:p>
+            <a:fld id="{F7021451-1387-4CA6-816F-3879F97B5CBC}" type="slidenum">
+              <a:rPr lang="en-US"/>
+              <a:t>9</a:t>
+            </a:fld>
+            <a:endParaRPr lang="en-US"/>
+          </a:p>
+        </p:txBody>
+      </p:sp>
+    </p:spTree>
+    <p:extLst>
+      <p:ext uri="{BB962C8B-B14F-4D97-AF65-F5344CB8AC3E}">
+        <p14:creationId xmlns:p14="http://schemas.microsoft.com/office/powerpoint/2010/main" val="1024086991"/>
+      </p:ext>
+    </p:extLst>
+  </p:cSld>
+  <p:clrMapOvr>
+    <a:masterClrMapping/>
+  </p:clrMapOvr>
+</p:notes>
+</file>
+
 <file path=ppt/slideLayouts/slideLayout1.xml><?xml version="1.0" encoding="utf-8"?>
 <p:sldLayout xmlns:a="http://schemas.openxmlformats.org/drawingml/2006/main" xmlns:r="http://schemas.openxmlformats.org/officeDocument/2006/relationships" xmlns:p="http://schemas.openxmlformats.org/presentationml/2006/main" preserve="1">
   <p:cSld name="DEFAULT">
@@ -5556,6 +5646,926 @@
                 <a:ea typeface="Cambria" pitchFamily="34" charset="-122"/>
                 <a:cs typeface="Cambria" pitchFamily="34" charset="-120"/>
               </a:rPr>
+              <a:t>Ayoba: high ticket and a profitable operation</a:t>
+            </a:r>
+            <a:endParaRPr lang="en-US" sz="2600" dirty="0"/>
+          </a:p>
+        </p:txBody>
+      </p:sp>
+      <p:sp>
+        <p:nvSpPr>
+          <p:cNvPr id="3" name="AY stat 1"/>
+          <p:cNvSpPr/>
+          <p:nvPr/>
+        </p:nvSpPr>
+        <p:spPr>
+          <a:xfrm>
+            <a:off x="457200" y="1005840"/>
+            <a:ext cx="4206240" cy="1005840"/>
+          </a:xfrm>
+          <a:prstGeom prst="roundRect">
+            <a:avLst>
+              <a:gd name="adj" fmla="val 7273"/>
+            </a:avLst>
+          </a:prstGeom>
+          <a:solidFill>
+            <a:schemeClr val="bg2"/>
+          </a:solidFill>
+          <a:ln/>
+        </p:spPr>
+      </p:sp>
+      <p:sp>
+        <p:nvSpPr>
+          <p:cNvPr id="4" name="Text 2"/>
+          <p:cNvSpPr txBox="1"/>
+          <p:nvPr/>
+        </p:nvSpPr>
+        <p:spPr>
+          <a:xfrm>
+            <a:off x="640080" y="1097280"/>
+            <a:ext cx="1463040" cy="822960"/>
+          </a:xfrm>
+          <a:prstGeom prst="rect">
+            <a:avLst/>
+          </a:prstGeom>
+          <a:noFill/>
+          <a:ln/>
+        </p:spPr>
+        <p:txBody>
+          <a:bodyPr wrap="square" lIns="0" tIns="0" rIns="0" bIns="0" rtlCol="0" anchor="ctr">
+            <a:normAutofit/>
+          </a:bodyPr>
+          <a:lstStyle/>
+          <a:p>
+            <a:pPr indent="0" marL="0">
+              <a:buNone/>
+            </a:pPr>
+            <a:r>
+              <a:rPr lang="en-US" sz="3000" b="1" dirty="0">
+                <a:solidFill>
+                  <a:schemeClr val="tx2"/>
+                </a:solidFill>
+                <a:latin typeface="Cambria" pitchFamily="34" charset="0"/>
+                <a:ea typeface="Cambria" pitchFamily="34" charset="-122"/>
+                <a:cs typeface="Cambria" pitchFamily="34" charset="-120"/>
+              </a:rPr>
+              <a:t>$107.8K</a:t>
+            </a:r>
+            <a:endParaRPr lang="en-US" sz="3000" dirty="0"/>
+          </a:p>
+        </p:txBody>
+      </p:sp>
+      <p:sp>
+        <p:nvSpPr>
+          <p:cNvPr id="5" name="Text 3"/>
+          <p:cNvSpPr txBox="1"/>
+          <p:nvPr/>
+        </p:nvSpPr>
+        <p:spPr>
+          <a:xfrm>
+            <a:off x="2194560" y="1097280"/>
+            <a:ext cx="2331720" cy="822960"/>
+          </a:xfrm>
+          <a:prstGeom prst="rect">
+            <a:avLst/>
+          </a:prstGeom>
+          <a:noFill/>
+          <a:ln/>
+        </p:spPr>
+        <p:txBody>
+          <a:bodyPr wrap="square" lIns="0" tIns="0" rIns="0" bIns="0" rtlCol="0" anchor="ctr"/>
+          <a:lstStyle/>
+          <a:p>
+            <a:pPr indent="0" marL="0">
+              <a:buNone/>
+            </a:pPr>
+            <a:r>
+              <a:rPr lang="en-US" sz="1200" dirty="0">
+                <a:solidFill>
+                  <a:schemeClr val="tx1"/>
+                </a:solidFill>
+              </a:rPr>
+              <a:t>in gross sales year to date, from 1,188 orders</a:t>
+            </a:r>
+            <a:endParaRPr lang="en-US" sz="1200" dirty="0"/>
+          </a:p>
+        </p:txBody>
+      </p:sp>
+      <p:sp>
+        <p:nvSpPr>
+          <p:cNvPr id="6" name="AY stat 2"/>
+          <p:cNvSpPr/>
+          <p:nvPr/>
+        </p:nvSpPr>
+        <p:spPr>
+          <a:xfrm>
+            <a:off x="457200" y="2148840"/>
+            <a:ext cx="4206240" cy="1005840"/>
+          </a:xfrm>
+          <a:prstGeom prst="roundRect">
+            <a:avLst>
+              <a:gd name="adj" fmla="val 7273"/>
+            </a:avLst>
+          </a:prstGeom>
+          <a:solidFill>
+            <a:schemeClr val="bg2"/>
+          </a:solidFill>
+          <a:ln/>
+        </p:spPr>
+      </p:sp>
+      <p:sp>
+        <p:nvSpPr>
+          <p:cNvPr id="7" name="Text 5"/>
+          <p:cNvSpPr txBox="1"/>
+          <p:nvPr/>
+        </p:nvSpPr>
+        <p:spPr>
+          <a:xfrm>
+            <a:off x="640080" y="2240280"/>
+            <a:ext cx="1463040" cy="822960"/>
+          </a:xfrm>
+          <a:prstGeom prst="rect">
+            <a:avLst/>
+          </a:prstGeom>
+          <a:noFill/>
+          <a:ln/>
+        </p:spPr>
+        <p:txBody>
+          <a:bodyPr wrap="square" lIns="0" tIns="0" rIns="0" bIns="0" rtlCol="0" anchor="ctr">
+            <a:normAutofit/>
+          </a:bodyPr>
+          <a:lstStyle/>
+          <a:p>
+            <a:pPr indent="0" marL="0">
+              <a:buNone/>
+            </a:pPr>
+            <a:r>
+              <a:rPr lang="en-US" sz="3000" b="1" dirty="0">
+                <a:solidFill>
+                  <a:schemeClr val="accent2"/>
+                </a:solidFill>
+                <a:latin typeface="Cambria" pitchFamily="34" charset="0"/>
+                <a:ea typeface="Cambria" pitchFamily="34" charset="-122"/>
+                <a:cs typeface="Cambria" pitchFamily="34" charset="-120"/>
+              </a:rPr>
+              <a:t>60%</a:t>
+            </a:r>
+            <a:endParaRPr lang="en-US" sz="3000" dirty="0"/>
+          </a:p>
+        </p:txBody>
+      </p:sp>
+      <p:sp>
+        <p:nvSpPr>
+          <p:cNvPr id="8" name="Text 6"/>
+          <p:cNvSpPr txBox="1"/>
+          <p:nvPr/>
+        </p:nvSpPr>
+        <p:spPr>
+          <a:xfrm>
+            <a:off x="2194560" y="2240280"/>
+            <a:ext cx="2331720" cy="822960"/>
+          </a:xfrm>
+          <a:prstGeom prst="rect">
+            <a:avLst/>
+          </a:prstGeom>
+          <a:noFill/>
+          <a:ln/>
+        </p:spPr>
+        <p:txBody>
+          <a:bodyPr wrap="square" lIns="0" tIns="0" rIns="0" bIns="0" rtlCol="0" anchor="ctr"/>
+          <a:lstStyle/>
+          <a:p>
+            <a:pPr indent="0" marL="0">
+              <a:buNone/>
+            </a:pPr>
+            <a:r>
+              <a:rPr lang="en-US" sz="1200" dirty="0">
+                <a:solidFill>
+                  <a:schemeClr val="tx1"/>
+                </a:solidFill>
+              </a:rPr>
+              <a:t>gross margin after product cost: $64.7K in contribution</a:t>
+            </a:r>
+            <a:endParaRPr lang="en-US" sz="1200" dirty="0"/>
+          </a:p>
+        </p:txBody>
+      </p:sp>
+      <p:sp>
+        <p:nvSpPr>
+          <p:cNvPr id="9" name="AY stat 3"/>
+          <p:cNvSpPr/>
+          <p:nvPr/>
+        </p:nvSpPr>
+        <p:spPr>
+          <a:xfrm>
+            <a:off x="457200" y="3291840"/>
+            <a:ext cx="4206240" cy="1005840"/>
+          </a:xfrm>
+          <a:prstGeom prst="roundRect">
+            <a:avLst>
+              <a:gd name="adj" fmla="val 7273"/>
+            </a:avLst>
+          </a:prstGeom>
+          <a:solidFill>
+            <a:schemeClr val="bg2"/>
+          </a:solidFill>
+          <a:ln/>
+        </p:spPr>
+      </p:sp>
+      <p:sp>
+        <p:nvSpPr>
+          <p:cNvPr id="10" name="Text 8"/>
+          <p:cNvSpPr txBox="1"/>
+          <p:nvPr/>
+        </p:nvSpPr>
+        <p:spPr>
+          <a:xfrm>
+            <a:off x="640080" y="3383280"/>
+            <a:ext cx="1463040" cy="822960"/>
+          </a:xfrm>
+          <a:prstGeom prst="rect">
+            <a:avLst/>
+          </a:prstGeom>
+          <a:noFill/>
+          <a:ln/>
+        </p:spPr>
+        <p:txBody>
+          <a:bodyPr wrap="square" lIns="0" tIns="0" rIns="0" bIns="0" rtlCol="0" anchor="ctr">
+            <a:normAutofit/>
+          </a:bodyPr>
+          <a:lstStyle/>
+          <a:p>
+            <a:pPr indent="0" marL="0">
+              <a:buNone/>
+            </a:pPr>
+            <a:r>
+              <a:rPr lang="en-US" sz="3000" b="1" dirty="0">
+                <a:solidFill>
+                  <a:schemeClr val="accent1"/>
+                </a:solidFill>
+                <a:latin typeface="Cambria" pitchFamily="34" charset="0"/>
+                <a:ea typeface="Cambria" pitchFamily="34" charset="-122"/>
+                <a:cs typeface="Cambria" pitchFamily="34" charset="-120"/>
+              </a:rPr>
+              <a:t>4.2x</a:t>
+            </a:r>
+            <a:endParaRPr lang="en-US" sz="3000" dirty="0"/>
+          </a:p>
+        </p:txBody>
+      </p:sp>
+      <p:sp>
+        <p:nvSpPr>
+          <p:cNvPr id="11" name="Text 9"/>
+          <p:cNvSpPr txBox="1"/>
+          <p:nvPr/>
+        </p:nvSpPr>
+        <p:spPr>
+          <a:xfrm>
+            <a:off x="2194560" y="3383280"/>
+            <a:ext cx="2331720" cy="822960"/>
+          </a:xfrm>
+          <a:prstGeom prst="rect">
+            <a:avLst/>
+          </a:prstGeom>
+          <a:noFill/>
+          <a:ln/>
+        </p:spPr>
+        <p:txBody>
+          <a:bodyPr wrap="square" lIns="0" tIns="0" rIns="0" bIns="0" rtlCol="0" anchor="ctr"/>
+          <a:lstStyle/>
+          <a:p>
+            <a:pPr indent="0" marL="0">
+              <a:buNone/>
+            </a:pPr>
+            <a:r>
+              <a:rPr lang="en-US" sz="1200" dirty="0">
+                <a:solidFill>
+                  <a:schemeClr val="tx1"/>
+                </a:solidFill>
+              </a:rPr>
+              <a:t>in sales for every dollar invested in paid media this year</a:t>
+            </a:r>
+            <a:endParaRPr lang="en-US" sz="1200" dirty="0"/>
+          </a:p>
+        </p:txBody>
+      </p:sp>
+      <p:sp>
+        <p:nvSpPr>
+          <p:cNvPr id="12" name="AY card 1"/>
+          <p:cNvSpPr/>
+          <p:nvPr/>
+        </p:nvSpPr>
+        <p:spPr>
+          <a:xfrm>
+            <a:off x="5029200" y="1005840"/>
+            <a:ext cx="1783080" cy="1554480"/>
+          </a:xfrm>
+          <a:prstGeom prst="roundRect">
+            <a:avLst>
+              <a:gd name="adj" fmla="val 4706"/>
+            </a:avLst>
+          </a:prstGeom>
+          <a:solidFill>
+            <a:schemeClr val="bg2"/>
+          </a:solidFill>
+          <a:ln/>
+        </p:spPr>
+      </p:sp>
+      <p:sp>
+        <p:nvSpPr>
+          <p:cNvPr id="13" name="AY dot 1"/>
+          <p:cNvSpPr/>
+          <p:nvPr/>
+        </p:nvSpPr>
+        <p:spPr>
+          <a:xfrm>
+            <a:off x="5166360" y="1143000"/>
+            <a:ext cx="256032" cy="256032"/>
+          </a:xfrm>
+          <a:prstGeom prst="ellipse">
+            <a:avLst/>
+          </a:prstGeom>
+          <a:solidFill>
+            <a:schemeClr val="accent2"/>
+          </a:solidFill>
+          <a:ln/>
+        </p:spPr>
+      </p:sp>
+      <p:sp>
+        <p:nvSpPr>
+          <p:cNvPr id="14" name="Text 12"/>
+          <p:cNvSpPr txBox="1"/>
+          <p:nvPr/>
+        </p:nvSpPr>
+        <p:spPr>
+          <a:xfrm>
+            <a:off x="5486400" y="1097280"/>
+            <a:ext cx="1261872" cy="365760"/>
+          </a:xfrm>
+          <a:prstGeom prst="rect">
+            <a:avLst/>
+          </a:prstGeom>
+          <a:noFill/>
+          <a:ln/>
+        </p:spPr>
+        <p:txBody>
+          <a:bodyPr wrap="square" lIns="0" tIns="0" rIns="0" bIns="0" rtlCol="0" anchor="ctr">
+            <a:normAutofit/>
+          </a:bodyPr>
+          <a:lstStyle/>
+          <a:p>
+            <a:pPr indent="0" marL="0">
+              <a:buNone/>
+            </a:pPr>
+            <a:r>
+              <a:rPr lang="en-US" sz="1200" b="1" dirty="0">
+                <a:solidFill>
+                  <a:schemeClr val="tx1"/>
+                </a:solidFill>
+                <a:latin typeface="Cambria" pitchFamily="34" charset="0"/>
+                <a:ea typeface="Cambria" pitchFamily="34" charset="-122"/>
+                <a:cs typeface="Cambria" pitchFamily="34" charset="-120"/>
+              </a:rPr>
+              <a:t>Highest ticket</a:t>
+            </a:r>
+            <a:endParaRPr lang="en-US" sz="1200" dirty="0"/>
+          </a:p>
+        </p:txBody>
+      </p:sp>
+      <p:sp>
+        <p:nvSpPr>
+          <p:cNvPr id="15" name="Text 13"/>
+          <p:cNvSpPr txBox="1"/>
+          <p:nvPr/>
+        </p:nvSpPr>
+        <p:spPr>
+          <a:xfrm>
+            <a:off x="5166360" y="1508760"/>
+            <a:ext cx="1536192" cy="987552"/>
+          </a:xfrm>
+          <a:prstGeom prst="rect">
+            <a:avLst/>
+          </a:prstGeom>
+          <a:noFill/>
+          <a:ln/>
+        </p:spPr>
+        <p:txBody>
+          <a:bodyPr wrap="square" lIns="0" tIns="0" rIns="0" bIns="0" rtlCol="0" anchor="t"/>
+          <a:lstStyle/>
+          <a:p>
+            <a:pPr indent="0" marL="0">
+              <a:buNone/>
+            </a:pPr>
+            <a:r>
+              <a:rPr lang="en-US" sz="1100" dirty="0">
+                <a:solidFill>
+                  <a:schemeClr val="tx1"/>
+                </a:solidFill>
+              </a:rPr>
+              <a:t>$91 average per order, the highest in the portfolio</a:t>
+            </a:r>
+            <a:endParaRPr lang="en-US" sz="1100" dirty="0"/>
+          </a:p>
+        </p:txBody>
+      </p:sp>
+      <p:sp>
+        <p:nvSpPr>
+          <p:cNvPr id="16" name="AY card 2"/>
+          <p:cNvSpPr/>
+          <p:nvPr/>
+        </p:nvSpPr>
+        <p:spPr>
+          <a:xfrm>
+            <a:off x="6903720" y="1005840"/>
+            <a:ext cx="1783080" cy="1554480"/>
+          </a:xfrm>
+          <a:prstGeom prst="roundRect">
+            <a:avLst>
+              <a:gd name="adj" fmla="val 4706"/>
+            </a:avLst>
+          </a:prstGeom>
+          <a:solidFill>
+            <a:schemeClr val="bg2"/>
+          </a:solidFill>
+          <a:ln/>
+        </p:spPr>
+      </p:sp>
+      <p:sp>
+        <p:nvSpPr>
+          <p:cNvPr id="17" name="AY dot 2"/>
+          <p:cNvSpPr/>
+          <p:nvPr/>
+        </p:nvSpPr>
+        <p:spPr>
+          <a:xfrm>
+            <a:off x="7040880" y="1143000"/>
+            <a:ext cx="256032" cy="256032"/>
+          </a:xfrm>
+          <a:prstGeom prst="ellipse">
+            <a:avLst/>
+          </a:prstGeom>
+          <a:solidFill>
+            <a:schemeClr val="accent2"/>
+          </a:solidFill>
+          <a:ln/>
+        </p:spPr>
+      </p:sp>
+      <p:sp>
+        <p:nvSpPr>
+          <p:cNvPr id="18" name="Text 16"/>
+          <p:cNvSpPr txBox="1"/>
+          <p:nvPr/>
+        </p:nvSpPr>
+        <p:spPr>
+          <a:xfrm>
+            <a:off x="7360920" y="1097280"/>
+            <a:ext cx="1261872" cy="365760"/>
+          </a:xfrm>
+          <a:prstGeom prst="rect">
+            <a:avLst/>
+          </a:prstGeom>
+          <a:noFill/>
+          <a:ln/>
+        </p:spPr>
+        <p:txBody>
+          <a:bodyPr wrap="square" lIns="0" tIns="0" rIns="0" bIns="0" rtlCol="0" anchor="ctr">
+            <a:normAutofit/>
+          </a:bodyPr>
+          <a:lstStyle/>
+          <a:p>
+            <a:pPr indent="0" marL="0">
+              <a:buNone/>
+            </a:pPr>
+            <a:r>
+              <a:rPr lang="en-US" sz="1200" b="1" dirty="0">
+                <a:solidFill>
+                  <a:schemeClr val="tx1"/>
+                </a:solidFill>
+                <a:latin typeface="Cambria" pitchFamily="34" charset="0"/>
+                <a:ea typeface="Cambria" pitchFamily="34" charset="-122"/>
+                <a:cs typeface="Cambria" pitchFamily="34" charset="-120"/>
+              </a:rPr>
+              <a:t>New customers</a:t>
+            </a:r>
+            <a:endParaRPr lang="en-US" sz="1200" dirty="0"/>
+          </a:p>
+        </p:txBody>
+      </p:sp>
+      <p:sp>
+        <p:nvSpPr>
+          <p:cNvPr id="19" name="Text 17"/>
+          <p:cNvSpPr txBox="1"/>
+          <p:nvPr/>
+        </p:nvSpPr>
+        <p:spPr>
+          <a:xfrm>
+            <a:off x="7040880" y="1508760"/>
+            <a:ext cx="1536192" cy="987552"/>
+          </a:xfrm>
+          <a:prstGeom prst="rect">
+            <a:avLst/>
+          </a:prstGeom>
+          <a:noFill/>
+          <a:ln/>
+        </p:spPr>
+        <p:txBody>
+          <a:bodyPr wrap="square" lIns="0" tIns="0" rIns="0" bIns="0" rtlCol="0" anchor="t"/>
+          <a:lstStyle/>
+          <a:p>
+            <a:pPr indent="0" marL="0">
+              <a:buNone/>
+            </a:pPr>
+            <a:r>
+              <a:rPr lang="en-US" sz="1100" dirty="0">
+                <a:solidFill>
+                  <a:schemeClr val="tx1"/>
+                </a:solidFill>
+              </a:rPr>
+              <a:t>523 this year, at about $49 each</a:t>
+            </a:r>
+            <a:endParaRPr lang="en-US" sz="1100" dirty="0"/>
+          </a:p>
+        </p:txBody>
+      </p:sp>
+      <p:sp>
+        <p:nvSpPr>
+          <p:cNvPr id="20" name="AY card 3"/>
+          <p:cNvSpPr/>
+          <p:nvPr/>
+        </p:nvSpPr>
+        <p:spPr>
+          <a:xfrm>
+            <a:off x="5029200" y="2697480"/>
+            <a:ext cx="1783080" cy="1554480"/>
+          </a:xfrm>
+          <a:prstGeom prst="roundRect">
+            <a:avLst>
+              <a:gd name="adj" fmla="val 4706"/>
+            </a:avLst>
+          </a:prstGeom>
+          <a:solidFill>
+            <a:schemeClr val="bg2"/>
+          </a:solidFill>
+          <a:ln/>
+        </p:spPr>
+      </p:sp>
+      <p:sp>
+        <p:nvSpPr>
+          <p:cNvPr id="21" name="AY dot 3"/>
+          <p:cNvSpPr/>
+          <p:nvPr/>
+        </p:nvSpPr>
+        <p:spPr>
+          <a:xfrm>
+            <a:off x="5166360" y="2834640"/>
+            <a:ext cx="256032" cy="256032"/>
+          </a:xfrm>
+          <a:prstGeom prst="ellipse">
+            <a:avLst/>
+          </a:prstGeom>
+          <a:solidFill>
+            <a:schemeClr val="accent2"/>
+          </a:solidFill>
+          <a:ln/>
+        </p:spPr>
+      </p:sp>
+      <p:sp>
+        <p:nvSpPr>
+          <p:cNvPr id="22" name="Text 20"/>
+          <p:cNvSpPr txBox="1"/>
+          <p:nvPr/>
+        </p:nvSpPr>
+        <p:spPr>
+          <a:xfrm>
+            <a:off x="5486400" y="2788920"/>
+            <a:ext cx="1261872" cy="365760"/>
+          </a:xfrm>
+          <a:prstGeom prst="rect">
+            <a:avLst/>
+          </a:prstGeom>
+          <a:noFill/>
+          <a:ln/>
+        </p:spPr>
+        <p:txBody>
+          <a:bodyPr wrap="square" lIns="0" tIns="0" rIns="0" bIns="0" rtlCol="0" anchor="ctr">
+            <a:normAutofit/>
+          </a:bodyPr>
+          <a:lstStyle/>
+          <a:p>
+            <a:pPr indent="0" marL="0">
+              <a:buNone/>
+            </a:pPr>
+            <a:r>
+              <a:rPr lang="en-US" sz="1200" b="1" dirty="0">
+                <a:solidFill>
+                  <a:schemeClr val="tx1"/>
+                </a:solidFill>
+                <a:latin typeface="Cambria" pitchFamily="34" charset="0"/>
+                <a:ea typeface="Cambria" pitchFamily="34" charset="-122"/>
+                <a:cs typeface="Cambria" pitchFamily="34" charset="-120"/>
+              </a:rPr>
+              <a:t>Healthy sales</a:t>
+            </a:r>
+            <a:endParaRPr lang="en-US" sz="1200" dirty="0"/>
+          </a:p>
+        </p:txBody>
+      </p:sp>
+      <p:sp>
+        <p:nvSpPr>
+          <p:cNvPr id="23" name="Text 21"/>
+          <p:cNvSpPr txBox="1"/>
+          <p:nvPr/>
+        </p:nvSpPr>
+        <p:spPr>
+          <a:xfrm>
+            <a:off x="5166360" y="3200400"/>
+            <a:ext cx="1536192" cy="987552"/>
+          </a:xfrm>
+          <a:prstGeom prst="rect">
+            <a:avLst/>
+          </a:prstGeom>
+          <a:noFill/>
+          <a:ln/>
+        </p:spPr>
+        <p:txBody>
+          <a:bodyPr wrap="square" lIns="0" tIns="0" rIns="0" bIns="0" rtlCol="0" anchor="t"/>
+          <a:lstStyle/>
+          <a:p>
+            <a:pPr indent="0" marL="0">
+              <a:buNone/>
+            </a:pPr>
+            <a:r>
+              <a:rPr lang="en-US" sz="1100" dirty="0">
+                <a:solidFill>
+                  <a:schemeClr val="tx1"/>
+                </a:solidFill>
+              </a:rPr>
+              <a:t>Discounts of just 5.7% and returns of 3.5% of sales</a:t>
+            </a:r>
+            <a:endParaRPr lang="en-US" sz="1100" dirty="0"/>
+          </a:p>
+        </p:txBody>
+      </p:sp>
+      <p:sp>
+        <p:nvSpPr>
+          <p:cNvPr id="24" name="AY card 4"/>
+          <p:cNvSpPr/>
+          <p:nvPr/>
+        </p:nvSpPr>
+        <p:spPr>
+          <a:xfrm>
+            <a:off x="6903720" y="2697480"/>
+            <a:ext cx="1783080" cy="1554480"/>
+          </a:xfrm>
+          <a:prstGeom prst="roundRect">
+            <a:avLst>
+              <a:gd name="adj" fmla="val 4706"/>
+            </a:avLst>
+          </a:prstGeom>
+          <a:solidFill>
+            <a:schemeClr val="bg2"/>
+          </a:solidFill>
+          <a:ln/>
+        </p:spPr>
+      </p:sp>
+      <p:sp>
+        <p:nvSpPr>
+          <p:cNvPr id="25" name="AY dot 4"/>
+          <p:cNvSpPr/>
+          <p:nvPr/>
+        </p:nvSpPr>
+        <p:spPr>
+          <a:xfrm>
+            <a:off x="7040880" y="2834640"/>
+            <a:ext cx="256032" cy="256032"/>
+          </a:xfrm>
+          <a:prstGeom prst="ellipse">
+            <a:avLst/>
+          </a:prstGeom>
+          <a:solidFill>
+            <a:schemeClr val="accent2"/>
+          </a:solidFill>
+          <a:ln/>
+        </p:spPr>
+      </p:sp>
+      <p:sp>
+        <p:nvSpPr>
+          <p:cNvPr id="26" name="Text 24"/>
+          <p:cNvSpPr txBox="1"/>
+          <p:nvPr/>
+        </p:nvSpPr>
+        <p:spPr>
+          <a:xfrm>
+            <a:off x="7360920" y="2788920"/>
+            <a:ext cx="1261872" cy="365760"/>
+          </a:xfrm>
+          <a:prstGeom prst="rect">
+            <a:avLst/>
+          </a:prstGeom>
+          <a:noFill/>
+          <a:ln/>
+        </p:spPr>
+        <p:txBody>
+          <a:bodyPr wrap="square" lIns="0" tIns="0" rIns="0" bIns="0" rtlCol="0" anchor="ctr">
+            <a:normAutofit/>
+          </a:bodyPr>
+          <a:lstStyle/>
+          <a:p>
+            <a:pPr indent="0" marL="0">
+              <a:buNone/>
+            </a:pPr>
+            <a:r>
+              <a:rPr lang="en-US" sz="1200" b="1" dirty="0">
+                <a:solidFill>
+                  <a:schemeClr val="tx1"/>
+                </a:solidFill>
+                <a:latin typeface="Cambria" pitchFamily="34" charset="0"/>
+                <a:ea typeface="Cambria" pitchFamily="34" charset="-122"/>
+                <a:cs typeface="Cambria" pitchFamily="34" charset="-120"/>
+              </a:rPr>
+              <a:t>Meta in October</a:t>
+            </a:r>
+            <a:endParaRPr lang="en-US" sz="1200" dirty="0"/>
+          </a:p>
+        </p:txBody>
+      </p:sp>
+      <p:sp>
+        <p:nvSpPr>
+          <p:cNvPr id="27" name="Text 25"/>
+          <p:cNvSpPr txBox="1"/>
+          <p:nvPr/>
+        </p:nvSpPr>
+        <p:spPr>
+          <a:xfrm>
+            <a:off x="7040880" y="3200400"/>
+            <a:ext cx="1536192" cy="987552"/>
+          </a:xfrm>
+          <a:prstGeom prst="rect">
+            <a:avLst/>
+          </a:prstGeom>
+          <a:noFill/>
+          <a:ln/>
+        </p:spPr>
+        <p:txBody>
+          <a:bodyPr wrap="square" lIns="0" tIns="0" rIns="0" bIns="0" rtlCol="0" anchor="t"/>
+          <a:lstStyle/>
+          <a:p>
+            <a:pPr indent="0" marL="0">
+              <a:buNone/>
+            </a:pPr>
+            <a:r>
+              <a:rPr lang="en-US" sz="1100" dirty="0">
+                <a:solidFill>
+                  <a:schemeClr val="tx1"/>
+                </a:solidFill>
+              </a:rPr>
+              <a:t>New customers at $26 per purchase, the most efficient campaign in the portfolio</a:t>
+            </a:r>
+            <a:endParaRPr lang="en-US" sz="1100" dirty="0"/>
+          </a:p>
+        </p:txBody>
+      </p:sp>
+      <p:sp>
+        <p:nvSpPr>
+          <p:cNvPr id="28" name="Text 26"/>
+          <p:cNvSpPr txBox="1"/>
+          <p:nvPr/>
+        </p:nvSpPr>
+        <p:spPr>
+          <a:xfrm>
+            <a:off x="457200" y="4434840"/>
+            <a:ext cx="8229600" cy="274320"/>
+          </a:xfrm>
+          <a:prstGeom prst="rect">
+            <a:avLst/>
+          </a:prstGeom>
+          <a:noFill/>
+          <a:ln/>
+        </p:spPr>
+        <p:txBody>
+          <a:bodyPr wrap="square" lIns="0" tIns="0" rIns="0" bIns="0" rtlCol="0" anchor="ctr"/>
+          <a:lstStyle/>
+          <a:p>
+            <a:pPr indent="0" marL="0">
+              <a:buNone/>
+            </a:pPr>
+            <a:r>
+              <a:rPr lang="en-US" sz="900" i="1" dirty="0">
+                <a:solidFill>
+                  <a:schemeClr val="accent4"/>
+                </a:solidFill>
+              </a:rPr>
+              <a:t>Source: Ayoba Shopify DTC dashboard (Jan 1 – Oct 13, 2026) and Meta Ads Manager (Oct 6–13).</a:t>
+            </a:r>
+            <a:endParaRPr lang="en-US" sz="900" dirty="0"/>
+          </a:p>
+        </p:txBody>
+      </p:sp>
+      <p:sp>
+        <p:nvSpPr>
+          <p:cNvPr id="25" name="Slide Number Placeholder 0"/>
+          <p:cNvSpPr>
+            <a:spLocks noGrp="1"/>
+          </p:cNvSpPr>
+          <p:nvPr>
+            <p:ph type="sldNum" sz="quarter" idx="4294967295"/>
+          </p:nvPr>
+        </p:nvSpPr>
+        <p:spPr>
+          <a:xfrm>
+            <a:off x="8321040" y="4800600"/>
+            <a:ext cx="365760" cy="228600"/>
+          </a:xfrm>
+          <a:prstGeom prst="rect">
+            <a:avLst/>
+          </a:prstGeom>
+          <a:extLst>
+            <a:ext uri="{C572A759-6A51-4108-AA02-DFA0A04FC94B}">
+              <ma14:wrappingTextBoxFlag xmlns:ma14="http://schemas.microsoft.com/office/mac/drawingml/2011/main" val="0"/>
+            </a:ext>
+          </a:extLst>
+        </p:spPr>
+        <p:txBody>
+          <a:bodyPr/>
+          <a:lstStyle>
+            <a:lvl1pPr>
+              <a:defRPr sz="900">
+                <a:solidFill>
+                  <a:schemeClr val="accent4"/>
+                </a:solidFill>
+              </a:defRPr>
+            </a:lvl1pPr>
+          </a:lstStyle>
+          <a:p>
+            <a:pPr algn="r"/>
+            <a:fld id="{F7021451-1387-4CA6-816F-3879F97B5CBC}" type="slidenum">
+              <a:rPr b="0" lang="en-US"/>
+              <a:t>5</a:t>
+            </a:fld>
+            <a:endParaRPr lang="en-US"/>
+          </a:p>
+        </p:txBody>
+      </p:sp>
+    </p:spTree>
+  </p:cSld>
+  <p:clrMapOvr>
+    <a:masterClrMapping/>
+  </p:clrMapOvr>
+</p:sld>
+</file>
+
+<file path=ppt/slides/slide6.xml><?xml version="1.0" encoding="utf-8"?>
+<p:sld xmlns:a="http://schemas.openxmlformats.org/drawingml/2006/main" xmlns:r="http://schemas.openxmlformats.org/officeDocument/2006/relationships" xmlns:p="http://schemas.openxmlformats.org/presentationml/2006/main">
+  <p:cSld name="Slide 6">
+    <p:spTree>
+      <p:nvGrpSpPr>
+        <p:cNvPr id="1" name=""/>
+        <p:cNvGrpSpPr/>
+        <p:nvPr/>
+      </p:nvGrpSpPr>
+      <p:grpSpPr>
+        <a:xfrm>
+          <a:off x="0" y="0"/>
+          <a:ext cx="0" cy="0"/>
+          <a:chOff x="0" y="0"/>
+          <a:chExt cx="0" cy="0"/>
+        </a:xfrm>
+      </p:grpSpPr>
+      <p:sp>
+        <p:nvSpPr>
+          <p:cNvPr id="2" name="Text 0"/>
+          <p:cNvSpPr/>
+          <p:nvPr>
+            <p:ph idx="100" type="title" hasCustomPrompt="1"/>
+          </p:nvPr>
+        </p:nvSpPr>
+        <p:spPr>
+          <a:xfrm>
+            <a:off x="457200" y="274320"/>
+            <a:ext cx="8229600" cy="594360"/>
+          </a:xfrm>
+          <a:prstGeom prst="rect">
+            <a:avLst/>
+          </a:prstGeom>
+          <a:noFill/>
+          <a:ln/>
+        </p:spPr>
+        <p:txBody>
+          <a:bodyPr wrap="square" lIns="0" tIns="0" rIns="0" bIns="0" rtlCol="0" anchor="ctr"/>
+          <a:lstStyle/>
+          <a:p>
+            <a:pPr algn="l" indent="0" marL="0">
+              <a:buNone/>
+            </a:pPr>
+            <a:r>
+              <a:rPr lang="en-US" sz="2600" b="1" dirty="0">
+                <a:solidFill>
+                  <a:schemeClr val="tx1"/>
+                </a:solidFill>
+                <a:latin typeface="Cambria" pitchFamily="34" charset="0"/>
+                <a:ea typeface="Cambria" pitchFamily="34" charset="-122"/>
+                <a:cs typeface="Cambria" pitchFamily="34" charset="-120"/>
+              </a:rPr>
               <a:t>October 9 commitments: status by brand</a:t>
             </a:r>
             <a:endParaRPr lang="en-US" sz="2600" dirty="0"/>
@@ -5564,7 +6574,7 @@
       </p:sp>
       <p:graphicFrame>
         <p:nvGraphicFramePr>
-          <p:cNvPr id="6" name="Commitment tracker"/>
+          <p:cNvPr id="7" name="Commitment tracker"/>
           <p:cNvGraphicFramePr>
             <a:graphicFrameLocks noGrp="1"/>
           </p:cNvGraphicFramePr>
@@ -8373,381 +9383,6 @@
             <a:pPr algn="r"/>
             <a:fld id="{F7021451-1387-4CA6-816F-3879F97B5CBC}" type="slidenum">
               <a:rPr b="0" lang="en-US"/>
-              <a:t>5</a:t>
-            </a:fld>
-            <a:endParaRPr lang="en-US"/>
-          </a:p>
-        </p:txBody>
-      </p:sp>
-    </p:spTree>
-  </p:cSld>
-  <p:clrMapOvr>
-    <a:masterClrMapping/>
-  </p:clrMapOvr>
-</p:sld>
-</file>
-
-<file path=ppt/slides/slide6.xml><?xml version="1.0" encoding="utf-8"?>
-<p:sld xmlns:a="http://schemas.openxmlformats.org/drawingml/2006/main" xmlns:r="http://schemas.openxmlformats.org/officeDocument/2006/relationships" xmlns:p="http://schemas.openxmlformats.org/presentationml/2006/main">
-  <p:cSld name="Slide 6">
-    <p:spTree>
-      <p:nvGrpSpPr>
-        <p:cNvPr id="1" name=""/>
-        <p:cNvGrpSpPr/>
-        <p:nvPr/>
-      </p:nvGrpSpPr>
-      <p:grpSpPr>
-        <a:xfrm>
-          <a:off x="0" y="0"/>
-          <a:ext cx="0" cy="0"/>
-          <a:chOff x="0" y="0"/>
-          <a:chExt cx="0" cy="0"/>
-        </a:xfrm>
-      </p:grpSpPr>
-      <p:sp>
-        <p:nvSpPr>
-          <p:cNvPr id="2" name="Text 0"/>
-          <p:cNvSpPr/>
-          <p:nvPr>
-            <p:ph idx="100" type="title" hasCustomPrompt="1"/>
-          </p:nvPr>
-        </p:nvSpPr>
-        <p:spPr>
-          <a:xfrm>
-            <a:off x="457200" y="274320"/>
-            <a:ext cx="8229600" cy="594360"/>
-          </a:xfrm>
-          <a:prstGeom prst="rect">
-            <a:avLst/>
-          </a:prstGeom>
-          <a:noFill/>
-          <a:ln/>
-        </p:spPr>
-        <p:txBody>
-          <a:bodyPr wrap="square" lIns="0" tIns="0" rIns="0" bIns="0" rtlCol="0" anchor="ctr"/>
-          <a:lstStyle/>
-          <a:p>
-            <a:pPr algn="l" indent="0" marL="0">
-              <a:buNone/>
-            </a:pPr>
-            <a:r>
-              <a:rPr lang="en-US" sz="2600" b="1" dirty="0">
-                <a:solidFill>
-                  <a:schemeClr val="tx1"/>
-                </a:solidFill>
-                <a:latin typeface="Cambria" pitchFamily="34" charset="0"/>
-                <a:ea typeface="Cambria" pitchFamily="34" charset="-122"/>
-                <a:cs typeface="Cambria" pitchFamily="34" charset="-120"/>
-              </a:rPr>
-              <a:t>Meta: more volume, efficiency still being built</a:t>
-            </a:r>
-            <a:endParaRPr lang="en-US" sz="2600" dirty="0"/>
-          </a:p>
-        </p:txBody>
-      </p:sp>
-      <p:graphicFrame>
-        <p:nvGraphicFramePr>
-          <p:cNvPr id="3" name="Purchases chart" descr=""/>
-          <p:cNvGraphicFramePr/>
-          <p:nvPr/>
-        </p:nvGraphicFramePr>
-        <p:xfrm>
-          <a:off x="457200" y="960120"/>
-          <a:ext cx="4206240" cy="3429000"/>
-        </p:xfrm>
-        <a:graphic xmlns:a="http://schemas.openxmlformats.org/drawingml/2006/main">
-          <a:graphicData uri="http://schemas.openxmlformats.org/drawingml/2006/chart">
-            <c:chart xmlns:c="http://schemas.openxmlformats.org/drawingml/2006/chart" r:id="rId1"/>
-          </a:graphicData>
-        </a:graphic>
-      </p:graphicFrame>
-      <p:sp>
-        <p:nvSpPr>
-          <p:cNvPr id="4" name="Text 1"/>
-          <p:cNvSpPr txBox="1"/>
-          <p:nvPr/>
-        </p:nvSpPr>
-        <p:spPr>
-          <a:xfrm>
-            <a:off x="4937760" y="1005840"/>
-            <a:ext cx="3749040" cy="320040"/>
-          </a:xfrm>
-          <a:prstGeom prst="rect">
-            <a:avLst/>
-          </a:prstGeom>
-          <a:noFill/>
-          <a:ln/>
-        </p:spPr>
-        <p:txBody>
-          <a:bodyPr wrap="square" lIns="0" tIns="0" rIns="0" bIns="0" rtlCol="0" anchor="ctr"/>
-          <a:lstStyle/>
-          <a:p>
-            <a:pPr indent="0" marL="0">
-              <a:buNone/>
-            </a:pPr>
-            <a:r>
-              <a:rPr lang="en-US" sz="1500" b="1" dirty="0">
-                <a:solidFill>
-                  <a:schemeClr val="accent2"/>
-                </a:solidFill>
-                <a:latin typeface="Cambria" pitchFamily="34" charset="0"/>
-                <a:ea typeface="Cambria" pitchFamily="34" charset="-122"/>
-                <a:cs typeface="Cambria" pitchFamily="34" charset="-120"/>
-              </a:rPr>
-              <a:t>What's working</a:t>
-            </a:r>
-            <a:endParaRPr lang="en-US" sz="1500" dirty="0"/>
-          </a:p>
-        </p:txBody>
-      </p:sp>
-      <p:sp>
-        <p:nvSpPr>
-          <p:cNvPr id="5" name="Text 2"/>
-          <p:cNvSpPr txBox="1"/>
-          <p:nvPr/>
-        </p:nvSpPr>
-        <p:spPr>
-          <a:xfrm>
-            <a:off x="4937760" y="1371600"/>
-            <a:ext cx="3749040" cy="1152144"/>
-          </a:xfrm>
-          <a:prstGeom prst="rect">
-            <a:avLst/>
-          </a:prstGeom>
-          <a:noFill/>
-          <a:ln/>
-        </p:spPr>
-        <p:txBody>
-          <a:bodyPr wrap="square" lIns="0" tIns="0" rIns="0" bIns="0" rtlCol="0" anchor="t"/>
-          <a:lstStyle/>
-          <a:p>
-            <a:pPr marL="342900" indent="-342900">
-              <a:spcAft>
-                <a:spcPts val="400"/>
-              </a:spcAft>
-              <a:buSzPct val="100000"/>
-              <a:buChar char="•"/>
-            </a:pPr>
-            <a:r>
-              <a:rPr lang="en-US" sz="1200" dirty="0">
-                <a:solidFill>
-                  <a:schemeClr val="tx1"/>
-                </a:solidFill>
-              </a:rPr>
-              <a:t>Ayoba new customers: $26 per purchase, 1.6x return</a:t>
-            </a:r>
-            <a:endParaRPr lang="en-US" sz="1200" dirty="0"/>
-          </a:p>
-          <a:p>
-            <a:pPr marL="342900" indent="-342900">
-              <a:spcAft>
-                <a:spcPts val="400"/>
-              </a:spcAft>
-              <a:buSzPct val="100000"/>
-              <a:buChar char="•"/>
-            </a:pPr>
-            <a:r>
-              <a:rPr lang="en-US" sz="1200" dirty="0">
-                <a:solidFill>
-                  <a:schemeClr val="tx1"/>
-                </a:solidFill>
-              </a:rPr>
-              <a:t>Brooklyn dynamic retargeting: $26 per purchase, 2.9x return</a:t>
-            </a:r>
-            <a:endParaRPr lang="en-US" sz="1200" dirty="0"/>
-          </a:p>
-          <a:p>
-            <a:pPr marL="342900" indent="-342900">
-              <a:spcAft>
-                <a:spcPts val="400"/>
-              </a:spcAft>
-              <a:buSzPct val="100000"/>
-              <a:buChar char="•"/>
-            </a:pPr>
-            <a:r>
-              <a:rPr lang="en-US" sz="1200" dirty="0">
-                <a:solidFill>
-                  <a:schemeClr val="tx1"/>
-                </a:solidFill>
-              </a:rPr>
-              <a:t>Beg &amp; Barker dynamic retargeting: 3.1x return</a:t>
-            </a:r>
-            <a:endParaRPr lang="en-US" sz="1200" dirty="0"/>
-          </a:p>
-        </p:txBody>
-      </p:sp>
-      <p:sp>
-        <p:nvSpPr>
-          <p:cNvPr id="6" name="Text 3"/>
-          <p:cNvSpPr txBox="1"/>
-          <p:nvPr/>
-        </p:nvSpPr>
-        <p:spPr>
-          <a:xfrm>
-            <a:off x="4937760" y="2697480"/>
-            <a:ext cx="3749040" cy="320040"/>
-          </a:xfrm>
-          <a:prstGeom prst="rect">
-            <a:avLst/>
-          </a:prstGeom>
-          <a:noFill/>
-          <a:ln/>
-        </p:spPr>
-        <p:txBody>
-          <a:bodyPr wrap="square" lIns="0" tIns="0" rIns="0" bIns="0" rtlCol="0" anchor="ctr"/>
-          <a:lstStyle/>
-          <a:p>
-            <a:pPr indent="0" marL="0">
-              <a:buNone/>
-            </a:pPr>
-            <a:r>
-              <a:rPr lang="en-US" sz="1500" b="1" dirty="0">
-                <a:solidFill>
-                  <a:schemeClr val="accent1"/>
-                </a:solidFill>
-                <a:latin typeface="Cambria" pitchFamily="34" charset="0"/>
-                <a:ea typeface="Cambria" pitchFamily="34" charset="-122"/>
-                <a:cs typeface="Cambria" pitchFamily="34" charset="-120"/>
-              </a:rPr>
-              <a:t>What we're fixing</a:t>
-            </a:r>
-            <a:endParaRPr lang="en-US" sz="1500" dirty="0"/>
-          </a:p>
-        </p:txBody>
-      </p:sp>
-      <p:sp>
-        <p:nvSpPr>
-          <p:cNvPr id="7" name="Text 4"/>
-          <p:cNvSpPr txBox="1"/>
-          <p:nvPr/>
-        </p:nvSpPr>
-        <p:spPr>
-          <a:xfrm>
-            <a:off x="4937760" y="3063240"/>
-            <a:ext cx="3749040" cy="768096"/>
-          </a:xfrm>
-          <a:prstGeom prst="rect">
-            <a:avLst/>
-          </a:prstGeom>
-          <a:noFill/>
-          <a:ln/>
-        </p:spPr>
-        <p:txBody>
-          <a:bodyPr wrap="square" lIns="0" tIns="0" rIns="0" bIns="0" rtlCol="0" anchor="t"/>
-          <a:lstStyle/>
-          <a:p>
-            <a:pPr marL="342900" indent="-342900">
-              <a:spcAft>
-                <a:spcPts val="400"/>
-              </a:spcAft>
-              <a:buSzPct val="100000"/>
-              <a:buChar char="•"/>
-            </a:pPr>
-            <a:r>
-              <a:rPr lang="en-US" sz="1200" dirty="0">
-                <a:solidFill>
-                  <a:schemeClr val="tx1"/>
-                </a:solidFill>
-              </a:rPr>
-              <a:t>Brooklyn new customers: $170 per purchase → budget trimmed on Oct 13</a:t>
-            </a:r>
-            <a:endParaRPr lang="en-US" sz="1200" dirty="0"/>
-          </a:p>
-          <a:p>
-            <a:pPr marL="342900" indent="-342900">
-              <a:spcAft>
-                <a:spcPts val="400"/>
-              </a:spcAft>
-              <a:buSzPct val="100000"/>
-              <a:buChar char="•"/>
-            </a:pPr>
-            <a:r>
-              <a:rPr lang="en-US" sz="1200" dirty="0">
-                <a:solidFill>
-                  <a:schemeClr val="tx1"/>
-                </a:solidFill>
-              </a:rPr>
-              <a:t>New retargeting (since Oct 10) is still learning; budget raised for Ayoba and Beg &amp; Barker</a:t>
-            </a:r>
-            <a:endParaRPr lang="en-US" sz="1200" dirty="0"/>
-          </a:p>
-        </p:txBody>
-      </p:sp>
-      <p:sp>
-        <p:nvSpPr>
-          <p:cNvPr id="8" name="Text 5"/>
-          <p:cNvSpPr txBox="1"/>
-          <p:nvPr/>
-        </p:nvSpPr>
-        <p:spPr>
-          <a:xfrm>
-            <a:off x="457200" y="4434840"/>
-            <a:ext cx="8229600" cy="274320"/>
-          </a:xfrm>
-          <a:prstGeom prst="rect">
-            <a:avLst/>
-          </a:prstGeom>
-          <a:noFill/>
-          <a:ln/>
-        </p:spPr>
-        <p:txBody>
-          <a:bodyPr wrap="square" lIns="0" tIns="0" rIns="0" bIns="0" rtlCol="0" anchor="ctr"/>
-          <a:lstStyle/>
-          <a:p>
-            <a:pPr indent="0" marL="0">
-              <a:buNone/>
-            </a:pPr>
-            <a:r>
-              <a:rPr lang="en-US" sz="900" i="1" dirty="0">
-                <a:solidFill>
-                  <a:schemeClr val="accent4"/>
-                </a:solidFill>
-              </a:rPr>
-              <a:t>Source: Meta Ads Manager, platform-attributed purchases and return. Excludes Google Ads and total store sales (see dashboards).</a:t>
-            </a:r>
-            <a:endParaRPr lang="en-US" sz="900" dirty="0"/>
-          </a:p>
-        </p:txBody>
-      </p:sp>
-      <p:sp>
-        <p:nvSpPr>
-          <p:cNvPr id="25" name="Slide Number Placeholder 0"/>
-          <p:cNvSpPr>
-            <a:spLocks noGrp="1"/>
-          </p:cNvSpPr>
-          <p:nvPr>
-            <p:ph type="sldNum" sz="quarter" idx="4294967295"/>
-          </p:nvPr>
-        </p:nvSpPr>
-        <p:spPr>
-          <a:xfrm>
-            <a:off x="8321040" y="4800600"/>
-            <a:ext cx="365760" cy="228600"/>
-          </a:xfrm>
-          <a:prstGeom prst="rect">
-            <a:avLst/>
-          </a:prstGeom>
-          <a:extLst>
-            <a:ext uri="{C572A759-6A51-4108-AA02-DFA0A04FC94B}">
-              <ma14:wrappingTextBoxFlag xmlns:ma14="http://schemas.microsoft.com/office/mac/drawingml/2011/main" val="0"/>
-            </a:ext>
-          </a:extLst>
-        </p:spPr>
-        <p:txBody>
-          <a:bodyPr/>
-          <a:lstStyle>
-            <a:lvl1pPr>
-              <a:defRPr sz="900">
-                <a:solidFill>
-                  <a:schemeClr val="accent4"/>
-                </a:solidFill>
-              </a:defRPr>
-            </a:lvl1pPr>
-          </a:lstStyle>
-          <a:p>
-            <a:pPr algn="r"/>
-            <a:fld id="{F7021451-1387-4CA6-816F-3879F97B5CBC}" type="slidenum">
-              <a:rPr b="0" lang="en-US"/>
               <a:t>6</a:t>
             </a:fld>
             <a:endParaRPr lang="en-US"/>
@@ -8814,207 +9449,21 @@
                 <a:ea typeface="Cambria" pitchFamily="34" charset="-122"/>
                 <a:cs typeface="Cambria" pitchFamily="34" charset="-120"/>
               </a:rPr>
-              <a:t>Brooklyn: email and SMS are driving repeat sales</a:t>
+              <a:t>Meta: more volume, efficiency still being built</a:t>
             </a:r>
             <a:endParaRPr lang="en-US" sz="2600" dirty="0"/>
-          </a:p>
-        </p:txBody>
-      </p:sp>
-      <p:sp>
-        <p:nvSpPr>
-          <p:cNvPr id="3" name="Retention stat panel"/>
-          <p:cNvSpPr/>
-          <p:nvPr/>
-        </p:nvSpPr>
-        <p:spPr>
-          <a:xfrm>
-            <a:off x="457200" y="1005840"/>
-            <a:ext cx="3108960" cy="3291840"/>
-          </a:xfrm>
-          <a:prstGeom prst="roundRect">
-            <a:avLst>
-              <a:gd name="adj" fmla="val 2353"/>
-            </a:avLst>
-          </a:prstGeom>
-          <a:solidFill>
-            <a:schemeClr val="tx1"/>
-          </a:solidFill>
-          <a:ln/>
-        </p:spPr>
-      </p:sp>
-      <p:sp>
-        <p:nvSpPr>
-          <p:cNvPr id="4" name="Text 2"/>
-          <p:cNvSpPr txBox="1"/>
-          <p:nvPr/>
-        </p:nvSpPr>
-        <p:spPr>
-          <a:xfrm>
-            <a:off x="685800" y="1188720"/>
-            <a:ext cx="2651760" cy="685800"/>
-          </a:xfrm>
-          <a:prstGeom prst="rect">
-            <a:avLst/>
-          </a:prstGeom>
-          <a:noFill/>
-          <a:ln/>
-        </p:spPr>
-        <p:txBody>
-          <a:bodyPr wrap="square" lIns="0" tIns="0" rIns="0" bIns="0" rtlCol="0" anchor="ctr"/>
-          <a:lstStyle/>
-          <a:p>
-            <a:pPr indent="0" marL="0">
-              <a:buNone/>
-            </a:pPr>
-            <a:r>
-              <a:rPr lang="en-US" sz="4000" b="1" dirty="0">
-                <a:solidFill>
-                  <a:schemeClr val="bg1"/>
-                </a:solidFill>
-                <a:latin typeface="Cambria" pitchFamily="34" charset="0"/>
-                <a:ea typeface="Cambria" pitchFamily="34" charset="-122"/>
-                <a:cs typeface="Cambria" pitchFamily="34" charset="-120"/>
-              </a:rPr>
-              <a:t>$2,074</a:t>
-            </a:r>
-            <a:endParaRPr lang="en-US" sz="4000" dirty="0"/>
-          </a:p>
-        </p:txBody>
-      </p:sp>
-      <p:sp>
-        <p:nvSpPr>
-          <p:cNvPr id="5" name="Text 3"/>
-          <p:cNvSpPr txBox="1"/>
-          <p:nvPr/>
-        </p:nvSpPr>
-        <p:spPr>
-          <a:xfrm>
-            <a:off x="685800" y="1874520"/>
-            <a:ext cx="2651760" cy="457200"/>
-          </a:xfrm>
-          <a:prstGeom prst="rect">
-            <a:avLst/>
-          </a:prstGeom>
-          <a:noFill/>
-          <a:ln/>
-        </p:spPr>
-        <p:txBody>
-          <a:bodyPr wrap="square" lIns="0" tIns="0" rIns="0" bIns="0" rtlCol="0" anchor="ctr"/>
-          <a:lstStyle/>
-          <a:p>
-            <a:pPr indent="0" marL="0">
-              <a:buNone/>
-            </a:pPr>
-            <a:r>
-              <a:rPr lang="en-US" sz="1200" dirty="0">
-                <a:solidFill>
-                  <a:schemeClr val="accent6"/>
-                </a:solidFill>
-              </a:rPr>
-              <a:t>in email and SMS-attributed sales,</a:t>
-            </a:r>
-            <a:endParaRPr lang="en-US" sz="1200" dirty="0"/>
-          </a:p>
-          <a:p>
-            <a:pPr indent="0" marL="0">
-              <a:buNone/>
-            </a:pPr>
-            <a:r>
-              <a:rPr lang="en-US" sz="1200" dirty="0">
-                <a:solidFill>
-                  <a:schemeClr val="accent6"/>
-                </a:solidFill>
-              </a:rPr>
-              <a:t>Oct 1–14</a:t>
-            </a:r>
-            <a:endParaRPr lang="en-US" sz="1200" dirty="0"/>
-          </a:p>
-        </p:txBody>
-      </p:sp>
-      <p:sp>
-        <p:nvSpPr>
-          <p:cNvPr id="6" name="Text 4"/>
-          <p:cNvSpPr txBox="1"/>
-          <p:nvPr/>
-        </p:nvSpPr>
-        <p:spPr>
-          <a:xfrm>
-            <a:off x="685800" y="2468880"/>
-            <a:ext cx="2651760" cy="685800"/>
-          </a:xfrm>
-          <a:prstGeom prst="rect">
-            <a:avLst/>
-          </a:prstGeom>
-          <a:noFill/>
-          <a:ln/>
-        </p:spPr>
-        <p:txBody>
-          <a:bodyPr wrap="square" lIns="0" tIns="0" rIns="0" bIns="0" rtlCol="0" anchor="ctr"/>
-          <a:lstStyle/>
-          <a:p>
-            <a:pPr indent="0" marL="0">
-              <a:buNone/>
-            </a:pPr>
-            <a:r>
-              <a:rPr lang="en-US" sz="4000" b="1" dirty="0">
-                <a:solidFill>
-                  <a:schemeClr val="bg1"/>
-                </a:solidFill>
-                <a:latin typeface="Cambria" pitchFamily="34" charset="0"/>
-                <a:ea typeface="Cambria" pitchFamily="34" charset="-122"/>
-                <a:cs typeface="Cambria" pitchFamily="34" charset="-120"/>
-              </a:rPr>
-              <a:t>31</a:t>
-            </a:r>
-            <a:endParaRPr lang="en-US" sz="4000" dirty="0"/>
-          </a:p>
-        </p:txBody>
-      </p:sp>
-      <p:sp>
-        <p:nvSpPr>
-          <p:cNvPr id="7" name="Text 5"/>
-          <p:cNvSpPr txBox="1"/>
-          <p:nvPr/>
-        </p:nvSpPr>
-        <p:spPr>
-          <a:xfrm>
-            <a:off x="685800" y="3154680"/>
-            <a:ext cx="2651760" cy="457200"/>
-          </a:xfrm>
-          <a:prstGeom prst="rect">
-            <a:avLst/>
-          </a:prstGeom>
-          <a:noFill/>
-          <a:ln/>
-        </p:spPr>
-        <p:txBody>
-          <a:bodyPr wrap="square" lIns="0" tIns="0" rIns="0" bIns="0" rtlCol="0" anchor="ctr"/>
-          <a:lstStyle/>
-          <a:p>
-            <a:pPr indent="0" marL="0">
-              <a:buNone/>
-            </a:pPr>
-            <a:r>
-              <a:rPr lang="en-US" sz="1200" dirty="0">
-                <a:solidFill>
-                  <a:schemeClr val="accent6"/>
-                </a:solidFill>
-              </a:rPr>
-              <a:t>orders; 17 came in automatically through flows</a:t>
-            </a:r>
-            <a:endParaRPr lang="en-US" sz="1200" dirty="0"/>
           </a:p>
         </p:txBody>
       </p:sp>
       <p:graphicFrame>
         <p:nvGraphicFramePr>
-          <p:cNvPr id="8" name="Sales by program chart" descr=""/>
+          <p:cNvPr id="3" name="Purchases chart" descr=""/>
           <p:cNvGraphicFramePr/>
           <p:nvPr/>
         </p:nvGraphicFramePr>
         <p:xfrm>
-          <a:off x="3840480" y="960120"/>
-          <a:ext cx="4846320" cy="2743200"/>
+          <a:off x="457200" y="960120"/>
+          <a:ext cx="4206240" cy="3429000"/>
         </p:xfrm>
         <a:graphic xmlns:a="http://schemas.openxmlformats.org/drawingml/2006/main">
           <a:graphicData uri="http://schemas.openxmlformats.org/drawingml/2006/chart">
@@ -9024,14 +9473,53 @@
       </p:graphicFrame>
       <p:sp>
         <p:nvSpPr>
-          <p:cNvPr id="9" name="Text 6"/>
+          <p:cNvPr id="4" name="Text 1"/>
           <p:cNvSpPr txBox="1"/>
           <p:nvPr/>
         </p:nvSpPr>
         <p:spPr>
           <a:xfrm>
-            <a:off x="3931920" y="3749040"/>
-            <a:ext cx="4754880" cy="548640"/>
+            <a:off x="4937760" y="1005840"/>
+            <a:ext cx="3749040" cy="320040"/>
+          </a:xfrm>
+          <a:prstGeom prst="rect">
+            <a:avLst/>
+          </a:prstGeom>
+          <a:noFill/>
+          <a:ln/>
+        </p:spPr>
+        <p:txBody>
+          <a:bodyPr wrap="square" lIns="0" tIns="0" rIns="0" bIns="0" rtlCol="0" anchor="ctr"/>
+          <a:lstStyle/>
+          <a:p>
+            <a:pPr indent="0" marL="0">
+              <a:buNone/>
+            </a:pPr>
+            <a:r>
+              <a:rPr lang="en-US" sz="1500" b="1" dirty="0">
+                <a:solidFill>
+                  <a:schemeClr val="accent2"/>
+                </a:solidFill>
+                <a:latin typeface="Cambria" pitchFamily="34" charset="0"/>
+                <a:ea typeface="Cambria" pitchFamily="34" charset="-122"/>
+                <a:cs typeface="Cambria" pitchFamily="34" charset="-120"/>
+              </a:rPr>
+              <a:t>What's working</a:t>
+            </a:r>
+            <a:endParaRPr lang="en-US" sz="1500" dirty="0"/>
+          </a:p>
+        </p:txBody>
+      </p:sp>
+      <p:sp>
+        <p:nvSpPr>
+          <p:cNvPr id="5" name="Text 2"/>
+          <p:cNvSpPr txBox="1"/>
+          <p:nvPr/>
+        </p:nvSpPr>
+        <p:spPr>
+          <a:xfrm>
+            <a:off x="4937760" y="1371600"/>
+            <a:ext cx="3749040" cy="1152144"/>
           </a:xfrm>
           <a:prstGeom prst="rect">
             <a:avLst/>
@@ -9043,24 +9531,161 @@
           <a:bodyPr wrap="square" lIns="0" tIns="0" rIns="0" bIns="0" rtlCol="0" anchor="t"/>
           <a:lstStyle/>
           <a:p>
+            <a:pPr marL="342900" indent="-342900">
+              <a:spcAft>
+                <a:spcPts val="400"/>
+              </a:spcAft>
+              <a:buSzPct val="100000"/>
+              <a:buChar char="•"/>
+            </a:pPr>
+            <a:r>
+              <a:rPr lang="en-US" sz="1200" dirty="0">
+                <a:solidFill>
+                  <a:schemeClr val="tx1"/>
+                </a:solidFill>
+              </a:rPr>
+              <a:t>Ayoba new customers: $26 per purchase, 1.6x return</a:t>
+            </a:r>
+            <a:endParaRPr lang="en-US" sz="1200" dirty="0"/>
+          </a:p>
+          <a:p>
+            <a:pPr marL="342900" indent="-342900">
+              <a:spcAft>
+                <a:spcPts val="400"/>
+              </a:spcAft>
+              <a:buSzPct val="100000"/>
+              <a:buChar char="•"/>
+            </a:pPr>
+            <a:r>
+              <a:rPr lang="en-US" sz="1200" dirty="0">
+                <a:solidFill>
+                  <a:schemeClr val="tx1"/>
+                </a:solidFill>
+              </a:rPr>
+              <a:t>Brooklyn dynamic retargeting: $26 per purchase, 2.9x return</a:t>
+            </a:r>
+            <a:endParaRPr lang="en-US" sz="1200" dirty="0"/>
+          </a:p>
+          <a:p>
+            <a:pPr marL="342900" indent="-342900">
+              <a:spcAft>
+                <a:spcPts val="400"/>
+              </a:spcAft>
+              <a:buSzPct val="100000"/>
+              <a:buChar char="•"/>
+            </a:pPr>
+            <a:r>
+              <a:rPr lang="en-US" sz="1200" dirty="0">
+                <a:solidFill>
+                  <a:schemeClr val="tx1"/>
+                </a:solidFill>
+              </a:rPr>
+              <a:t>Beg &amp; Barker dynamic retargeting: 3.1x return</a:t>
+            </a:r>
+            <a:endParaRPr lang="en-US" sz="1200" dirty="0"/>
+          </a:p>
+        </p:txBody>
+      </p:sp>
+      <p:sp>
+        <p:nvSpPr>
+          <p:cNvPr id="6" name="Text 3"/>
+          <p:cNvSpPr txBox="1"/>
+          <p:nvPr/>
+        </p:nvSpPr>
+        <p:spPr>
+          <a:xfrm>
+            <a:off x="4937760" y="2697480"/>
+            <a:ext cx="3749040" cy="320040"/>
+          </a:xfrm>
+          <a:prstGeom prst="rect">
+            <a:avLst/>
+          </a:prstGeom>
+          <a:noFill/>
+          <a:ln/>
+        </p:spPr>
+        <p:txBody>
+          <a:bodyPr wrap="square" lIns="0" tIns="0" rIns="0" bIns="0" rtlCol="0" anchor="ctr"/>
+          <a:lstStyle/>
+          <a:p>
             <a:pPr indent="0" marL="0">
               <a:buNone/>
             </a:pPr>
             <a:r>
+              <a:rPr lang="en-US" sz="1500" b="1" dirty="0">
+                <a:solidFill>
+                  <a:schemeClr val="accent1"/>
+                </a:solidFill>
+                <a:latin typeface="Cambria" pitchFamily="34" charset="0"/>
+                <a:ea typeface="Cambria" pitchFamily="34" charset="-122"/>
+                <a:cs typeface="Cambria" pitchFamily="34" charset="-120"/>
+              </a:rPr>
+              <a:t>What we're fixing</a:t>
+            </a:r>
+            <a:endParaRPr lang="en-US" sz="1500" dirty="0"/>
+          </a:p>
+        </p:txBody>
+      </p:sp>
+      <p:sp>
+        <p:nvSpPr>
+          <p:cNvPr id="7" name="Text 4"/>
+          <p:cNvSpPr txBox="1"/>
+          <p:nvPr/>
+        </p:nvSpPr>
+        <p:spPr>
+          <a:xfrm>
+            <a:off x="4937760" y="3063240"/>
+            <a:ext cx="3749040" cy="768096"/>
+          </a:xfrm>
+          <a:prstGeom prst="rect">
+            <a:avLst/>
+          </a:prstGeom>
+          <a:noFill/>
+          <a:ln/>
+        </p:spPr>
+        <p:txBody>
+          <a:bodyPr wrap="square" lIns="0" tIns="0" rIns="0" bIns="0" rtlCol="0" anchor="t"/>
+          <a:lstStyle/>
+          <a:p>
+            <a:pPr marL="342900" indent="-342900">
+              <a:spcAft>
+                <a:spcPts val="400"/>
+              </a:spcAft>
+              <a:buSzPct val="100000"/>
+              <a:buChar char="•"/>
+            </a:pPr>
+            <a:r>
               <a:rPr lang="en-US" sz="1200" dirty="0">
                 <a:solidFill>
                   <a:schemeClr val="tx1"/>
                 </a:solidFill>
               </a:rPr>
-              <a:t>Game Day had a 60% open rate. The Subscribe &amp; Save and Second Order flows have been live since Oct 7.</a:t>
+              <a:t>Brooklyn new customers: $170 per purchase → budget trimmed on Oct 13</a:t>
             </a:r>
             <a:endParaRPr lang="en-US" sz="1200" dirty="0"/>
           </a:p>
-        </p:txBody>
-      </p:sp>
-      <p:sp>
-        <p:nvSpPr>
-          <p:cNvPr id="10" name="Text 7"/>
+          <a:p>
+            <a:pPr marL="342900" indent="-342900">
+              <a:spcAft>
+                <a:spcPts val="400"/>
+              </a:spcAft>
+              <a:buSzPct val="100000"/>
+              <a:buChar char="•"/>
+            </a:pPr>
+            <a:r>
+              <a:rPr lang="en-US" sz="1200" dirty="0">
+                <a:solidFill>
+                  <a:schemeClr val="tx1"/>
+                </a:solidFill>
+              </a:rPr>
+              <a:t>New retargeting (since Oct 10) is still learning; budget raised for Ayoba and Beg &amp; Barker</a:t>
+            </a:r>
+            <a:endParaRPr lang="en-US" sz="1200" dirty="0"/>
+          </a:p>
+        </p:txBody>
+      </p:sp>
+      <p:sp>
+        <p:nvSpPr>
+          <p:cNvPr id="8" name="Text 5"/>
           <p:cNvSpPr txBox="1"/>
           <p:nvPr/>
         </p:nvSpPr>
@@ -9088,7 +9713,7 @@
                   <a:schemeClr val="accent4"/>
                 </a:solidFill>
               </a:rPr>
-              <a:t>Source: Klaviyo (Brooklyn Biltong), platform-attributed orders.</a:t>
+              <a:t>Source: Meta Ads Manager, platform-attributed purchases and return. Excludes Google Ads and total store sales (see dashboards).</a:t>
             </a:r>
             <a:endParaRPr lang="en-US" sz="900" dirty="0"/>
           </a:p>
@@ -9199,7 +9824,7 @@
                 <a:ea typeface="Cambria" pitchFamily="34" charset="-122"/>
                 <a:cs typeface="Cambria" pitchFamily="34" charset="-120"/>
               </a:rPr>
-              <a:t>What we'll do this week</a:t>
+              <a:t>Brooklyn: email and SMS are driving repeat sales</a:t>
             </a:r>
             <a:endParaRPr lang="en-US" sz="2600" dirty="0"/>
           </a:p>
@@ -9207,56 +9832,36 @@
       </p:sp>
       <p:sp>
         <p:nvSpPr>
-          <p:cNvPr id="3" name="Plan card 1"/>
+          <p:cNvPr id="3" name="Retention stat panel"/>
           <p:cNvSpPr/>
           <p:nvPr/>
         </p:nvSpPr>
         <p:spPr>
           <a:xfrm>
             <a:off x="457200" y="1005840"/>
-            <a:ext cx="2651760" cy="2377440"/>
+            <a:ext cx="3108960" cy="3291840"/>
           </a:xfrm>
           <a:prstGeom prst="roundRect">
             <a:avLst>
-              <a:gd name="adj" fmla="val 3077"/>
+              <a:gd name="adj" fmla="val 2353"/>
             </a:avLst>
           </a:prstGeom>
           <a:solidFill>
-            <a:schemeClr val="bg2"/>
+            <a:schemeClr val="tx1"/>
           </a:solidFill>
           <a:ln/>
         </p:spPr>
       </p:sp>
       <p:sp>
         <p:nvSpPr>
-          <p:cNvPr id="4" name="Plan dot 1"/>
-          <p:cNvSpPr/>
-          <p:nvPr/>
-        </p:nvSpPr>
-        <p:spPr>
-          <a:xfrm>
-            <a:off x="640080" y="1188720"/>
-            <a:ext cx="274320" cy="274320"/>
-          </a:xfrm>
-          <a:prstGeom prst="ellipse">
-            <a:avLst/>
-          </a:prstGeom>
-          <a:solidFill>
-            <a:schemeClr val="accent1"/>
-          </a:solidFill>
-          <a:ln/>
-        </p:spPr>
-      </p:sp>
-      <p:sp>
-        <p:nvSpPr>
-          <p:cNvPr id="5" name="Text 3"/>
+          <p:cNvPr id="4" name="Text 2"/>
           <p:cNvSpPr txBox="1"/>
           <p:nvPr/>
         </p:nvSpPr>
         <p:spPr>
           <a:xfrm>
-            <a:off x="1005840" y="1143000"/>
-            <a:ext cx="1965960" cy="365760"/>
+            <a:off x="685800" y="1188720"/>
+            <a:ext cx="2651760" cy="685800"/>
           </a:xfrm>
           <a:prstGeom prst="rect">
             <a:avLst/>
@@ -9272,17 +9877,67 @@
               <a:buNone/>
             </a:pPr>
             <a:r>
-              <a:rPr lang="en-US" sz="1500" b="1" dirty="0">
-                <a:solidFill>
-                  <a:schemeClr val="tx1"/>
+              <a:rPr lang="en-US" sz="4000" b="1" dirty="0">
+                <a:solidFill>
+                  <a:schemeClr val="bg1"/>
                 </a:solidFill>
                 <a:latin typeface="Cambria" pitchFamily="34" charset="0"/>
                 <a:ea typeface="Cambria" pitchFamily="34" charset="-122"/>
                 <a:cs typeface="Cambria" pitchFamily="34" charset="-120"/>
               </a:rPr>
-              <a:t>Brooklyn Biltong</a:t>
-            </a:r>
-            <a:endParaRPr lang="en-US" sz="1500" dirty="0"/>
+              <a:t>$2,074</a:t>
+            </a:r>
+            <a:endParaRPr lang="en-US" sz="4000" dirty="0"/>
+          </a:p>
+        </p:txBody>
+      </p:sp>
+      <p:sp>
+        <p:nvSpPr>
+          <p:cNvPr id="5" name="Text 3"/>
+          <p:cNvSpPr txBox="1"/>
+          <p:nvPr/>
+        </p:nvSpPr>
+        <p:spPr>
+          <a:xfrm>
+            <a:off x="685800" y="1874520"/>
+            <a:ext cx="2651760" cy="457200"/>
+          </a:xfrm>
+          <a:prstGeom prst="rect">
+            <a:avLst/>
+          </a:prstGeom>
+          <a:noFill/>
+          <a:ln/>
+        </p:spPr>
+        <p:txBody>
+          <a:bodyPr wrap="square" lIns="0" tIns="0" rIns="0" bIns="0" rtlCol="0" anchor="ctr"/>
+          <a:lstStyle/>
+          <a:p>
+            <a:pPr indent="0" marL="0">
+              <a:buNone/>
+            </a:pPr>
+            <a:r>
+              <a:rPr lang="en-US" sz="1200" dirty="0">
+                <a:solidFill>
+                  <a:schemeClr val="accent6"/>
+                </a:solidFill>
+              </a:rPr>
+              <a:t>in email and SMS-attributed sales,</a:t>
+            </a:r>
+            <a:endParaRPr lang="en-US" sz="1200" dirty="0"/>
+          </a:p>
+          <a:p>
+            <a:pPr indent="0" marL="0">
+              <a:buNone/>
+            </a:pPr>
+            <a:r>
+              <a:rPr lang="en-US" sz="1200" dirty="0">
+                <a:solidFill>
+                  <a:schemeClr val="accent6"/>
+                </a:solidFill>
+              </a:rPr>
+              <a:t>Oct 1–14</a:t>
+            </a:r>
+            <a:endParaRPr lang="en-US" sz="1200" dirty="0"/>
           </a:p>
         </p:txBody>
       </p:sp>
@@ -9294,126 +9949,8 @@
         </p:nvSpPr>
         <p:spPr>
           <a:xfrm>
-            <a:off x="640080" y="1600200"/>
-            <a:ext cx="2331720" cy="1691640"/>
-          </a:xfrm>
-          <a:prstGeom prst="rect">
-            <a:avLst/>
-          </a:prstGeom>
-          <a:noFill/>
-          <a:ln/>
-        </p:spPr>
-        <p:txBody>
-          <a:bodyPr wrap="square" lIns="0" tIns="0" rIns="0" bIns="0" rtlCol="0" anchor="t"/>
-          <a:lstStyle/>
-          <a:p>
-            <a:pPr marL="342900" indent="-342900">
-              <a:spcAft>
-                <a:spcPts val="500"/>
-              </a:spcAft>
-              <a:buSzPct val="100000"/>
-              <a:buChar char="•"/>
-            </a:pPr>
-            <a:r>
-              <a:rPr lang="en-US" sz="1100" dirty="0">
-                <a:solidFill>
-                  <a:schemeClr val="tx1"/>
-                </a:solidFill>
-              </a:rPr>
-              <a:t>Fast Sale: VIP 20% and list 15% (Oct 15), reminder Oct 16, last call Oct 18</a:t>
-            </a:r>
-            <a:endParaRPr lang="en-US" sz="1100" dirty="0"/>
-          </a:p>
-          <a:p>
-            <a:pPr marL="342900" indent="-342900">
-              <a:spcAft>
-                <a:spcPts val="500"/>
-              </a:spcAft>
-              <a:buSzPct val="100000"/>
-              <a:buChar char="•"/>
-            </a:pPr>
-            <a:r>
-              <a:rPr lang="en-US" sz="1100" dirty="0">
-                <a:solidFill>
-                  <a:schemeClr val="tx1"/>
-                </a:solidFill>
-              </a:rPr>
-              <a:t>Scale dynamic retargeting and Smile; tune new-customer campaigns by cost per purchase</a:t>
-            </a:r>
-            <a:endParaRPr lang="en-US" sz="1100" dirty="0"/>
-          </a:p>
-          <a:p>
-            <a:pPr marL="342900" indent="-342900">
-              <a:spcAft>
-                <a:spcPts val="500"/>
-              </a:spcAft>
-              <a:buSzPct val="100000"/>
-              <a:buChar char="•"/>
-            </a:pPr>
-            <a:r>
-              <a:rPr lang="en-US" sz="1100" dirty="0">
-                <a:solidFill>
-                  <a:schemeClr val="tx1"/>
-                </a:solidFill>
-              </a:rPr>
-              <a:t>Restore email frequency and activate the Recurring → Subscription flow</a:t>
-            </a:r>
-            <a:endParaRPr lang="en-US" sz="1100" dirty="0"/>
-          </a:p>
-        </p:txBody>
-      </p:sp>
-      <p:sp>
-        <p:nvSpPr>
-          <p:cNvPr id="7" name="Plan card 2"/>
-          <p:cNvSpPr/>
-          <p:nvPr/>
-        </p:nvSpPr>
-        <p:spPr>
-          <a:xfrm>
-            <a:off x="3246120" y="1005840"/>
-            <a:ext cx="2651760" cy="2377440"/>
-          </a:xfrm>
-          <a:prstGeom prst="roundRect">
-            <a:avLst>
-              <a:gd name="adj" fmla="val 3077"/>
-            </a:avLst>
-          </a:prstGeom>
-          <a:solidFill>
-            <a:schemeClr val="bg2"/>
-          </a:solidFill>
-          <a:ln/>
-        </p:spPr>
-      </p:sp>
-      <p:sp>
-        <p:nvSpPr>
-          <p:cNvPr id="8" name="Plan dot 2"/>
-          <p:cNvSpPr/>
-          <p:nvPr/>
-        </p:nvSpPr>
-        <p:spPr>
-          <a:xfrm>
-            <a:off x="3429000" y="1188720"/>
-            <a:ext cx="274320" cy="274320"/>
-          </a:xfrm>
-          <a:prstGeom prst="ellipse">
-            <a:avLst/>
-          </a:prstGeom>
-          <a:solidFill>
-            <a:schemeClr val="tx2"/>
-          </a:solidFill>
-          <a:ln/>
-        </p:spPr>
-      </p:sp>
-      <p:sp>
-        <p:nvSpPr>
-          <p:cNvPr id="9" name="Text 7"/>
-          <p:cNvSpPr txBox="1"/>
-          <p:nvPr/>
-        </p:nvSpPr>
-        <p:spPr>
-          <a:xfrm>
-            <a:off x="3794760" y="1143000"/>
-            <a:ext cx="1965960" cy="365760"/>
+            <a:off x="685800" y="2468880"/>
+            <a:ext cx="2651760" cy="685800"/>
           </a:xfrm>
           <a:prstGeom prst="rect">
             <a:avLst/>
@@ -9429,30 +9966,82 @@
               <a:buNone/>
             </a:pPr>
             <a:r>
-              <a:rPr lang="en-US" sz="1500" b="1" dirty="0">
-                <a:solidFill>
-                  <a:schemeClr val="tx1"/>
+              <a:rPr lang="en-US" sz="4000" b="1" dirty="0">
+                <a:solidFill>
+                  <a:schemeClr val="bg1"/>
                 </a:solidFill>
                 <a:latin typeface="Cambria" pitchFamily="34" charset="0"/>
                 <a:ea typeface="Cambria" pitchFamily="34" charset="-122"/>
                 <a:cs typeface="Cambria" pitchFamily="34" charset="-120"/>
               </a:rPr>
-              <a:t>Ayoba Foods</a:t>
-            </a:r>
-            <a:endParaRPr lang="en-US" sz="1500" dirty="0"/>
-          </a:p>
-        </p:txBody>
-      </p:sp>
-      <p:sp>
-        <p:nvSpPr>
-          <p:cNvPr id="10" name="Text 8"/>
+              <a:t>31</a:t>
+            </a:r>
+            <a:endParaRPr lang="en-US" sz="4000" dirty="0"/>
+          </a:p>
+        </p:txBody>
+      </p:sp>
+      <p:sp>
+        <p:nvSpPr>
+          <p:cNvPr id="7" name="Text 5"/>
           <p:cNvSpPr txBox="1"/>
           <p:nvPr/>
         </p:nvSpPr>
         <p:spPr>
           <a:xfrm>
-            <a:off x="3429000" y="1600200"/>
-            <a:ext cx="2331720" cy="1691640"/>
+            <a:off x="685800" y="3154680"/>
+            <a:ext cx="2651760" cy="457200"/>
+          </a:xfrm>
+          <a:prstGeom prst="rect">
+            <a:avLst/>
+          </a:prstGeom>
+          <a:noFill/>
+          <a:ln/>
+        </p:spPr>
+        <p:txBody>
+          <a:bodyPr wrap="square" lIns="0" tIns="0" rIns="0" bIns="0" rtlCol="0" anchor="ctr"/>
+          <a:lstStyle/>
+          <a:p>
+            <a:pPr indent="0" marL="0">
+              <a:buNone/>
+            </a:pPr>
+            <a:r>
+              <a:rPr lang="en-US" sz="1200" dirty="0">
+                <a:solidFill>
+                  <a:schemeClr val="accent6"/>
+                </a:solidFill>
+              </a:rPr>
+              <a:t>orders; 17 came in automatically through flows</a:t>
+            </a:r>
+            <a:endParaRPr lang="en-US" sz="1200" dirty="0"/>
+          </a:p>
+        </p:txBody>
+      </p:sp>
+      <p:graphicFrame>
+        <p:nvGraphicFramePr>
+          <p:cNvPr id="8" name="Sales by program chart" descr=""/>
+          <p:cNvGraphicFramePr/>
+          <p:nvPr/>
+        </p:nvGraphicFramePr>
+        <p:xfrm>
+          <a:off x="3840480" y="960120"/>
+          <a:ext cx="4846320" cy="2743200"/>
+        </p:xfrm>
+        <a:graphic xmlns:a="http://schemas.openxmlformats.org/drawingml/2006/main">
+          <a:graphicData uri="http://schemas.openxmlformats.org/drawingml/2006/chart">
+            <c:chart xmlns:c="http://schemas.openxmlformats.org/drawingml/2006/chart" r:id="rId1"/>
+          </a:graphicData>
+        </a:graphic>
+      </p:graphicFrame>
+      <p:sp>
+        <p:nvSpPr>
+          <p:cNvPr id="9" name="Text 6"/>
+          <p:cNvSpPr txBox="1"/>
+          <p:nvPr/>
+        </p:nvSpPr>
+        <p:spPr>
+          <a:xfrm>
+            <a:off x="3931920" y="3749040"/>
+            <a:ext cx="4754880" cy="548640"/>
           </a:xfrm>
           <a:prstGeom prst="rect">
             <a:avLst/>
@@ -9464,113 +10053,31 @@
           <a:bodyPr wrap="square" lIns="0" tIns="0" rIns="0" bIns="0" rtlCol="0" anchor="t"/>
           <a:lstStyle/>
           <a:p>
-            <a:pPr marL="342900" indent="-342900">
-              <a:spcAft>
-                <a:spcPts val="500"/>
-              </a:spcAft>
-              <a:buSzPct val="100000"/>
-              <a:buChar char="•"/>
-            </a:pPr>
-            <a:r>
-              <a:rPr lang="en-US" sz="1100" dirty="0">
+            <a:pPr indent="0" marL="0">
+              <a:buNone/>
+            </a:pPr>
+            <a:r>
+              <a:rPr lang="en-US" sz="1200" dirty="0">
                 <a:solidFill>
                   <a:schemeClr val="tx1"/>
                 </a:solidFill>
               </a:rPr>
-              <a:t>Scale the new-customer campaign, the lowest cost per purchase in the portfolio</a:t>
-            </a:r>
-            <a:endParaRPr lang="en-US" sz="1100" dirty="0"/>
-          </a:p>
-          <a:p>
-            <a:pPr marL="342900" indent="-342900">
-              <a:spcAft>
-                <a:spcPts val="500"/>
-              </a:spcAft>
-              <a:buSzPct val="100000"/>
-              <a:buChar char="•"/>
-            </a:pPr>
-            <a:r>
-              <a:rPr lang="en-US" sz="1100" dirty="0">
-                <a:solidFill>
-                  <a:schemeClr val="tx1"/>
-                </a:solidFill>
-              </a:rPr>
-              <a:t>Activate the retention flows so they run automatically</a:t>
-            </a:r>
-            <a:endParaRPr lang="en-US" sz="1100" dirty="0"/>
-          </a:p>
-          <a:p>
-            <a:pPr marL="342900" indent="-342900">
-              <a:spcAft>
-                <a:spcPts val="500"/>
-              </a:spcAft>
-              <a:buSzPct val="100000"/>
-              <a:buChar char="•"/>
-            </a:pPr>
-            <a:r>
-              <a:rPr lang="en-US" sz="1100" dirty="0">
-                <a:solidFill>
-                  <a:schemeClr val="tx1"/>
-                </a:solidFill>
-              </a:rPr>
-              <a:t>Campaigns: Spicy Taco Night, Droëwors Oktoberfest and Cabin Weekend</a:t>
-            </a:r>
-            <a:endParaRPr lang="en-US" sz="1100" dirty="0"/>
-          </a:p>
-        </p:txBody>
-      </p:sp>
-      <p:sp>
-        <p:nvSpPr>
-          <p:cNvPr id="11" name="Plan card 3"/>
-          <p:cNvSpPr/>
-          <p:nvPr/>
-        </p:nvSpPr>
-        <p:spPr>
-          <a:xfrm>
-            <a:off x="6035040" y="1005840"/>
-            <a:ext cx="2651760" cy="2377440"/>
-          </a:xfrm>
-          <a:prstGeom prst="roundRect">
-            <a:avLst>
-              <a:gd name="adj" fmla="val 3077"/>
-            </a:avLst>
-          </a:prstGeom>
-          <a:solidFill>
-            <a:schemeClr val="bg2"/>
-          </a:solidFill>
-          <a:ln/>
-        </p:spPr>
-      </p:sp>
-      <p:sp>
-        <p:nvSpPr>
-          <p:cNvPr id="12" name="Plan dot 3"/>
-          <p:cNvSpPr/>
-          <p:nvPr/>
-        </p:nvSpPr>
-        <p:spPr>
-          <a:xfrm>
-            <a:off x="6217920" y="1188720"/>
-            <a:ext cx="274320" cy="274320"/>
-          </a:xfrm>
-          <a:prstGeom prst="ellipse">
-            <a:avLst/>
-          </a:prstGeom>
-          <a:solidFill>
-            <a:schemeClr val="tx2"/>
-          </a:solidFill>
-          <a:ln/>
-        </p:spPr>
-      </p:sp>
-      <p:sp>
-        <p:nvSpPr>
-          <p:cNvPr id="13" name="Text 11"/>
+              <a:t>Game Day had a 60% open rate. The Subscribe &amp; Save and Second Order flows have been live since Oct 7.</a:t>
+            </a:r>
+            <a:endParaRPr lang="en-US" sz="1200" dirty="0"/>
+          </a:p>
+        </p:txBody>
+      </p:sp>
+      <p:sp>
+        <p:nvSpPr>
+          <p:cNvPr id="10" name="Text 7"/>
           <p:cNvSpPr txBox="1"/>
           <p:nvPr/>
         </p:nvSpPr>
         <p:spPr>
           <a:xfrm>
-            <a:off x="6583680" y="1143000"/>
-            <a:ext cx="1965960" cy="365760"/>
+            <a:off x="457200" y="4434840"/>
+            <a:ext cx="8229600" cy="274320"/>
           </a:xfrm>
           <a:prstGeom prst="rect">
             <a:avLst/>
@@ -9586,190 +10093,14 @@
               <a:buNone/>
             </a:pPr>
             <a:r>
-              <a:rPr lang="en-US" sz="1500" b="1" dirty="0">
-                <a:solidFill>
-                  <a:schemeClr val="tx1"/>
-                </a:solidFill>
-                <a:latin typeface="Cambria" pitchFamily="34" charset="0"/>
-                <a:ea typeface="Cambria" pitchFamily="34" charset="-122"/>
-                <a:cs typeface="Cambria" pitchFamily="34" charset="-120"/>
+              <a:rPr lang="en-US" sz="900" i="1" dirty="0">
+                <a:solidFill>
+                  <a:schemeClr val="accent4"/>
+                </a:solidFill>
               </a:rPr>
-              <a:t>Beg &amp; Barker</a:t>
-            </a:r>
-            <a:endParaRPr lang="en-US" sz="1500" dirty="0"/>
-          </a:p>
-        </p:txBody>
-      </p:sp>
-      <p:sp>
-        <p:nvSpPr>
-          <p:cNvPr id="14" name="Text 12"/>
-          <p:cNvSpPr txBox="1"/>
-          <p:nvPr/>
-        </p:nvSpPr>
-        <p:spPr>
-          <a:xfrm>
-            <a:off x="6217920" y="1600200"/>
-            <a:ext cx="2331720" cy="1691640"/>
-          </a:xfrm>
-          <a:prstGeom prst="rect">
-            <a:avLst/>
-          </a:prstGeom>
-          <a:noFill/>
-          <a:ln/>
-        </p:spPr>
-        <p:txBody>
-          <a:bodyPr wrap="square" lIns="0" tIns="0" rIns="0" bIns="0" rtlCol="0" anchor="t"/>
-          <a:lstStyle/>
-          <a:p>
-            <a:pPr marL="342900" indent="-342900">
-              <a:spcAft>
-                <a:spcPts val="500"/>
-              </a:spcAft>
-              <a:buSzPct val="100000"/>
-              <a:buChar char="•"/>
-            </a:pPr>
-            <a:r>
-              <a:rPr lang="en-US" sz="1100" dirty="0">
-                <a:solidFill>
-                  <a:schemeClr val="tx1"/>
-                </a:solidFill>
-              </a:rPr>
-              <a:t>Scale the new-customer campaign as it gathers data</a:t>
-            </a:r>
-            <a:endParaRPr lang="en-US" sz="1100" dirty="0"/>
-          </a:p>
-          <a:p>
-            <a:pPr marL="342900" indent="-342900">
-              <a:spcAft>
-                <a:spcPts val="500"/>
-              </a:spcAft>
-              <a:buSzPct val="100000"/>
-              <a:buChar char="•"/>
-            </a:pPr>
-            <a:r>
-              <a:rPr lang="en-US" sz="1100" dirty="0">
-                <a:solidFill>
-                  <a:schemeClr val="tx1"/>
-                </a:solidFill>
-              </a:rPr>
-              <a:t>Launch the SMS Welcome Series and track the new BARK15 Welcome</a:t>
-            </a:r>
-            <a:endParaRPr lang="en-US" sz="1100" dirty="0"/>
-          </a:p>
-          <a:p>
-            <a:pPr marL="342900" indent="-342900">
-              <a:spcAft>
-                <a:spcPts val="500"/>
-              </a:spcAft>
-              <a:buSzPct val="100000"/>
-              <a:buChar char="•"/>
-            </a:pPr>
-            <a:r>
-              <a:rPr lang="en-US" sz="1100" dirty="0">
-                <a:solidFill>
-                  <a:schemeClr val="tx1"/>
-                </a:solidFill>
-              </a:rPr>
-              <a:t>Sustain dynamic retargeting at its new budget</a:t>
-            </a:r>
-            <a:endParaRPr lang="en-US" sz="1100" dirty="0"/>
-          </a:p>
-        </p:txBody>
-      </p:sp>
-      <p:sp>
-        <p:nvSpPr>
-          <p:cNvPr id="15" name="Follow-up panel"/>
-          <p:cNvSpPr/>
-          <p:nvPr/>
-        </p:nvSpPr>
-        <p:spPr>
-          <a:xfrm>
-            <a:off x="457200" y="3566160"/>
-            <a:ext cx="8229600" cy="960120"/>
-          </a:xfrm>
-          <a:prstGeom prst="roundRect">
-            <a:avLst>
-              <a:gd name="adj" fmla="val 7619"/>
-            </a:avLst>
-          </a:prstGeom>
-          <a:solidFill>
-            <a:schemeClr val="tx1"/>
-          </a:solidFill>
-          <a:ln/>
-        </p:spPr>
-      </p:sp>
-      <p:sp>
-        <p:nvSpPr>
-          <p:cNvPr id="16" name="Text 14"/>
-          <p:cNvSpPr txBox="1"/>
-          <p:nvPr/>
-        </p:nvSpPr>
-        <p:spPr>
-          <a:xfrm>
-            <a:off x="685800" y="3657600"/>
-            <a:ext cx="7772400" cy="320040"/>
-          </a:xfrm>
-          <a:prstGeom prst="rect">
-            <a:avLst/>
-          </a:prstGeom>
-          <a:noFill/>
-          <a:ln/>
-        </p:spPr>
-        <p:txBody>
-          <a:bodyPr wrap="square" lIns="0" tIns="0" rIns="0" bIns="0" rtlCol="0" anchor="ctr"/>
-          <a:lstStyle/>
-          <a:p>
-            <a:pPr indent="0" marL="0">
-              <a:buNone/>
-            </a:pPr>
-            <a:r>
-              <a:rPr lang="en-US" sz="1500" b="1" dirty="0">
-                <a:solidFill>
-                  <a:schemeClr val="bg1"/>
-                </a:solidFill>
-                <a:latin typeface="Cambria" pitchFamily="34" charset="0"/>
-                <a:ea typeface="Cambria" pitchFamily="34" charset="-122"/>
-                <a:cs typeface="Cambria" pitchFamily="34" charset="-120"/>
-              </a:rPr>
-              <a:t>Next follow-up: October 21</a:t>
-            </a:r>
-            <a:endParaRPr lang="en-US" sz="1500" dirty="0"/>
-          </a:p>
-        </p:txBody>
-      </p:sp>
-      <p:sp>
-        <p:nvSpPr>
-          <p:cNvPr id="17" name="Text 15"/>
-          <p:cNvSpPr txBox="1"/>
-          <p:nvPr/>
-        </p:nvSpPr>
-        <p:spPr>
-          <a:xfrm>
-            <a:off x="685800" y="3995928"/>
-            <a:ext cx="7772400" cy="457200"/>
-          </a:xfrm>
-          <a:prstGeom prst="rect">
-            <a:avLst/>
-          </a:prstGeom>
-          <a:noFill/>
-          <a:ln/>
-        </p:spPr>
-        <p:txBody>
-          <a:bodyPr wrap="square" lIns="0" tIns="0" rIns="0" bIns="0" rtlCol="0" anchor="t"/>
-          <a:lstStyle/>
-          <a:p>
-            <a:pPr indent="0" marL="0">
-              <a:buNone/>
-            </a:pPr>
-            <a:r>
-              <a:rPr lang="en-US" sz="1200" dirty="0">
-                <a:solidFill>
-                  <a:schemeClr val="accent6"/>
-                </a:solidFill>
-              </a:rPr>
-              <a:t>We'll share the results of Brooklyn's Fast Sale (sales, orders, and VIP vs. list response) and how the new-customer campaigns are progressing across all 3 brands.</a:t>
-            </a:r>
-            <a:endParaRPr lang="en-US" sz="1200" dirty="0"/>
+              <a:t>Source: Klaviyo (Brooklyn Biltong), platform-attributed orders.</a:t>
+            </a:r>
+            <a:endParaRPr lang="en-US" sz="900" dirty="0"/>
           </a:p>
         </p:txBody>
       </p:sp>
@@ -9813,6 +10144,685 @@
             <a:fld id="{F7021451-1387-4CA6-816F-3879F97B5CBC}" type="slidenum">
               <a:rPr b="0" lang="en-US"/>
               <a:t>8</a:t>
+            </a:fld>
+            <a:endParaRPr lang="en-US"/>
+          </a:p>
+        </p:txBody>
+      </p:sp>
+    </p:spTree>
+  </p:cSld>
+  <p:clrMapOvr>
+    <a:masterClrMapping/>
+  </p:clrMapOvr>
+</p:sld>
+</file>
+
+<file path=ppt/slides/slide9.xml><?xml version="1.0" encoding="utf-8"?>
+<p:sld xmlns:a="http://schemas.openxmlformats.org/drawingml/2006/main" xmlns:r="http://schemas.openxmlformats.org/officeDocument/2006/relationships" xmlns:p="http://schemas.openxmlformats.org/presentationml/2006/main">
+  <p:cSld name="Slide 9">
+    <p:spTree>
+      <p:nvGrpSpPr>
+        <p:cNvPr id="1" name=""/>
+        <p:cNvGrpSpPr/>
+        <p:nvPr/>
+      </p:nvGrpSpPr>
+      <p:grpSpPr>
+        <a:xfrm>
+          <a:off x="0" y="0"/>
+          <a:ext cx="0" cy="0"/>
+          <a:chOff x="0" y="0"/>
+          <a:chExt cx="0" cy="0"/>
+        </a:xfrm>
+      </p:grpSpPr>
+      <p:sp>
+        <p:nvSpPr>
+          <p:cNvPr id="2" name="Text 0"/>
+          <p:cNvSpPr/>
+          <p:nvPr>
+            <p:ph idx="100" type="title" hasCustomPrompt="1"/>
+          </p:nvPr>
+        </p:nvSpPr>
+        <p:spPr>
+          <a:xfrm>
+            <a:off x="457200" y="274320"/>
+            <a:ext cx="8229600" cy="594360"/>
+          </a:xfrm>
+          <a:prstGeom prst="rect">
+            <a:avLst/>
+          </a:prstGeom>
+          <a:noFill/>
+          <a:ln/>
+        </p:spPr>
+        <p:txBody>
+          <a:bodyPr wrap="square" lIns="0" tIns="0" rIns="0" bIns="0" rtlCol="0" anchor="ctr"/>
+          <a:lstStyle/>
+          <a:p>
+            <a:pPr algn="l" indent="0" marL="0">
+              <a:buNone/>
+            </a:pPr>
+            <a:r>
+              <a:rPr lang="en-US" sz="2600" b="1" dirty="0">
+                <a:solidFill>
+                  <a:schemeClr val="tx1"/>
+                </a:solidFill>
+                <a:latin typeface="Cambria" pitchFamily="34" charset="0"/>
+                <a:ea typeface="Cambria" pitchFamily="34" charset="-122"/>
+                <a:cs typeface="Cambria" pitchFamily="34" charset="-120"/>
+              </a:rPr>
+              <a:t>What we'll do this week</a:t>
+            </a:r>
+            <a:endParaRPr lang="en-US" sz="2600" dirty="0"/>
+          </a:p>
+        </p:txBody>
+      </p:sp>
+      <p:sp>
+        <p:nvSpPr>
+          <p:cNvPr id="3" name="Plan card 1"/>
+          <p:cNvSpPr/>
+          <p:nvPr/>
+        </p:nvSpPr>
+        <p:spPr>
+          <a:xfrm>
+            <a:off x="457200" y="1005840"/>
+            <a:ext cx="2651760" cy="2377440"/>
+          </a:xfrm>
+          <a:prstGeom prst="roundRect">
+            <a:avLst>
+              <a:gd name="adj" fmla="val 3077"/>
+            </a:avLst>
+          </a:prstGeom>
+          <a:solidFill>
+            <a:schemeClr val="bg2"/>
+          </a:solidFill>
+          <a:ln/>
+        </p:spPr>
+      </p:sp>
+      <p:sp>
+        <p:nvSpPr>
+          <p:cNvPr id="4" name="Plan dot 1"/>
+          <p:cNvSpPr/>
+          <p:nvPr/>
+        </p:nvSpPr>
+        <p:spPr>
+          <a:xfrm>
+            <a:off x="640080" y="1188720"/>
+            <a:ext cx="274320" cy="274320"/>
+          </a:xfrm>
+          <a:prstGeom prst="ellipse">
+            <a:avLst/>
+          </a:prstGeom>
+          <a:solidFill>
+            <a:schemeClr val="accent1"/>
+          </a:solidFill>
+          <a:ln/>
+        </p:spPr>
+      </p:sp>
+      <p:sp>
+        <p:nvSpPr>
+          <p:cNvPr id="5" name="Text 3"/>
+          <p:cNvSpPr txBox="1"/>
+          <p:nvPr/>
+        </p:nvSpPr>
+        <p:spPr>
+          <a:xfrm>
+            <a:off x="1005840" y="1143000"/>
+            <a:ext cx="1965960" cy="365760"/>
+          </a:xfrm>
+          <a:prstGeom prst="rect">
+            <a:avLst/>
+          </a:prstGeom>
+          <a:noFill/>
+          <a:ln/>
+        </p:spPr>
+        <p:txBody>
+          <a:bodyPr wrap="square" lIns="0" tIns="0" rIns="0" bIns="0" rtlCol="0" anchor="ctr"/>
+          <a:lstStyle/>
+          <a:p>
+            <a:pPr indent="0" marL="0">
+              <a:buNone/>
+            </a:pPr>
+            <a:r>
+              <a:rPr lang="en-US" sz="1500" b="1" dirty="0">
+                <a:solidFill>
+                  <a:schemeClr val="tx1"/>
+                </a:solidFill>
+                <a:latin typeface="Cambria" pitchFamily="34" charset="0"/>
+                <a:ea typeface="Cambria" pitchFamily="34" charset="-122"/>
+                <a:cs typeface="Cambria" pitchFamily="34" charset="-120"/>
+              </a:rPr>
+              <a:t>Brooklyn Biltong</a:t>
+            </a:r>
+            <a:endParaRPr lang="en-US" sz="1500" dirty="0"/>
+          </a:p>
+        </p:txBody>
+      </p:sp>
+      <p:sp>
+        <p:nvSpPr>
+          <p:cNvPr id="6" name="Text 4"/>
+          <p:cNvSpPr txBox="1"/>
+          <p:nvPr/>
+        </p:nvSpPr>
+        <p:spPr>
+          <a:xfrm>
+            <a:off x="640080" y="1600200"/>
+            <a:ext cx="2331720" cy="1691640"/>
+          </a:xfrm>
+          <a:prstGeom prst="rect">
+            <a:avLst/>
+          </a:prstGeom>
+          <a:noFill/>
+          <a:ln/>
+        </p:spPr>
+        <p:txBody>
+          <a:bodyPr wrap="square" lIns="0" tIns="0" rIns="0" bIns="0" rtlCol="0" anchor="t"/>
+          <a:lstStyle/>
+          <a:p>
+            <a:pPr marL="342900" indent="-342900">
+              <a:spcAft>
+                <a:spcPts val="500"/>
+              </a:spcAft>
+              <a:buSzPct val="100000"/>
+              <a:buChar char="•"/>
+            </a:pPr>
+            <a:r>
+              <a:rPr lang="en-US" sz="1100" dirty="0">
+                <a:solidFill>
+                  <a:schemeClr val="tx1"/>
+                </a:solidFill>
+              </a:rPr>
+              <a:t>Fast Sale: VIP 20% and list 15% (Oct 15), reminder Oct 16, last call Oct 18</a:t>
+            </a:r>
+            <a:endParaRPr lang="en-US" sz="1100" dirty="0"/>
+          </a:p>
+          <a:p>
+            <a:pPr marL="342900" indent="-342900">
+              <a:spcAft>
+                <a:spcPts val="500"/>
+              </a:spcAft>
+              <a:buSzPct val="100000"/>
+              <a:buChar char="•"/>
+            </a:pPr>
+            <a:r>
+              <a:rPr lang="en-US" sz="1100" dirty="0">
+                <a:solidFill>
+                  <a:schemeClr val="tx1"/>
+                </a:solidFill>
+              </a:rPr>
+              <a:t>Scale dynamic retargeting and Smile; tune new-customer campaigns by cost per purchase</a:t>
+            </a:r>
+            <a:endParaRPr lang="en-US" sz="1100" dirty="0"/>
+          </a:p>
+          <a:p>
+            <a:pPr marL="342900" indent="-342900">
+              <a:spcAft>
+                <a:spcPts val="500"/>
+              </a:spcAft>
+              <a:buSzPct val="100000"/>
+              <a:buChar char="•"/>
+            </a:pPr>
+            <a:r>
+              <a:rPr lang="en-US" sz="1100" dirty="0">
+                <a:solidFill>
+                  <a:schemeClr val="tx1"/>
+                </a:solidFill>
+              </a:rPr>
+              <a:t>Restore email frequency and activate the Recurring → Subscription flow</a:t>
+            </a:r>
+            <a:endParaRPr lang="en-US" sz="1100" dirty="0"/>
+          </a:p>
+        </p:txBody>
+      </p:sp>
+      <p:sp>
+        <p:nvSpPr>
+          <p:cNvPr id="7" name="Plan card 2"/>
+          <p:cNvSpPr/>
+          <p:nvPr/>
+        </p:nvSpPr>
+        <p:spPr>
+          <a:xfrm>
+            <a:off x="3246120" y="1005840"/>
+            <a:ext cx="2651760" cy="2377440"/>
+          </a:xfrm>
+          <a:prstGeom prst="roundRect">
+            <a:avLst>
+              <a:gd name="adj" fmla="val 3077"/>
+            </a:avLst>
+          </a:prstGeom>
+          <a:solidFill>
+            <a:schemeClr val="bg2"/>
+          </a:solidFill>
+          <a:ln/>
+        </p:spPr>
+      </p:sp>
+      <p:sp>
+        <p:nvSpPr>
+          <p:cNvPr id="8" name="Plan dot 2"/>
+          <p:cNvSpPr/>
+          <p:nvPr/>
+        </p:nvSpPr>
+        <p:spPr>
+          <a:xfrm>
+            <a:off x="3429000" y="1188720"/>
+            <a:ext cx="274320" cy="274320"/>
+          </a:xfrm>
+          <a:prstGeom prst="ellipse">
+            <a:avLst/>
+          </a:prstGeom>
+          <a:solidFill>
+            <a:schemeClr val="tx2"/>
+          </a:solidFill>
+          <a:ln/>
+        </p:spPr>
+      </p:sp>
+      <p:sp>
+        <p:nvSpPr>
+          <p:cNvPr id="9" name="Text 7"/>
+          <p:cNvSpPr txBox="1"/>
+          <p:nvPr/>
+        </p:nvSpPr>
+        <p:spPr>
+          <a:xfrm>
+            <a:off x="3794760" y="1143000"/>
+            <a:ext cx="1965960" cy="365760"/>
+          </a:xfrm>
+          <a:prstGeom prst="rect">
+            <a:avLst/>
+          </a:prstGeom>
+          <a:noFill/>
+          <a:ln/>
+        </p:spPr>
+        <p:txBody>
+          <a:bodyPr wrap="square" lIns="0" tIns="0" rIns="0" bIns="0" rtlCol="0" anchor="ctr"/>
+          <a:lstStyle/>
+          <a:p>
+            <a:pPr indent="0" marL="0">
+              <a:buNone/>
+            </a:pPr>
+            <a:r>
+              <a:rPr lang="en-US" sz="1500" b="1" dirty="0">
+                <a:solidFill>
+                  <a:schemeClr val="tx1"/>
+                </a:solidFill>
+                <a:latin typeface="Cambria" pitchFamily="34" charset="0"/>
+                <a:ea typeface="Cambria" pitchFamily="34" charset="-122"/>
+                <a:cs typeface="Cambria" pitchFamily="34" charset="-120"/>
+              </a:rPr>
+              <a:t>Ayoba Foods</a:t>
+            </a:r>
+            <a:endParaRPr lang="en-US" sz="1500" dirty="0"/>
+          </a:p>
+        </p:txBody>
+      </p:sp>
+      <p:sp>
+        <p:nvSpPr>
+          <p:cNvPr id="10" name="Text 8"/>
+          <p:cNvSpPr txBox="1"/>
+          <p:nvPr/>
+        </p:nvSpPr>
+        <p:spPr>
+          <a:xfrm>
+            <a:off x="3429000" y="1600200"/>
+            <a:ext cx="2331720" cy="1691640"/>
+          </a:xfrm>
+          <a:prstGeom prst="rect">
+            <a:avLst/>
+          </a:prstGeom>
+          <a:noFill/>
+          <a:ln/>
+        </p:spPr>
+        <p:txBody>
+          <a:bodyPr wrap="square" lIns="0" tIns="0" rIns="0" bIns="0" rtlCol="0" anchor="t"/>
+          <a:lstStyle/>
+          <a:p>
+            <a:pPr marL="342900" indent="-342900">
+              <a:spcAft>
+                <a:spcPts val="500"/>
+              </a:spcAft>
+              <a:buSzPct val="100000"/>
+              <a:buChar char="•"/>
+            </a:pPr>
+            <a:r>
+              <a:rPr lang="en-US" sz="1100" dirty="0">
+                <a:solidFill>
+                  <a:schemeClr val="tx1"/>
+                </a:solidFill>
+              </a:rPr>
+              <a:t>Scale the new-customer campaign, the lowest cost per purchase in the portfolio</a:t>
+            </a:r>
+            <a:endParaRPr lang="en-US" sz="1100" dirty="0"/>
+          </a:p>
+          <a:p>
+            <a:pPr marL="342900" indent="-342900">
+              <a:spcAft>
+                <a:spcPts val="500"/>
+              </a:spcAft>
+              <a:buSzPct val="100000"/>
+              <a:buChar char="•"/>
+            </a:pPr>
+            <a:r>
+              <a:rPr lang="en-US" sz="1100" dirty="0">
+                <a:solidFill>
+                  <a:schemeClr val="tx1"/>
+                </a:solidFill>
+              </a:rPr>
+              <a:t>Activate the retention flows so they run automatically</a:t>
+            </a:r>
+            <a:endParaRPr lang="en-US" sz="1100" dirty="0"/>
+          </a:p>
+          <a:p>
+            <a:pPr marL="342900" indent="-342900">
+              <a:spcAft>
+                <a:spcPts val="500"/>
+              </a:spcAft>
+              <a:buSzPct val="100000"/>
+              <a:buChar char="•"/>
+            </a:pPr>
+            <a:r>
+              <a:rPr lang="en-US" sz="1100" dirty="0">
+                <a:solidFill>
+                  <a:schemeClr val="tx1"/>
+                </a:solidFill>
+              </a:rPr>
+              <a:t>Campaigns: Spicy Taco Night, Droëwors Oktoberfest and Cabin Weekend</a:t>
+            </a:r>
+            <a:endParaRPr lang="en-US" sz="1100" dirty="0"/>
+          </a:p>
+        </p:txBody>
+      </p:sp>
+      <p:sp>
+        <p:nvSpPr>
+          <p:cNvPr id="11" name="Plan card 3"/>
+          <p:cNvSpPr/>
+          <p:nvPr/>
+        </p:nvSpPr>
+        <p:spPr>
+          <a:xfrm>
+            <a:off x="6035040" y="1005840"/>
+            <a:ext cx="2651760" cy="2377440"/>
+          </a:xfrm>
+          <a:prstGeom prst="roundRect">
+            <a:avLst>
+              <a:gd name="adj" fmla="val 3077"/>
+            </a:avLst>
+          </a:prstGeom>
+          <a:solidFill>
+            <a:schemeClr val="bg2"/>
+          </a:solidFill>
+          <a:ln/>
+        </p:spPr>
+      </p:sp>
+      <p:sp>
+        <p:nvSpPr>
+          <p:cNvPr id="12" name="Plan dot 3"/>
+          <p:cNvSpPr/>
+          <p:nvPr/>
+        </p:nvSpPr>
+        <p:spPr>
+          <a:xfrm>
+            <a:off x="6217920" y="1188720"/>
+            <a:ext cx="274320" cy="274320"/>
+          </a:xfrm>
+          <a:prstGeom prst="ellipse">
+            <a:avLst/>
+          </a:prstGeom>
+          <a:solidFill>
+            <a:schemeClr val="tx2"/>
+          </a:solidFill>
+          <a:ln/>
+        </p:spPr>
+      </p:sp>
+      <p:sp>
+        <p:nvSpPr>
+          <p:cNvPr id="13" name="Text 11"/>
+          <p:cNvSpPr txBox="1"/>
+          <p:nvPr/>
+        </p:nvSpPr>
+        <p:spPr>
+          <a:xfrm>
+            <a:off x="6583680" y="1143000"/>
+            <a:ext cx="1965960" cy="365760"/>
+          </a:xfrm>
+          <a:prstGeom prst="rect">
+            <a:avLst/>
+          </a:prstGeom>
+          <a:noFill/>
+          <a:ln/>
+        </p:spPr>
+        <p:txBody>
+          <a:bodyPr wrap="square" lIns="0" tIns="0" rIns="0" bIns="0" rtlCol="0" anchor="ctr"/>
+          <a:lstStyle/>
+          <a:p>
+            <a:pPr indent="0" marL="0">
+              <a:buNone/>
+            </a:pPr>
+            <a:r>
+              <a:rPr lang="en-US" sz="1500" b="1" dirty="0">
+                <a:solidFill>
+                  <a:schemeClr val="tx1"/>
+                </a:solidFill>
+                <a:latin typeface="Cambria" pitchFamily="34" charset="0"/>
+                <a:ea typeface="Cambria" pitchFamily="34" charset="-122"/>
+                <a:cs typeface="Cambria" pitchFamily="34" charset="-120"/>
+              </a:rPr>
+              <a:t>Beg &amp; Barker</a:t>
+            </a:r>
+            <a:endParaRPr lang="en-US" sz="1500" dirty="0"/>
+          </a:p>
+        </p:txBody>
+      </p:sp>
+      <p:sp>
+        <p:nvSpPr>
+          <p:cNvPr id="14" name="Text 12"/>
+          <p:cNvSpPr txBox="1"/>
+          <p:nvPr/>
+        </p:nvSpPr>
+        <p:spPr>
+          <a:xfrm>
+            <a:off x="6217920" y="1600200"/>
+            <a:ext cx="2331720" cy="1691640"/>
+          </a:xfrm>
+          <a:prstGeom prst="rect">
+            <a:avLst/>
+          </a:prstGeom>
+          <a:noFill/>
+          <a:ln/>
+        </p:spPr>
+        <p:txBody>
+          <a:bodyPr wrap="square" lIns="0" tIns="0" rIns="0" bIns="0" rtlCol="0" anchor="t"/>
+          <a:lstStyle/>
+          <a:p>
+            <a:pPr marL="342900" indent="-342900">
+              <a:spcAft>
+                <a:spcPts val="500"/>
+              </a:spcAft>
+              <a:buSzPct val="100000"/>
+              <a:buChar char="•"/>
+            </a:pPr>
+            <a:r>
+              <a:rPr lang="en-US" sz="1100" dirty="0">
+                <a:solidFill>
+                  <a:schemeClr val="tx1"/>
+                </a:solidFill>
+              </a:rPr>
+              <a:t>Scale the new-customer campaign as it gathers data</a:t>
+            </a:r>
+            <a:endParaRPr lang="en-US" sz="1100" dirty="0"/>
+          </a:p>
+          <a:p>
+            <a:pPr marL="342900" indent="-342900">
+              <a:spcAft>
+                <a:spcPts val="500"/>
+              </a:spcAft>
+              <a:buSzPct val="100000"/>
+              <a:buChar char="•"/>
+            </a:pPr>
+            <a:r>
+              <a:rPr lang="en-US" sz="1100" dirty="0">
+                <a:solidFill>
+                  <a:schemeClr val="tx1"/>
+                </a:solidFill>
+              </a:rPr>
+              <a:t>Launch the SMS Welcome Series and track the new BARK15 Welcome</a:t>
+            </a:r>
+            <a:endParaRPr lang="en-US" sz="1100" dirty="0"/>
+          </a:p>
+          <a:p>
+            <a:pPr marL="342900" indent="-342900">
+              <a:spcAft>
+                <a:spcPts val="500"/>
+              </a:spcAft>
+              <a:buSzPct val="100000"/>
+              <a:buChar char="•"/>
+            </a:pPr>
+            <a:r>
+              <a:rPr lang="en-US" sz="1100" dirty="0">
+                <a:solidFill>
+                  <a:schemeClr val="tx1"/>
+                </a:solidFill>
+              </a:rPr>
+              <a:t>Sustain dynamic retargeting at its new budget</a:t>
+            </a:r>
+            <a:endParaRPr lang="en-US" sz="1100" dirty="0"/>
+          </a:p>
+        </p:txBody>
+      </p:sp>
+      <p:sp>
+        <p:nvSpPr>
+          <p:cNvPr id="15" name="Follow-up panel"/>
+          <p:cNvSpPr/>
+          <p:nvPr/>
+        </p:nvSpPr>
+        <p:spPr>
+          <a:xfrm>
+            <a:off x="457200" y="3566160"/>
+            <a:ext cx="8229600" cy="960120"/>
+          </a:xfrm>
+          <a:prstGeom prst="roundRect">
+            <a:avLst>
+              <a:gd name="adj" fmla="val 7619"/>
+            </a:avLst>
+          </a:prstGeom>
+          <a:solidFill>
+            <a:schemeClr val="tx1"/>
+          </a:solidFill>
+          <a:ln/>
+        </p:spPr>
+      </p:sp>
+      <p:sp>
+        <p:nvSpPr>
+          <p:cNvPr id="16" name="Text 14"/>
+          <p:cNvSpPr txBox="1"/>
+          <p:nvPr/>
+        </p:nvSpPr>
+        <p:spPr>
+          <a:xfrm>
+            <a:off x="685800" y="3657600"/>
+            <a:ext cx="7772400" cy="320040"/>
+          </a:xfrm>
+          <a:prstGeom prst="rect">
+            <a:avLst/>
+          </a:prstGeom>
+          <a:noFill/>
+          <a:ln/>
+        </p:spPr>
+        <p:txBody>
+          <a:bodyPr wrap="square" lIns="0" tIns="0" rIns="0" bIns="0" rtlCol="0" anchor="ctr"/>
+          <a:lstStyle/>
+          <a:p>
+            <a:pPr indent="0" marL="0">
+              <a:buNone/>
+            </a:pPr>
+            <a:r>
+              <a:rPr lang="en-US" sz="1500" b="1" dirty="0">
+                <a:solidFill>
+                  <a:schemeClr val="bg1"/>
+                </a:solidFill>
+                <a:latin typeface="Cambria" pitchFamily="34" charset="0"/>
+                <a:ea typeface="Cambria" pitchFamily="34" charset="-122"/>
+                <a:cs typeface="Cambria" pitchFamily="34" charset="-120"/>
+              </a:rPr>
+              <a:t>Next follow-up: October 21</a:t>
+            </a:r>
+            <a:endParaRPr lang="en-US" sz="1500" dirty="0"/>
+          </a:p>
+        </p:txBody>
+      </p:sp>
+      <p:sp>
+        <p:nvSpPr>
+          <p:cNvPr id="17" name="Text 15"/>
+          <p:cNvSpPr txBox="1"/>
+          <p:nvPr/>
+        </p:nvSpPr>
+        <p:spPr>
+          <a:xfrm>
+            <a:off x="685800" y="3995928"/>
+            <a:ext cx="7772400" cy="457200"/>
+          </a:xfrm>
+          <a:prstGeom prst="rect">
+            <a:avLst/>
+          </a:prstGeom>
+          <a:noFill/>
+          <a:ln/>
+        </p:spPr>
+        <p:txBody>
+          <a:bodyPr wrap="square" lIns="0" tIns="0" rIns="0" bIns="0" rtlCol="0" anchor="t"/>
+          <a:lstStyle/>
+          <a:p>
+            <a:pPr indent="0" marL="0">
+              <a:buNone/>
+            </a:pPr>
+            <a:r>
+              <a:rPr lang="en-US" sz="1200" dirty="0">
+                <a:solidFill>
+                  <a:schemeClr val="accent6"/>
+                </a:solidFill>
+              </a:rPr>
+              <a:t>We'll share the results of Brooklyn's Fast Sale (sales, orders, and VIP vs. list response) and how the new-customer campaigns are progressing across all 3 brands.</a:t>
+            </a:r>
+            <a:endParaRPr lang="en-US" sz="1200" dirty="0"/>
+          </a:p>
+        </p:txBody>
+      </p:sp>
+      <p:sp>
+        <p:nvSpPr>
+          <p:cNvPr id="25" name="Slide Number Placeholder 0"/>
+          <p:cNvSpPr>
+            <a:spLocks noGrp="1"/>
+          </p:cNvSpPr>
+          <p:nvPr>
+            <p:ph type="sldNum" sz="quarter" idx="4294967295"/>
+          </p:nvPr>
+        </p:nvSpPr>
+        <p:spPr>
+          <a:xfrm>
+            <a:off x="8321040" y="4800600"/>
+            <a:ext cx="365760" cy="228600"/>
+          </a:xfrm>
+          <a:prstGeom prst="rect">
+            <a:avLst/>
+          </a:prstGeom>
+          <a:extLst>
+            <a:ext uri="{C572A759-6A51-4108-AA02-DFA0A04FC94B}">
+              <ma14:wrappingTextBoxFlag xmlns:ma14="http://schemas.microsoft.com/office/mac/drawingml/2011/main" val="0"/>
+            </a:ext>
+          </a:extLst>
+        </p:spPr>
+        <p:txBody>
+          <a:bodyPr/>
+          <a:lstStyle>
+            <a:lvl1pPr>
+              <a:defRPr sz="900">
+                <a:solidFill>
+                  <a:schemeClr val="accent4"/>
+                </a:solidFill>
+              </a:defRPr>
+            </a:lvl1pPr>
+          </a:lstStyle>
+          <a:p>
+            <a:pPr algn="r"/>
+            <a:fld id="{F7021451-1387-4CA6-816F-3879F97B5CBC}" type="slidenum">
+              <a:rPr b="0" lang="en-US"/>
+              <a:t>9</a:t>
             </a:fld>
             <a:endParaRPr lang="en-US"/>
           </a:p>

</xml_diff>